<commit_message>
refactor(lessons): 第 5-15 课教学口径整改轮
按备课规划 v2.2.0 与材料契约统一整改：逐页标题与正式 PPT
逐字同步（slides.md 为唯一标题源）；统一文献核验四态进入规则；
课堂最低产出收缩为可当堂完成的最小闭环并明确课后补齐项；
撤销重复次数等普适硬门槛，改为与方法类型相称的口径；虚构
教学工件增加屏显 + notes 双标；关键标签与字号按 v1.2.0 底线复核。

新增教学工件：第 9 课可复现实验样例（七字段 experiment-spec +
真实可运行脚本）、第 10 课受限 Agent 任务样例（diff/test/
failure-log）、第 13 课评估报告模板与示例、第 15 课同行评审与
修改计划模板，均对齐项目模板 v1.1.0。

Co-Authored-By: Claude Fable 5 <noreply@anthropic.com>
</commit_message>
<xml_diff>
--- a/lessons/lesson-05/slides.pptx
+++ b/lessons/lesson-05/slides.pptx
@@ -2,31 +2,31 @@
 <file path=ppt/presentation.xml><?xml version="1.0" encoding="utf-8"?>
 <p:presentation xmlns:p="http://schemas.openxmlformats.org/presentationml/2006/main">
   <p:sldMasterIdLst>
-    <p:sldMasterId xmlns:r="http://schemas.openxmlformats.org/officeDocument/2006/relationships" id="2147483648" r:id="Rb885762a504a429b"/>
+    <p:sldMasterId xmlns:r="http://schemas.openxmlformats.org/officeDocument/2006/relationships" id="2147483648" r:id="Rf92e1d6fc2c6492a"/>
   </p:sldMasterIdLst>
   <p:notesMasterIdLst>
-    <p:notesMasterId xmlns:r="http://schemas.openxmlformats.org/officeDocument/2006/relationships" r:id="Re2c72e616e74446c"/>
+    <p:notesMasterId xmlns:r="http://schemas.openxmlformats.org/officeDocument/2006/relationships" r:id="Rc5595d62dc884232"/>
   </p:notesMasterIdLst>
   <p:sldIdLst>
-    <p:sldId xmlns:r="http://schemas.openxmlformats.org/officeDocument/2006/relationships" id="256" r:id="R71bfbab9641f4f69"/>
-    <p:sldId xmlns:r="http://schemas.openxmlformats.org/officeDocument/2006/relationships" id="257" r:id="R656320ff4f874fbc"/>
-    <p:sldId xmlns:r="http://schemas.openxmlformats.org/officeDocument/2006/relationships" id="258" r:id="R2810b9748e5c4af3"/>
-    <p:sldId xmlns:r="http://schemas.openxmlformats.org/officeDocument/2006/relationships" id="259" r:id="Rf99dd2a2edef4c1a"/>
-    <p:sldId xmlns:r="http://schemas.openxmlformats.org/officeDocument/2006/relationships" id="260" r:id="R68afd8c278b94ac3"/>
-    <p:sldId xmlns:r="http://schemas.openxmlformats.org/officeDocument/2006/relationships" id="261" r:id="R8921d590479b4659"/>
-    <p:sldId xmlns:r="http://schemas.openxmlformats.org/officeDocument/2006/relationships" id="262" r:id="R620db5d587484ec9"/>
-    <p:sldId xmlns:r="http://schemas.openxmlformats.org/officeDocument/2006/relationships" id="263" r:id="R29401d6d98c94abb"/>
-    <p:sldId xmlns:r="http://schemas.openxmlformats.org/officeDocument/2006/relationships" id="264" r:id="Rd766b2c8398e449f"/>
-    <p:sldId xmlns:r="http://schemas.openxmlformats.org/officeDocument/2006/relationships" id="265" r:id="R5e2f339da3f646e1"/>
-    <p:sldId xmlns:r="http://schemas.openxmlformats.org/officeDocument/2006/relationships" id="266" r:id="R540b1667d5924e7b"/>
-    <p:sldId xmlns:r="http://schemas.openxmlformats.org/officeDocument/2006/relationships" id="267" r:id="R96535a05f0e44fc1"/>
-    <p:sldId xmlns:r="http://schemas.openxmlformats.org/officeDocument/2006/relationships" id="268" r:id="R5a44236eab0f4ab8"/>
-    <p:sldId xmlns:r="http://schemas.openxmlformats.org/officeDocument/2006/relationships" id="269" r:id="Rb1ba1fcb59824a0f"/>
-    <p:sldId xmlns:r="http://schemas.openxmlformats.org/officeDocument/2006/relationships" id="270" r:id="R379afed4ca324fa1"/>
-    <p:sldId xmlns:r="http://schemas.openxmlformats.org/officeDocument/2006/relationships" id="271" r:id="R6179420b72f44cc9"/>
-    <p:sldId xmlns:r="http://schemas.openxmlformats.org/officeDocument/2006/relationships" id="272" r:id="R10220e0ca0584f02"/>
-    <p:sldId xmlns:r="http://schemas.openxmlformats.org/officeDocument/2006/relationships" id="273" r:id="R024330b6a85645c3"/>
-    <p:sldId xmlns:r="http://schemas.openxmlformats.org/officeDocument/2006/relationships" id="274" r:id="R7d8add2737644311"/>
+    <p:sldId xmlns:r="http://schemas.openxmlformats.org/officeDocument/2006/relationships" id="256" r:id="Rb1880e4e5f5a4fc2"/>
+    <p:sldId xmlns:r="http://schemas.openxmlformats.org/officeDocument/2006/relationships" id="257" r:id="R213b16cf0ba24c9f"/>
+    <p:sldId xmlns:r="http://schemas.openxmlformats.org/officeDocument/2006/relationships" id="258" r:id="Rf909f7fbb0c94fb8"/>
+    <p:sldId xmlns:r="http://schemas.openxmlformats.org/officeDocument/2006/relationships" id="259" r:id="R768a01bcb50c4cd3"/>
+    <p:sldId xmlns:r="http://schemas.openxmlformats.org/officeDocument/2006/relationships" id="260" r:id="R81c5c1e739e04c08"/>
+    <p:sldId xmlns:r="http://schemas.openxmlformats.org/officeDocument/2006/relationships" id="261" r:id="R8a57a1cbc2904413"/>
+    <p:sldId xmlns:r="http://schemas.openxmlformats.org/officeDocument/2006/relationships" id="262" r:id="Raeda30773a0f4a04"/>
+    <p:sldId xmlns:r="http://schemas.openxmlformats.org/officeDocument/2006/relationships" id="263" r:id="Ra0d2dbbf09a44a4e"/>
+    <p:sldId xmlns:r="http://schemas.openxmlformats.org/officeDocument/2006/relationships" id="264" r:id="Rdd5844a1684b4e0f"/>
+    <p:sldId xmlns:r="http://schemas.openxmlformats.org/officeDocument/2006/relationships" id="265" r:id="R0f0370f68030450d"/>
+    <p:sldId xmlns:r="http://schemas.openxmlformats.org/officeDocument/2006/relationships" id="266" r:id="Re59ee59b436c4f43"/>
+    <p:sldId xmlns:r="http://schemas.openxmlformats.org/officeDocument/2006/relationships" id="267" r:id="R09c5a6cd779a4af0"/>
+    <p:sldId xmlns:r="http://schemas.openxmlformats.org/officeDocument/2006/relationships" id="268" r:id="R367c496528134481"/>
+    <p:sldId xmlns:r="http://schemas.openxmlformats.org/officeDocument/2006/relationships" id="269" r:id="R8cb5566faff64f1c"/>
+    <p:sldId xmlns:r="http://schemas.openxmlformats.org/officeDocument/2006/relationships" id="270" r:id="R4fd80b6c3b13457e"/>
+    <p:sldId xmlns:r="http://schemas.openxmlformats.org/officeDocument/2006/relationships" id="271" r:id="R273dfdc6e4404e6b"/>
+    <p:sldId xmlns:r="http://schemas.openxmlformats.org/officeDocument/2006/relationships" id="272" r:id="Ra59b966c93ad4ab7"/>
+    <p:sldId xmlns:r="http://schemas.openxmlformats.org/officeDocument/2006/relationships" id="273" r:id="R58fe9c2b89164c3a"/>
+    <p:sldId xmlns:r="http://schemas.openxmlformats.org/officeDocument/2006/relationships" id="274" r:id="R0e99f54c6aa449be"/>
   </p:sldIdLst>
   <p:sldSz cx="12192000" cy="6858000"/>
   <p:notesSz cx="6858000" cy="9144000"/>
@@ -421,17 +421,17 @@
           </a:p>
           <a:p xmlns:a="http://schemas.openxmlformats.org/drawingml/2006/main">
             <a:r>
-              <a:t>- /Users/bright/Projects/courses/graduate/course/syllabus.md</a:t>
-            </a:r>
-          </a:p>
-          <a:p xmlns:a="http://schemas.openxmlformats.org/drawingml/2006/main">
-            <a:r>
-              <a:t>- /Users/bright/Projects/courses/graduate/lessons/备课规划.md</a:t>
-            </a:r>
-          </a:p>
-          <a:p xmlns:a="http://schemas.openxmlformats.org/drawingml/2006/main">
-            <a:r>
-              <a:t>- /Users/bright/Projects/courses/graduate/lessons/lesson-05/slides.md</a:t>
+              <a:t>- course/syllabus.md</a:t>
+            </a:r>
+          </a:p>
+          <a:p xmlns:a="http://schemas.openxmlformats.org/drawingml/2006/main">
+            <a:r>
+              <a:t>- lessons/备课规划.md</a:t>
+            </a:r>
+          </a:p>
+          <a:p xmlns:a="http://schemas.openxmlformats.org/drawingml/2006/main">
+            <a:r>
+              <a:t>- lessons/lesson-05/slides.md</a:t>
             </a:r>
           </a:p>
           <a:p xmlns:a="http://schemas.openxmlformats.org/drawingml/2006/main">
@@ -521,7 +521,7 @@
           </a:p>
           <a:p xmlns:a="http://schemas.openxmlformats.org/drawingml/2006/main">
             <a:r>
-              <a:t>- /Users/bright/Projects/courses/graduate/lessons/lesson-05/handout.md</a:t>
+              <a:t>- lessons/lesson-05/handout.md</a:t>
             </a:r>
           </a:p>
           <a:p xmlns:a="http://schemas.openxmlformats.org/drawingml/2006/main">
@@ -611,17 +611,17 @@
           </a:p>
           <a:p xmlns:a="http://schemas.openxmlformats.org/drawingml/2006/main">
             <a:r>
-              <a:t>- /Users/bright/Projects/courses/graduate/AGENTS.md</a:t>
-            </a:r>
-          </a:p>
-          <a:p xmlns:a="http://schemas.openxmlformats.org/drawingml/2006/main">
-            <a:r>
-              <a:t>- /Users/bright/Projects/courses/graduate/lessons/lesson-03/handout.md</a:t>
-            </a:r>
-          </a:p>
-          <a:p xmlns:a="http://schemas.openxmlformats.org/drawingml/2006/main">
-            <a:r>
-              <a:t>- /Users/bright/Projects/courses/graduate/lessons/lesson-05/handout.md</a:t>
+              <a:t>- AGENTS.md</a:t>
+            </a:r>
+          </a:p>
+          <a:p xmlns:a="http://schemas.openxmlformats.org/drawingml/2006/main">
+            <a:r>
+              <a:t>- lessons/lesson-03/handout.md</a:t>
+            </a:r>
+          </a:p>
+          <a:p xmlns:a="http://schemas.openxmlformats.org/drawingml/2006/main">
+            <a:r>
+              <a:t>- lessons/lesson-05/handout.md</a:t>
             </a:r>
           </a:p>
           <a:p xmlns:a="http://schemas.openxmlformats.org/drawingml/2006/main">
@@ -711,12 +711,12 @@
           </a:p>
           <a:p xmlns:a="http://schemas.openxmlformats.org/drawingml/2006/main">
             <a:r>
-              <a:t>- /Users/bright/Projects/courses/graduate/lessons/lesson-05/slides.md</a:t>
-            </a:r>
-          </a:p>
-          <a:p xmlns:a="http://schemas.openxmlformats.org/drawingml/2006/main">
-            <a:r>
-              <a:t>- /Users/bright/Projects/courses/graduate/lessons/lesson-05/handout.md</a:t>
+              <a:t>- lessons/lesson-05/slides.md</a:t>
+            </a:r>
+          </a:p>
+          <a:p xmlns:a="http://schemas.openxmlformats.org/drawingml/2006/main">
+            <a:r>
+              <a:t>- lessons/lesson-05/handout.md</a:t>
             </a:r>
           </a:p>
           <a:p xmlns:a="http://schemas.openxmlformats.org/drawingml/2006/main">
@@ -806,12 +806,12 @@
           </a:p>
           <a:p xmlns:a="http://schemas.openxmlformats.org/drawingml/2006/main">
             <a:r>
-              <a:t>- /Users/bright/Projects/courses/graduate/course/assignments.md</a:t>
-            </a:r>
-          </a:p>
-          <a:p xmlns:a="http://schemas.openxmlformats.org/drawingml/2006/main">
-            <a:r>
-              <a:t>- /Users/bright/Projects/courses/graduate/lessons/lesson-05/handout.md</a:t>
+              <a:t>- course/assignments.md</a:t>
+            </a:r>
+          </a:p>
+          <a:p xmlns:a="http://schemas.openxmlformats.org/drawingml/2006/main">
+            <a:r>
+              <a:t>- lessons/lesson-05/handout.md</a:t>
             </a:r>
           </a:p>
           <a:p xmlns:a="http://schemas.openxmlformats.org/drawingml/2006/main">
@@ -901,12 +901,12 @@
           </a:p>
           <a:p xmlns:a="http://schemas.openxmlformats.org/drawingml/2006/main">
             <a:r>
-              <a:t>- /Users/bright/Projects/courses/graduate/lessons/lesson-05/handout.md</a:t>
-            </a:r>
-          </a:p>
-          <a:p xmlns:a="http://schemas.openxmlformats.org/drawingml/2006/main">
-            <a:r>
-              <a:t>- /Users/bright/Projects/courses/graduate/AGENTS.md</a:t>
+              <a:t>- lessons/lesson-05/handout.md</a:t>
+            </a:r>
+          </a:p>
+          <a:p xmlns:a="http://schemas.openxmlformats.org/drawingml/2006/main">
+            <a:r>
+              <a:t>- AGENTS.md</a:t>
             </a:r>
           </a:p>
           <a:p xmlns:a="http://schemas.openxmlformats.org/drawingml/2006/main">
@@ -996,12 +996,12 @@
           </a:p>
           <a:p xmlns:a="http://schemas.openxmlformats.org/drawingml/2006/main">
             <a:r>
-              <a:t>- /Users/bright/Projects/courses/graduate/lessons/lesson-02/handout.md</a:t>
-            </a:r>
-          </a:p>
-          <a:p xmlns:a="http://schemas.openxmlformats.org/drawingml/2006/main">
-            <a:r>
-              <a:t>- /Users/bright/Projects/courses/graduate/lessons/lesson-05/teaching-plan.md</a:t>
+              <a:t>- lessons/lesson-02/handout.md</a:t>
+            </a:r>
+          </a:p>
+          <a:p xmlns:a="http://schemas.openxmlformats.org/drawingml/2006/main">
+            <a:r>
+              <a:t>- lessons/lesson-05/teaching-plan.md</a:t>
             </a:r>
           </a:p>
           <a:p xmlns:a="http://schemas.openxmlformats.org/drawingml/2006/main">
@@ -1091,12 +1091,12 @@
           </a:p>
           <a:p xmlns:a="http://schemas.openxmlformats.org/drawingml/2006/main">
             <a:r>
-              <a:t>- /Users/bright/Projects/courses/graduate/course/starter-template.md</a:t>
-            </a:r>
-          </a:p>
-          <a:p xmlns:a="http://schemas.openxmlformats.org/drawingml/2006/main">
-            <a:r>
-              <a:t>- /Users/bright/Projects/courses/graduate/lessons/lesson-05/slides.md</a:t>
+              <a:t>- course/starter-template.md</a:t>
+            </a:r>
+          </a:p>
+          <a:p xmlns:a="http://schemas.openxmlformats.org/drawingml/2006/main">
+            <a:r>
+              <a:t>- lessons/lesson-05/slides.md</a:t>
             </a:r>
           </a:p>
           <a:p xmlns:a="http://schemas.openxmlformats.org/drawingml/2006/main">
@@ -1186,12 +1186,12 @@
           </a:p>
           <a:p xmlns:a="http://schemas.openxmlformats.org/drawingml/2006/main">
             <a:r>
-              <a:t>- /Users/bright/Projects/courses/graduate/lessons/lesson-05/handout.md</a:t>
-            </a:r>
-          </a:p>
-          <a:p xmlns:a="http://schemas.openxmlformats.org/drawingml/2006/main">
-            <a:r>
-              <a:t>- /Users/bright/Projects/courses/graduate/course/starter-template.md</a:t>
+              <a:t>- lessons/lesson-05/handout.md</a:t>
+            </a:r>
+          </a:p>
+          <a:p xmlns:a="http://schemas.openxmlformats.org/drawingml/2006/main">
+            <a:r>
+              <a:t>- course/starter-template.md</a:t>
             </a:r>
           </a:p>
           <a:p xmlns:a="http://schemas.openxmlformats.org/drawingml/2006/main">
@@ -1281,12 +1281,12 @@
           </a:p>
           <a:p xmlns:a="http://schemas.openxmlformats.org/drawingml/2006/main">
             <a:r>
-              <a:t>- /Users/bright/Projects/courses/graduate/course/assignments.md</a:t>
-            </a:r>
-          </a:p>
-          <a:p xmlns:a="http://schemas.openxmlformats.org/drawingml/2006/main">
-            <a:r>
-              <a:t>- /Users/bright/Projects/courses/graduate/lessons/lesson-05/teaching-plan.md</a:t>
+              <a:t>- course/assignments.md</a:t>
+            </a:r>
+          </a:p>
+          <a:p xmlns:a="http://schemas.openxmlformats.org/drawingml/2006/main">
+            <a:r>
+              <a:t>- lessons/lesson-05/teaching-plan.md</a:t>
             </a:r>
           </a:p>
           <a:p xmlns:a="http://schemas.openxmlformats.org/drawingml/2006/main">
@@ -1376,22 +1376,22 @@
           </a:p>
           <a:p xmlns:a="http://schemas.openxmlformats.org/drawingml/2006/main">
             <a:r>
-              <a:t>- /Users/bright/Projects/courses/graduate/course/syllabus.md</a:t>
-            </a:r>
-          </a:p>
-          <a:p xmlns:a="http://schemas.openxmlformats.org/drawingml/2006/main">
-            <a:r>
-              <a:t>- /Users/bright/Projects/courses/graduate/course/assignments.md</a:t>
-            </a:r>
-          </a:p>
-          <a:p xmlns:a="http://schemas.openxmlformats.org/drawingml/2006/main">
-            <a:r>
-              <a:t>- /Users/bright/Projects/courses/graduate/course/reading-list.md</a:t>
-            </a:r>
-          </a:p>
-          <a:p xmlns:a="http://schemas.openxmlformats.org/drawingml/2006/main">
-            <a:r>
-              <a:t>- /Users/bright/Projects/courses/graduate/lessons/lesson-05/slides.md</a:t>
+              <a:t>- course/syllabus.md</a:t>
+            </a:r>
+          </a:p>
+          <a:p xmlns:a="http://schemas.openxmlformats.org/drawingml/2006/main">
+            <a:r>
+              <a:t>- course/assignments.md</a:t>
+            </a:r>
+          </a:p>
+          <a:p xmlns:a="http://schemas.openxmlformats.org/drawingml/2006/main">
+            <a:r>
+              <a:t>- course/reading-list.md</a:t>
+            </a:r>
+          </a:p>
+          <a:p xmlns:a="http://schemas.openxmlformats.org/drawingml/2006/main">
+            <a:r>
+              <a:t>- lessons/lesson-05/slides.md</a:t>
             </a:r>
           </a:p>
           <a:p xmlns:a="http://schemas.openxmlformats.org/drawingml/2006/main">
@@ -1481,12 +1481,12 @@
           </a:p>
           <a:p xmlns:a="http://schemas.openxmlformats.org/drawingml/2006/main">
             <a:r>
-              <a:t>- /Users/bright/Projects/courses/graduate/lessons/lesson-04/slides.md</a:t>
-            </a:r>
-          </a:p>
-          <a:p xmlns:a="http://schemas.openxmlformats.org/drawingml/2006/main">
-            <a:r>
-              <a:t>- /Users/bright/Projects/courses/graduate/lessons/lesson-05/handout.md</a:t>
+              <a:t>- lessons/lesson-04/slides.md</a:t>
+            </a:r>
+          </a:p>
+          <a:p xmlns:a="http://schemas.openxmlformats.org/drawingml/2006/main">
+            <a:r>
+              <a:t>- lessons/lesson-05/handout.md</a:t>
             </a:r>
           </a:p>
           <a:p xmlns:a="http://schemas.openxmlformats.org/drawingml/2006/main">
@@ -1576,17 +1576,17 @@
           </a:p>
           <a:p xmlns:a="http://schemas.openxmlformats.org/drawingml/2006/main">
             <a:r>
-              <a:t>- /Users/bright/Projects/courses/graduate/course/syllabus.md</a:t>
-            </a:r>
-          </a:p>
-          <a:p xmlns:a="http://schemas.openxmlformats.org/drawingml/2006/main">
-            <a:r>
-              <a:t>- /Users/bright/Projects/courses/graduate/course/assignments.md</a:t>
-            </a:r>
-          </a:p>
-          <a:p xmlns:a="http://schemas.openxmlformats.org/drawingml/2006/main">
-            <a:r>
-              <a:t>- /Users/bright/Projects/courses/graduate/lessons/lesson-05/slides.md</a:t>
+              <a:t>- course/syllabus.md</a:t>
+            </a:r>
+          </a:p>
+          <a:p xmlns:a="http://schemas.openxmlformats.org/drawingml/2006/main">
+            <a:r>
+              <a:t>- course/assignments.md</a:t>
+            </a:r>
+          </a:p>
+          <a:p xmlns:a="http://schemas.openxmlformats.org/drawingml/2006/main">
+            <a:r>
+              <a:t>- lessons/lesson-05/slides.md</a:t>
             </a:r>
           </a:p>
           <a:p xmlns:a="http://schemas.openxmlformats.org/drawingml/2006/main">
@@ -1676,7 +1676,7 @@
           </a:p>
           <a:p xmlns:a="http://schemas.openxmlformats.org/drawingml/2006/main">
             <a:r>
-              <a:t>- /Users/bright/Projects/courses/graduate/lessons/lesson-05/handout.md</a:t>
+              <a:t>- lessons/lesson-05/handout.md</a:t>
             </a:r>
           </a:p>
           <a:p xmlns:a="http://schemas.openxmlformats.org/drawingml/2006/main">
@@ -1771,7 +1771,7 @@
           </a:p>
           <a:p xmlns:a="http://schemas.openxmlformats.org/drawingml/2006/main">
             <a:r>
-              <a:t>- /Users/bright/Projects/courses/graduate/course/reading-list.md</a:t>
+              <a:t>- course/reading-list.md</a:t>
             </a:r>
           </a:p>
           <a:p xmlns:a="http://schemas.openxmlformats.org/drawingml/2006/main">
@@ -1861,7 +1861,7 @@
           </a:p>
           <a:p xmlns:a="http://schemas.openxmlformats.org/drawingml/2006/main">
             <a:r>
-              <a:t>- /Users/bright/Projects/courses/graduate/lessons/lesson-05/handout.md</a:t>
+              <a:t>- lessons/lesson-05/handout.md</a:t>
             </a:r>
           </a:p>
           <a:p xmlns:a="http://schemas.openxmlformats.org/drawingml/2006/main">
@@ -1951,17 +1951,17 @@
           </a:p>
           <a:p xmlns:a="http://schemas.openxmlformats.org/drawingml/2006/main">
             <a:r>
-              <a:t>- /Users/bright/Projects/courses/graduate/lessons/lesson-03/handout.md</a:t>
-            </a:r>
-          </a:p>
-          <a:p xmlns:a="http://schemas.openxmlformats.org/drawingml/2006/main">
-            <a:r>
-              <a:t>- /Users/bright/Projects/courses/graduate/course/assignments.md</a:t>
-            </a:r>
-          </a:p>
-          <a:p xmlns:a="http://schemas.openxmlformats.org/drawingml/2006/main">
-            <a:r>
-              <a:t>- /Users/bright/Projects/courses/graduate/lessons/lesson-05/handout.md</a:t>
+              <a:t>- lessons/lesson-03/handout.md</a:t>
+            </a:r>
+          </a:p>
+          <a:p xmlns:a="http://schemas.openxmlformats.org/drawingml/2006/main">
+            <a:r>
+              <a:t>- course/assignments.md</a:t>
+            </a:r>
+          </a:p>
+          <a:p xmlns:a="http://schemas.openxmlformats.org/drawingml/2006/main">
+            <a:r>
+              <a:t>- lessons/lesson-05/handout.md</a:t>
             </a:r>
           </a:p>
           <a:p xmlns:a="http://schemas.openxmlformats.org/drawingml/2006/main">
@@ -2051,7 +2051,7 @@
           </a:p>
           <a:p xmlns:a="http://schemas.openxmlformats.org/drawingml/2006/main">
             <a:r>
-              <a:t>- /Users/bright/Projects/courses/graduate/lessons/lesson-05/handout.md</a:t>
+              <a:t>- lessons/lesson-05/handout.md</a:t>
             </a:r>
           </a:p>
           <a:p xmlns:a="http://schemas.openxmlformats.org/drawingml/2006/main">
@@ -2141,12 +2141,12 @@
           </a:p>
           <a:p xmlns:a="http://schemas.openxmlformats.org/drawingml/2006/main">
             <a:r>
-              <a:t>- /Users/bright/Projects/courses/graduate/lessons/lesson-05/handout.md</a:t>
-            </a:r>
-          </a:p>
-          <a:p xmlns:a="http://schemas.openxmlformats.org/drawingml/2006/main">
-            <a:r>
-              <a:t>- /Users/bright/Projects/courses/graduate/course/reading-list.md</a:t>
+              <a:t>- lessons/lesson-05/handout.md</a:t>
+            </a:r>
+          </a:p>
+          <a:p xmlns:a="http://schemas.openxmlformats.org/drawingml/2006/main">
+            <a:r>
+              <a:t>- course/reading-list.md</a:t>
             </a:r>
           </a:p>
           <a:p xmlns:a="http://schemas.openxmlformats.org/drawingml/2006/main">
@@ -2202,7 +2202,7 @@
           <p:nvPr/>
         </p:nvPicPr>
         <p:blipFill>
-          <a:blip xmlns:r="http://schemas.openxmlformats.org/officeDocument/2006/relationships" xmlns:a="http://schemas.openxmlformats.org/drawingml/2006/main" r:embed="R3318f1e4980b478c">
+          <a:blip xmlns:r="http://schemas.openxmlformats.org/officeDocument/2006/relationships" xmlns:a="http://schemas.openxmlformats.org/drawingml/2006/main" r:embed="Re77ff10218db4919">
             <a:duotone>
               <a:prstClr val="black"/>
               <a:schemeClr val="accent1">
@@ -2380,7 +2380,7 @@
           <p:nvPr/>
         </p:nvPicPr>
         <p:blipFill rotWithShape="1">
-          <a:blip xmlns:r="http://schemas.openxmlformats.org/officeDocument/2006/relationships" xmlns:a="http://schemas.openxmlformats.org/drawingml/2006/main" r:embed="Rcf7e05977fe940d1"/>
+          <a:blip xmlns:r="http://schemas.openxmlformats.org/officeDocument/2006/relationships" xmlns:a="http://schemas.openxmlformats.org/drawingml/2006/main" r:embed="Re6a9d8cbe92f4f10"/>
           <a:srcRect xmlns:a="http://schemas.openxmlformats.org/drawingml/2006/main" l="74359" t="0" r="1346" b="0"/>
           <a:stretch xmlns:a="http://schemas.openxmlformats.org/drawingml/2006/main"/>
         </p:blipFill>
@@ -2403,7 +2403,7 @@
           <p:nvPr/>
         </p:nvPicPr>
         <p:blipFill rotWithShape="1">
-          <a:blip xmlns:r="http://schemas.openxmlformats.org/officeDocument/2006/relationships" xmlns:a="http://schemas.openxmlformats.org/drawingml/2006/main" r:embed="Rda37fb28dd754a6d">
+          <a:blip xmlns:r="http://schemas.openxmlformats.org/officeDocument/2006/relationships" xmlns:a="http://schemas.openxmlformats.org/drawingml/2006/main" r:embed="Red3e91d5f4eb435b">
             <a:alphaModFix amt="35000"/>
           </a:blip>
           <a:srcRect xmlns:a="http://schemas.openxmlformats.org/drawingml/2006/main" l="0" t="9831" r="0" b="36385"/>
@@ -2665,7 +2665,7 @@
           <p:nvPr/>
         </p:nvPicPr>
         <p:blipFill>
-          <a:blip xmlns:r="http://schemas.openxmlformats.org/officeDocument/2006/relationships" xmlns:a="http://schemas.openxmlformats.org/drawingml/2006/main" r:embed="R34fcc29f1dca43a7"/>
+          <a:blip xmlns:r="http://schemas.openxmlformats.org/officeDocument/2006/relationships" xmlns:a="http://schemas.openxmlformats.org/drawingml/2006/main" r:embed="R8062a518ba0740a6"/>
           <a:srcRect xmlns:a="http://schemas.openxmlformats.org/drawingml/2006/main" l="0" t="0" r="54251" b="0"/>
           <a:stretch xmlns:a="http://schemas.openxmlformats.org/drawingml/2006/main"/>
         </p:blipFill>
@@ -2922,7 +2922,7 @@
           <p:nvPr/>
         </p:nvPicPr>
         <p:blipFill rotWithShape="1">
-          <a:blip xmlns:r="http://schemas.openxmlformats.org/officeDocument/2006/relationships" xmlns:a="http://schemas.openxmlformats.org/drawingml/2006/main" r:embed="R03bc4934d64c4379"/>
+          <a:blip xmlns:r="http://schemas.openxmlformats.org/officeDocument/2006/relationships" xmlns:a="http://schemas.openxmlformats.org/drawingml/2006/main" r:embed="Rf3abcfde092a4c56"/>
           <a:srcRect xmlns:a="http://schemas.openxmlformats.org/drawingml/2006/main" l="0" t="0" r="1346" b="0"/>
           <a:stretch xmlns:a="http://schemas.openxmlformats.org/drawingml/2006/main"/>
         </p:blipFill>
@@ -3105,7 +3105,7 @@
           <p:nvPr/>
         </p:nvPicPr>
         <p:blipFill>
-          <a:blip xmlns:r="http://schemas.openxmlformats.org/officeDocument/2006/relationships" xmlns:a="http://schemas.openxmlformats.org/drawingml/2006/main" r:embed="R5e12700b51e44ff8"/>
+          <a:blip xmlns:r="http://schemas.openxmlformats.org/officeDocument/2006/relationships" xmlns:a="http://schemas.openxmlformats.org/drawingml/2006/main" r:embed="Rc1c19088c8ca4735"/>
           <a:stretch xmlns:a="http://schemas.openxmlformats.org/drawingml/2006/main">
             <a:fillRect l="0" t="0" r="0" b="0"/>
           </a:stretch>
@@ -3201,7 +3201,7 @@
           <p:nvPr/>
         </p:nvPicPr>
         <p:blipFill>
-          <a:blip xmlns:r="http://schemas.openxmlformats.org/officeDocument/2006/relationships" xmlns:a="http://schemas.openxmlformats.org/drawingml/2006/main" r:embed="Rf273b67fbfaa4267">
+          <a:blip xmlns:r="http://schemas.openxmlformats.org/officeDocument/2006/relationships" xmlns:a="http://schemas.openxmlformats.org/drawingml/2006/main" r:embed="Rf6ed74e801094c5b">
             <a:duotone>
               <a:prstClr val="black"/>
               <a:schemeClr val="accent1">
@@ -3368,7 +3368,7 @@
           <p:nvPr/>
         </p:nvPicPr>
         <p:blipFill rotWithShape="1">
-          <a:blip xmlns:r="http://schemas.openxmlformats.org/officeDocument/2006/relationships" xmlns:a="http://schemas.openxmlformats.org/drawingml/2006/main" r:embed="R67d0fcee6dfd4699">
+          <a:blip xmlns:r="http://schemas.openxmlformats.org/officeDocument/2006/relationships" xmlns:a="http://schemas.openxmlformats.org/drawingml/2006/main" r:embed="R8150e4cdc903442c">
             <a:alphaModFix amt="20000"/>
             <a:duotone>
               <a:schemeClr val="accent4">
@@ -3466,10 +3466,10 @@
   </p:cSld>
   <p:clrMap bg1="lt1" tx1="dk1" bg2="lt2" tx2="dk2" accent1="accent1" accent2="accent2" accent3="accent3" accent4="accent4" accent5="accent5" accent6="accent6" hlink="hlink" folHlink="folHlink"/>
   <p:sldLayoutIdLst>
-    <p:sldLayoutId xmlns:r="http://schemas.openxmlformats.org/officeDocument/2006/relationships" id="2147483649" r:id="R48d66be907994a62"/>
-    <p:sldLayoutId xmlns:r="http://schemas.openxmlformats.org/officeDocument/2006/relationships" id="2147483650" r:id="Rf69ad5574815403c"/>
-    <p:sldLayoutId xmlns:r="http://schemas.openxmlformats.org/officeDocument/2006/relationships" id="2147483651" r:id="R43a8353ad76a4ea9"/>
-    <p:sldLayoutId xmlns:r="http://schemas.openxmlformats.org/officeDocument/2006/relationships" id="2147483652" r:id="Rd9ff76874b0041c5"/>
+    <p:sldLayoutId xmlns:r="http://schemas.openxmlformats.org/officeDocument/2006/relationships" id="2147483649" r:id="R52b6653eec064d63"/>
+    <p:sldLayoutId xmlns:r="http://schemas.openxmlformats.org/officeDocument/2006/relationships" id="2147483650" r:id="R3534d1ed15f94a0f"/>
+    <p:sldLayoutId xmlns:r="http://schemas.openxmlformats.org/officeDocument/2006/relationships" id="2147483651" r:id="Re989b2741cec4e63"/>
+    <p:sldLayoutId xmlns:r="http://schemas.openxmlformats.org/officeDocument/2006/relationships" id="2147483652" r:id="Re85b3205ea7949bd"/>
   </p:sldLayoutIdLst>
   <p:hf hdr="0" ftr="0" dt="0"/>
   <p:txStyles>
@@ -4268,7 +4268,7 @@
           <p:cNvPr id="6" name="p10-a0">
             <a:extLst xmlns:a="http://schemas.openxmlformats.org/drawingml/2006/main">
               <a:ext uri="{FF2B5EF4-FFF2-40B4-BE49-F238E27FC236}">
-                <a16:creationId xmlns:a16="http://schemas.microsoft.com/office/drawing/2014/main" id="{663AD520-2AFD-4B1D-AB08-3326A3257387}"/>
+                <a16:creationId xmlns:a16="http://schemas.microsoft.com/office/drawing/2014/main" id="{9EEE9CB7-26FC-4830-9CB5-D21DA92FAF10}"/>
               </a:ext>
             </a:extLst>
           </p:cNvPr>
@@ -4325,7 +4325,7 @@
           <p:cNvPr id="7" name="p10-arr0">
             <a:extLst xmlns:a="http://schemas.openxmlformats.org/drawingml/2006/main">
               <a:ext uri="{FF2B5EF4-FFF2-40B4-BE49-F238E27FC236}">
-                <a16:creationId xmlns:a16="http://schemas.microsoft.com/office/drawing/2014/main" id="{F52017BC-B9A1-46E1-BD05-84B83853D3A9}"/>
+                <a16:creationId xmlns:a16="http://schemas.microsoft.com/office/drawing/2014/main" id="{25F6BD65-DF90-4B1B-B831-143067BDBCC5}"/>
               </a:ext>
             </a:extLst>
           </p:cNvPr>
@@ -4378,7 +4378,7 @@
           <p:cNvPr id="8" name="p10-b0">
             <a:extLst xmlns:a="http://schemas.openxmlformats.org/drawingml/2006/main">
               <a:ext uri="{FF2B5EF4-FFF2-40B4-BE49-F238E27FC236}">
-                <a16:creationId xmlns:a16="http://schemas.microsoft.com/office/drawing/2014/main" id="{E9D36EAB-4B77-4956-9990-A25539B82711}"/>
+                <a16:creationId xmlns:a16="http://schemas.microsoft.com/office/drawing/2014/main" id="{31857315-5C9B-4CBF-8E64-10F97D551FC0}"/>
               </a:ext>
             </a:extLst>
           </p:cNvPr>
@@ -4437,7 +4437,7 @@
           <p:cNvPr id="9" name="p10-a1">
             <a:extLst xmlns:a="http://schemas.openxmlformats.org/drawingml/2006/main">
               <a:ext uri="{FF2B5EF4-FFF2-40B4-BE49-F238E27FC236}">
-                <a16:creationId xmlns:a16="http://schemas.microsoft.com/office/drawing/2014/main" id="{5827CD6C-38DA-4D9C-9AB5-184FBDC1642F}"/>
+                <a16:creationId xmlns:a16="http://schemas.microsoft.com/office/drawing/2014/main" id="{134F4B49-F58F-4DF5-A497-72D68CF413C6}"/>
               </a:ext>
             </a:extLst>
           </p:cNvPr>
@@ -4494,7 +4494,7 @@
           <p:cNvPr id="10" name="p10-arr1">
             <a:extLst xmlns:a="http://schemas.openxmlformats.org/drawingml/2006/main">
               <a:ext uri="{FF2B5EF4-FFF2-40B4-BE49-F238E27FC236}">
-                <a16:creationId xmlns:a16="http://schemas.microsoft.com/office/drawing/2014/main" id="{F77C91FB-7175-43AA-B0A9-B5987E4CD3E0}"/>
+                <a16:creationId xmlns:a16="http://schemas.microsoft.com/office/drawing/2014/main" id="{D82F37A6-93CD-4C0E-B440-2DC82F4AD1D3}"/>
               </a:ext>
             </a:extLst>
           </p:cNvPr>
@@ -4547,7 +4547,7 @@
           <p:cNvPr id="11" name="p10-b1">
             <a:extLst xmlns:a="http://schemas.openxmlformats.org/drawingml/2006/main">
               <a:ext uri="{FF2B5EF4-FFF2-40B4-BE49-F238E27FC236}">
-                <a16:creationId xmlns:a16="http://schemas.microsoft.com/office/drawing/2014/main" id="{D0C0CD5A-6FAF-4295-8D79-65837B8645B4}"/>
+                <a16:creationId xmlns:a16="http://schemas.microsoft.com/office/drawing/2014/main" id="{8EBC901C-7B4D-4B8C-A260-53D7CBF9EAFB}"/>
               </a:ext>
             </a:extLst>
           </p:cNvPr>
@@ -4606,7 +4606,7 @@
           <p:cNvPr id="12" name="p10-a2">
             <a:extLst xmlns:a="http://schemas.openxmlformats.org/drawingml/2006/main">
               <a:ext uri="{FF2B5EF4-FFF2-40B4-BE49-F238E27FC236}">
-                <a16:creationId xmlns:a16="http://schemas.microsoft.com/office/drawing/2014/main" id="{7E1886B2-DD1B-47D7-AC8D-F42BCD4962BD}"/>
+                <a16:creationId xmlns:a16="http://schemas.microsoft.com/office/drawing/2014/main" id="{5ED8A546-E7DA-4037-B6C5-9C2B874E138F}"/>
               </a:ext>
             </a:extLst>
           </p:cNvPr>
@@ -4663,7 +4663,7 @@
           <p:cNvPr id="13" name="p10-arr2">
             <a:extLst xmlns:a="http://schemas.openxmlformats.org/drawingml/2006/main">
               <a:ext uri="{FF2B5EF4-FFF2-40B4-BE49-F238E27FC236}">
-                <a16:creationId xmlns:a16="http://schemas.microsoft.com/office/drawing/2014/main" id="{B43A08C3-56E3-4AC1-8AA4-E11F9F9E6945}"/>
+                <a16:creationId xmlns:a16="http://schemas.microsoft.com/office/drawing/2014/main" id="{AB91E045-C07A-42C3-8576-DEAC1B1BA979}"/>
               </a:ext>
             </a:extLst>
           </p:cNvPr>
@@ -4716,7 +4716,7 @@
           <p:cNvPr id="14" name="p10-b2">
             <a:extLst xmlns:a="http://schemas.openxmlformats.org/drawingml/2006/main">
               <a:ext uri="{FF2B5EF4-FFF2-40B4-BE49-F238E27FC236}">
-                <a16:creationId xmlns:a16="http://schemas.microsoft.com/office/drawing/2014/main" id="{1D584389-C6FF-4CFA-98DF-80E06CB36D7B}"/>
+                <a16:creationId xmlns:a16="http://schemas.microsoft.com/office/drawing/2014/main" id="{CEF724F7-01D0-4FE5-9EAB-24EED90D0AE7}"/>
               </a:ext>
             </a:extLst>
           </p:cNvPr>
@@ -4775,7 +4775,7 @@
           <p:cNvPr id="15" name="p10-a3">
             <a:extLst xmlns:a="http://schemas.openxmlformats.org/drawingml/2006/main">
               <a:ext uri="{FF2B5EF4-FFF2-40B4-BE49-F238E27FC236}">
-                <a16:creationId xmlns:a16="http://schemas.microsoft.com/office/drawing/2014/main" id="{02DB52BB-B4BD-480F-82AB-D41B08AA47AE}"/>
+                <a16:creationId xmlns:a16="http://schemas.microsoft.com/office/drawing/2014/main" id="{0EDEE54F-8973-466A-A781-FB1AE75F928E}"/>
               </a:ext>
             </a:extLst>
           </p:cNvPr>
@@ -4832,7 +4832,7 @@
           <p:cNvPr id="16" name="p10-arr3">
             <a:extLst xmlns:a="http://schemas.openxmlformats.org/drawingml/2006/main">
               <a:ext uri="{FF2B5EF4-FFF2-40B4-BE49-F238E27FC236}">
-                <a16:creationId xmlns:a16="http://schemas.microsoft.com/office/drawing/2014/main" id="{8A1A0FA5-BF06-43F1-B9EB-9E17CC4F997C}"/>
+                <a16:creationId xmlns:a16="http://schemas.microsoft.com/office/drawing/2014/main" id="{9EE70306-D2E4-4487-8FD1-D4E399DE7802}"/>
               </a:ext>
             </a:extLst>
           </p:cNvPr>
@@ -4885,7 +4885,7 @@
           <p:cNvPr id="17" name="p10-b3">
             <a:extLst xmlns:a="http://schemas.openxmlformats.org/drawingml/2006/main">
               <a:ext uri="{FF2B5EF4-FFF2-40B4-BE49-F238E27FC236}">
-                <a16:creationId xmlns:a16="http://schemas.microsoft.com/office/drawing/2014/main" id="{A5463FF9-893D-4925-B45C-78C4608A553B}"/>
+                <a16:creationId xmlns:a16="http://schemas.microsoft.com/office/drawing/2014/main" id="{9487FAA2-8904-4DDB-8DC9-BC14E5AD16EE}"/>
               </a:ext>
             </a:extLst>
           </p:cNvPr>
@@ -4944,7 +4944,7 @@
           <p:cNvPr id="18" name="p10-bottom">
             <a:extLst xmlns:a="http://schemas.openxmlformats.org/drawingml/2006/main">
               <a:ext uri="{FF2B5EF4-FFF2-40B4-BE49-F238E27FC236}">
-                <a16:creationId xmlns:a16="http://schemas.microsoft.com/office/drawing/2014/main" id="{665B2915-B0C7-493A-9134-162B39AD1AD9}"/>
+                <a16:creationId xmlns:a16="http://schemas.microsoft.com/office/drawing/2014/main" id="{BC8BD521-A292-4026-ACD2-A1A61A3331EE}"/>
               </a:ext>
             </a:extLst>
           </p:cNvPr>
@@ -5091,7 +5091,7 @@
           <p:cNvPr id="6" name="p11-n0">
             <a:extLst xmlns:a="http://schemas.openxmlformats.org/drawingml/2006/main">
               <a:ext uri="{FF2B5EF4-FFF2-40B4-BE49-F238E27FC236}">
-                <a16:creationId xmlns:a16="http://schemas.microsoft.com/office/drawing/2014/main" id="{DB31C880-9835-425A-BDEF-895A59B91401}"/>
+                <a16:creationId xmlns:a16="http://schemas.microsoft.com/office/drawing/2014/main" id="{D8AF56E1-DD65-40B1-9569-8C708971C7A9}"/>
               </a:ext>
             </a:extLst>
           </p:cNvPr>
@@ -5148,7 +5148,7 @@
           <p:cNvPr id="7" name="p11-t0">
             <a:extLst xmlns:a="http://schemas.openxmlformats.org/drawingml/2006/main">
               <a:ext uri="{FF2B5EF4-FFF2-40B4-BE49-F238E27FC236}">
-                <a16:creationId xmlns:a16="http://schemas.microsoft.com/office/drawing/2014/main" id="{122E4C36-6D9A-4CA2-8334-050B1B1CF1C7}"/>
+                <a16:creationId xmlns:a16="http://schemas.microsoft.com/office/drawing/2014/main" id="{D1473288-0B42-41A4-992F-B89E08F4C9E6}"/>
               </a:ext>
             </a:extLst>
           </p:cNvPr>
@@ -5207,7 +5207,7 @@
           <p:cNvPr id="8" name="p11-n1">
             <a:extLst xmlns:a="http://schemas.openxmlformats.org/drawingml/2006/main">
               <a:ext uri="{FF2B5EF4-FFF2-40B4-BE49-F238E27FC236}">
-                <a16:creationId xmlns:a16="http://schemas.microsoft.com/office/drawing/2014/main" id="{C28DCCE7-EF65-495B-8BEC-035824A87042}"/>
+                <a16:creationId xmlns:a16="http://schemas.microsoft.com/office/drawing/2014/main" id="{6076CE8E-CFC0-4A56-9DC7-3B5D7A5B8783}"/>
               </a:ext>
             </a:extLst>
           </p:cNvPr>
@@ -5264,7 +5264,7 @@
           <p:cNvPr id="9" name="p11-t1">
             <a:extLst xmlns:a="http://schemas.openxmlformats.org/drawingml/2006/main">
               <a:ext uri="{FF2B5EF4-FFF2-40B4-BE49-F238E27FC236}">
-                <a16:creationId xmlns:a16="http://schemas.microsoft.com/office/drawing/2014/main" id="{D845596F-8E3E-4A14-A8E8-ECCB0205461E}"/>
+                <a16:creationId xmlns:a16="http://schemas.microsoft.com/office/drawing/2014/main" id="{52542DE7-2F89-4239-840A-CE5A0C4AE08E}"/>
               </a:ext>
             </a:extLst>
           </p:cNvPr>
@@ -5323,7 +5323,7 @@
           <p:cNvPr id="10" name="p11-n2">
             <a:extLst xmlns:a="http://schemas.openxmlformats.org/drawingml/2006/main">
               <a:ext uri="{FF2B5EF4-FFF2-40B4-BE49-F238E27FC236}">
-                <a16:creationId xmlns:a16="http://schemas.microsoft.com/office/drawing/2014/main" id="{CC1C844D-1DFD-466E-960F-E3F72C71A525}"/>
+                <a16:creationId xmlns:a16="http://schemas.microsoft.com/office/drawing/2014/main" id="{5093DBAC-181D-451F-A1F0-A871694D7424}"/>
               </a:ext>
             </a:extLst>
           </p:cNvPr>
@@ -5380,7 +5380,7 @@
           <p:cNvPr id="11" name="p11-t2">
             <a:extLst xmlns:a="http://schemas.openxmlformats.org/drawingml/2006/main">
               <a:ext uri="{FF2B5EF4-FFF2-40B4-BE49-F238E27FC236}">
-                <a16:creationId xmlns:a16="http://schemas.microsoft.com/office/drawing/2014/main" id="{1B1E44C6-3BBF-475D-9466-8EBCDB8736F9}"/>
+                <a16:creationId xmlns:a16="http://schemas.microsoft.com/office/drawing/2014/main" id="{2579BA18-67B8-4B88-94F6-53AD9721FCFD}"/>
               </a:ext>
             </a:extLst>
           </p:cNvPr>
@@ -5439,7 +5439,7 @@
           <p:cNvPr id="12" name="p11-n3">
             <a:extLst xmlns:a="http://schemas.openxmlformats.org/drawingml/2006/main">
               <a:ext uri="{FF2B5EF4-FFF2-40B4-BE49-F238E27FC236}">
-                <a16:creationId xmlns:a16="http://schemas.microsoft.com/office/drawing/2014/main" id="{BC0F14E4-8122-4EA8-8F79-F273C5C4ACB1}"/>
+                <a16:creationId xmlns:a16="http://schemas.microsoft.com/office/drawing/2014/main" id="{99C4C03A-EB62-41D9-9483-D934EF52120B}"/>
               </a:ext>
             </a:extLst>
           </p:cNvPr>
@@ -5496,7 +5496,7 @@
           <p:cNvPr id="13" name="p11-t3">
             <a:extLst xmlns:a="http://schemas.openxmlformats.org/drawingml/2006/main">
               <a:ext uri="{FF2B5EF4-FFF2-40B4-BE49-F238E27FC236}">
-                <a16:creationId xmlns:a16="http://schemas.microsoft.com/office/drawing/2014/main" id="{2BC4BD1F-8168-4C1E-890C-151D63B48966}"/>
+                <a16:creationId xmlns:a16="http://schemas.microsoft.com/office/drawing/2014/main" id="{A6A8652E-A078-4E6A-AA43-627594D7AFAD}"/>
               </a:ext>
             </a:extLst>
           </p:cNvPr>
@@ -5555,7 +5555,7 @@
           <p:cNvPr id="14" name="p11-n4">
             <a:extLst xmlns:a="http://schemas.openxmlformats.org/drawingml/2006/main">
               <a:ext uri="{FF2B5EF4-FFF2-40B4-BE49-F238E27FC236}">
-                <a16:creationId xmlns:a16="http://schemas.microsoft.com/office/drawing/2014/main" id="{2073F7E0-A4D8-4FA2-BB4B-D9504E379F2C}"/>
+                <a16:creationId xmlns:a16="http://schemas.microsoft.com/office/drawing/2014/main" id="{9387252E-BD4D-4B37-860E-6D522296E6E2}"/>
               </a:ext>
             </a:extLst>
           </p:cNvPr>
@@ -5612,7 +5612,7 @@
           <p:cNvPr id="15" name="p11-t4">
             <a:extLst xmlns:a="http://schemas.openxmlformats.org/drawingml/2006/main">
               <a:ext uri="{FF2B5EF4-FFF2-40B4-BE49-F238E27FC236}">
-                <a16:creationId xmlns:a16="http://schemas.microsoft.com/office/drawing/2014/main" id="{0397A502-297B-4E69-9006-62FB885F20C6}"/>
+                <a16:creationId xmlns:a16="http://schemas.microsoft.com/office/drawing/2014/main" id="{5E04C71E-F83A-48A6-8AF3-B5BE9E600E2A}"/>
               </a:ext>
             </a:extLst>
           </p:cNvPr>
@@ -5671,7 +5671,7 @@
           <p:cNvPr id="16" name="p11-status-h">
             <a:extLst xmlns:a="http://schemas.openxmlformats.org/drawingml/2006/main">
               <a:ext uri="{FF2B5EF4-FFF2-40B4-BE49-F238E27FC236}">
-                <a16:creationId xmlns:a16="http://schemas.microsoft.com/office/drawing/2014/main" id="{D6CD9A31-45C1-43C8-ABF1-0E709FE740C2}"/>
+                <a16:creationId xmlns:a16="http://schemas.microsoft.com/office/drawing/2014/main" id="{FBC6E190-4456-4513-9D3F-39F5EDC9E6ED}"/>
               </a:ext>
             </a:extLst>
           </p:cNvPr>
@@ -5726,19 +5726,19 @@
           <p:cNvPr id="17" name="p11-s0">
             <a:extLst xmlns:a="http://schemas.openxmlformats.org/drawingml/2006/main">
               <a:ext uri="{FF2B5EF4-FFF2-40B4-BE49-F238E27FC236}">
-                <a16:creationId xmlns:a16="http://schemas.microsoft.com/office/drawing/2014/main" id="{46F85B35-058D-4603-A255-1FC726700CB8}"/>
-              </a:ext>
-            </a:extLst>
-          </p:cNvPr>
-          <p:cNvSpPr>
-            <a:spLocks xmlns:a="http://schemas.openxmlformats.org/drawingml/2006/main" noGrp="1"/>
-          </p:cNvSpPr>
-          <p:nvPr/>
-        </p:nvSpPr>
-        <p:spPr>
-          <a:xfrm xmlns:a="http://schemas.openxmlformats.org/drawingml/2006/main">
-            <a:off x="9525000" y="1790700"/>
-            <a:ext cx="1714500" cy="476250"/>
+                <a16:creationId xmlns:a16="http://schemas.microsoft.com/office/drawing/2014/main" id="{8108D961-19D6-45E4-877F-65956A2EC0C5}"/>
+              </a:ext>
+            </a:extLst>
+          </p:cNvPr>
+          <p:cNvSpPr>
+            <a:spLocks xmlns:a="http://schemas.openxmlformats.org/drawingml/2006/main" noGrp="1"/>
+          </p:cNvSpPr>
+          <p:nvPr/>
+        </p:nvSpPr>
+        <p:spPr>
+          <a:xfrm xmlns:a="http://schemas.openxmlformats.org/drawingml/2006/main">
+            <a:off x="9144000" y="1790700"/>
+            <a:ext cx="2476500" cy="476250"/>
           </a:xfrm>
           <a:prstGeom xmlns:a="http://schemas.openxmlformats.org/drawingml/2006/main" prst="roundRect">
             <a:avLst>
@@ -5758,14 +5758,14 @@
           <a:lstStyle xmlns:a="http://schemas.openxmlformats.org/drawingml/2006/main"/>
           <a:p xmlns:a="http://schemas.openxmlformats.org/drawingml/2006/main">
             <a:pPr algn="ctr">
-              <a:defRPr sz="1350" b="1">
+              <a:defRPr sz="1275" b="1">
                 <a:solidFill>
                   <a:srgbClr val="A86C12"/>
                 </a:solidFill>
               </a:defRPr>
             </a:pPr>
             <a:r>
-              <a:rPr sz="1350" b="1">
+              <a:rPr sz="1275" b="1">
                 <a:solidFill>
                   <a:srgbClr val="A86C12"/>
                 </a:solidFill>
@@ -5783,19 +5783,19 @@
           <p:cNvPr id="18" name="p11-s1">
             <a:extLst xmlns:a="http://schemas.openxmlformats.org/drawingml/2006/main">
               <a:ext uri="{FF2B5EF4-FFF2-40B4-BE49-F238E27FC236}">
-                <a16:creationId xmlns:a16="http://schemas.microsoft.com/office/drawing/2014/main" id="{34E342C3-B960-4DED-BB3C-3E042BD01B7A}"/>
-              </a:ext>
-            </a:extLst>
-          </p:cNvPr>
-          <p:cNvSpPr>
-            <a:spLocks xmlns:a="http://schemas.openxmlformats.org/drawingml/2006/main" noGrp="1"/>
-          </p:cNvSpPr>
-          <p:nvPr/>
-        </p:nvSpPr>
-        <p:spPr>
-          <a:xfrm xmlns:a="http://schemas.openxmlformats.org/drawingml/2006/main">
-            <a:off x="9525000" y="2571750"/>
-            <a:ext cx="1714500" cy="476250"/>
+                <a16:creationId xmlns:a16="http://schemas.microsoft.com/office/drawing/2014/main" id="{7B1A744F-116A-47EB-B100-0F29B7C4B5CE}"/>
+              </a:ext>
+            </a:extLst>
+          </p:cNvPr>
+          <p:cNvSpPr>
+            <a:spLocks xmlns:a="http://schemas.openxmlformats.org/drawingml/2006/main" noGrp="1"/>
+          </p:cNvSpPr>
+          <p:nvPr/>
+        </p:nvSpPr>
+        <p:spPr>
+          <a:xfrm xmlns:a="http://schemas.openxmlformats.org/drawingml/2006/main">
+            <a:off x="9144000" y="2571750"/>
+            <a:ext cx="2476500" cy="476250"/>
           </a:xfrm>
           <a:prstGeom xmlns:a="http://schemas.openxmlformats.org/drawingml/2006/main" prst="roundRect">
             <a:avLst>
@@ -5815,14 +5815,14 @@
           <a:lstStyle xmlns:a="http://schemas.openxmlformats.org/drawingml/2006/main"/>
           <a:p xmlns:a="http://schemas.openxmlformats.org/drawingml/2006/main">
             <a:pPr algn="ctr">
-              <a:defRPr sz="1350" b="1">
+              <a:defRPr sz="1275" b="1">
                 <a:solidFill>
                   <a:srgbClr val="28745A"/>
                 </a:solidFill>
               </a:defRPr>
             </a:pPr>
             <a:r>
-              <a:rPr sz="1350" b="1">
+              <a:rPr sz="1275" b="1">
                 <a:solidFill>
                   <a:srgbClr val="28745A"/>
                 </a:solidFill>
@@ -5840,19 +5840,19 @@
           <p:cNvPr id="19" name="p11-s2">
             <a:extLst xmlns:a="http://schemas.openxmlformats.org/drawingml/2006/main">
               <a:ext uri="{FF2B5EF4-FFF2-40B4-BE49-F238E27FC236}">
-                <a16:creationId xmlns:a16="http://schemas.microsoft.com/office/drawing/2014/main" id="{87BB89E8-9F81-48EF-929B-6C568B6FB494}"/>
-              </a:ext>
-            </a:extLst>
-          </p:cNvPr>
-          <p:cNvSpPr>
-            <a:spLocks xmlns:a="http://schemas.openxmlformats.org/drawingml/2006/main" noGrp="1"/>
-          </p:cNvSpPr>
-          <p:nvPr/>
-        </p:nvSpPr>
-        <p:spPr>
-          <a:xfrm xmlns:a="http://schemas.openxmlformats.org/drawingml/2006/main">
-            <a:off x="9525000" y="3352800"/>
-            <a:ext cx="1714500" cy="476250"/>
+                <a16:creationId xmlns:a16="http://schemas.microsoft.com/office/drawing/2014/main" id="{7785C593-A404-41FE-ADDC-675197B7916E}"/>
+              </a:ext>
+            </a:extLst>
+          </p:cNvPr>
+          <p:cNvSpPr>
+            <a:spLocks xmlns:a="http://schemas.openxmlformats.org/drawingml/2006/main" noGrp="1"/>
+          </p:cNvSpPr>
+          <p:nvPr/>
+        </p:nvSpPr>
+        <p:spPr>
+          <a:xfrm xmlns:a="http://schemas.openxmlformats.org/drawingml/2006/main">
+            <a:off x="9144000" y="3352800"/>
+            <a:ext cx="2476500" cy="476250"/>
           </a:xfrm>
           <a:prstGeom xmlns:a="http://schemas.openxmlformats.org/drawingml/2006/main" prst="roundRect">
             <a:avLst>
@@ -5872,14 +5872,14 @@
           <a:lstStyle xmlns:a="http://schemas.openxmlformats.org/drawingml/2006/main"/>
           <a:p xmlns:a="http://schemas.openxmlformats.org/drawingml/2006/main">
             <a:pPr algn="ctr">
-              <a:defRPr sz="1350" b="1">
+              <a:defRPr sz="1275" b="1">
                 <a:solidFill>
                   <a:srgbClr val="2F638A"/>
                 </a:solidFill>
               </a:defRPr>
             </a:pPr>
             <a:r>
-              <a:rPr sz="1350" b="1">
+              <a:rPr sz="1275" b="1">
                 <a:solidFill>
                   <a:srgbClr val="2F638A"/>
                 </a:solidFill>
@@ -5887,7 +5887,7 @@
                 <a:ea typeface="Microsoft YaHei"/>
                 <a:cs typeface="Microsoft YaHei"/>
               </a:rPr>
-              <a:t>with caveat</a:t>
+              <a:t>verified-with-caveat</a:t>
             </a:r>
           </a:p>
         </p:txBody>
@@ -5897,19 +5897,19 @@
           <p:cNvPr id="20" name="p11-s3">
             <a:extLst xmlns:a="http://schemas.openxmlformats.org/drawingml/2006/main">
               <a:ext uri="{FF2B5EF4-FFF2-40B4-BE49-F238E27FC236}">
-                <a16:creationId xmlns:a16="http://schemas.microsoft.com/office/drawing/2014/main" id="{C4DE3A6D-032A-448D-A84A-7009324AB079}"/>
-              </a:ext>
-            </a:extLst>
-          </p:cNvPr>
-          <p:cNvSpPr>
-            <a:spLocks xmlns:a="http://schemas.openxmlformats.org/drawingml/2006/main" noGrp="1"/>
-          </p:cNvSpPr>
-          <p:nvPr/>
-        </p:nvSpPr>
-        <p:spPr>
-          <a:xfrm xmlns:a="http://schemas.openxmlformats.org/drawingml/2006/main">
-            <a:off x="9525000" y="4133850"/>
-            <a:ext cx="1714500" cy="476250"/>
+                <a16:creationId xmlns:a16="http://schemas.microsoft.com/office/drawing/2014/main" id="{64BBE182-7045-4903-B924-F0B8FB193F0F}"/>
+              </a:ext>
+            </a:extLst>
+          </p:cNvPr>
+          <p:cNvSpPr>
+            <a:spLocks xmlns:a="http://schemas.openxmlformats.org/drawingml/2006/main" noGrp="1"/>
+          </p:cNvSpPr>
+          <p:nvPr/>
+        </p:nvSpPr>
+        <p:spPr>
+          <a:xfrm xmlns:a="http://schemas.openxmlformats.org/drawingml/2006/main">
+            <a:off x="9144000" y="4133850"/>
+            <a:ext cx="2476500" cy="476250"/>
           </a:xfrm>
           <a:prstGeom xmlns:a="http://schemas.openxmlformats.org/drawingml/2006/main" prst="roundRect">
             <a:avLst>
@@ -5929,14 +5929,14 @@
           <a:lstStyle xmlns:a="http://schemas.openxmlformats.org/drawingml/2006/main"/>
           <a:p xmlns:a="http://schemas.openxmlformats.org/drawingml/2006/main">
             <a:pPr algn="ctr">
-              <a:defRPr sz="1350" b="1">
+              <a:defRPr sz="1275" b="1">
                 <a:solidFill>
                   <a:srgbClr val="C8161E"/>
                 </a:solidFill>
               </a:defRPr>
             </a:pPr>
             <a:r>
-              <a:rPr sz="1350" b="1">
+              <a:rPr sz="1275" b="1">
                 <a:solidFill>
                   <a:srgbClr val="C8161E"/>
                 </a:solidFill>
@@ -5954,24 +5954,26 @@
           <p:cNvPr id="21" name="p11-bottom">
             <a:extLst xmlns:a="http://schemas.openxmlformats.org/drawingml/2006/main">
               <a:ext uri="{FF2B5EF4-FFF2-40B4-BE49-F238E27FC236}">
-                <a16:creationId xmlns:a16="http://schemas.microsoft.com/office/drawing/2014/main" id="{0421C27F-95CF-41C9-99C7-B4A0B5B91A51}"/>
-              </a:ext>
-            </a:extLst>
-          </p:cNvPr>
-          <p:cNvSpPr>
-            <a:spLocks xmlns:a="http://schemas.openxmlformats.org/drawingml/2006/main" noGrp="1"/>
-          </p:cNvSpPr>
-          <p:nvPr/>
-        </p:nvSpPr>
-        <p:spPr>
-          <a:xfrm xmlns:a="http://schemas.openxmlformats.org/drawingml/2006/main">
-            <a:off x="2095500" y="5162550"/>
-            <a:ext cx="8001000" cy="457200"/>
+                <a16:creationId xmlns:a16="http://schemas.microsoft.com/office/drawing/2014/main" id="{744020E6-E977-4E16-9533-F627E610B971}"/>
+              </a:ext>
+            </a:extLst>
+          </p:cNvPr>
+          <p:cNvSpPr>
+            <a:spLocks xmlns:a="http://schemas.openxmlformats.org/drawingml/2006/main" noGrp="1"/>
+          </p:cNvSpPr>
+          <p:nvPr/>
+        </p:nvSpPr>
+        <p:spPr>
+          <a:xfrm xmlns:a="http://schemas.openxmlformats.org/drawingml/2006/main">
+            <a:off x="1600200" y="5105400"/>
+            <a:ext cx="8991600" cy="533400"/>
           </a:xfrm>
           <a:prstGeom xmlns:a="http://schemas.openxmlformats.org/drawingml/2006/main" prst="rect">
             <a:avLst/>
           </a:prstGeom>
-          <a:noFill xmlns:a="http://schemas.openxmlformats.org/drawingml/2006/main"/>
+          <a:solidFill xmlns:a="http://schemas.openxmlformats.org/drawingml/2006/main">
+            <a:srgbClr val="F8E9EA"/>
+          </a:solidFill>
           <a:ln xmlns:a="http://schemas.openxmlformats.org/drawingml/2006/main" w="0">
             <a:noFill/>
             <a:prstDash val="solid"/>
@@ -5982,14 +5984,14 @@
           <a:lstStyle xmlns:a="http://schemas.openxmlformats.org/drawingml/2006/main"/>
           <a:p xmlns:a="http://schemas.openxmlformats.org/drawingml/2006/main">
             <a:pPr algn="ctr">
-              <a:defRPr sz="1800" b="1">
+              <a:defRPr sz="1500" b="1">
                 <a:solidFill>
                   <a:srgbClr val="C8161E"/>
                 </a:solidFill>
               </a:defRPr>
             </a:pPr>
             <a:r>
-              <a:rPr sz="1800" b="1">
+              <a:rPr sz="1500" b="1">
                 <a:solidFill>
                   <a:srgbClr val="C8161E"/>
                 </a:solidFill>
@@ -5997,7 +5999,7 @@
                 <a:ea typeface="Microsoft YaHei"/>
                 <a:cs typeface="Microsoft YaHei"/>
               </a:rPr>
-              <a:t>未完成核验前，AI 产出只留在线索区。</a:t>
+              <a:t>pending 仅线索区｜caveat 必须保留限定且不可单独支撑 stable｜rejected 仅审计</a:t>
             </a:r>
           </a:p>
         </p:txBody>
@@ -6060,7 +6062,7 @@
                 <a:ea typeface="Microsoft YaHei"/>
                 <a:cs typeface="Microsoft YaHei"/>
               </a:rPr>
-              <a:t>演示：5 张阅读卡进入相关工作矩阵</a:t>
+              <a:t>演示：5 张阅读卡 → 相关工作矩阵</a:t>
             </a:r>
             <a:endParaRPr/>
           </a:p>
@@ -6099,7 +6101,7 @@
           <p:cNvPr id="6" name="p12-virtual">
             <a:extLst xmlns:a="http://schemas.openxmlformats.org/drawingml/2006/main">
               <a:ext uri="{FF2B5EF4-FFF2-40B4-BE49-F238E27FC236}">
-                <a16:creationId xmlns:a16="http://schemas.microsoft.com/office/drawing/2014/main" id="{EEAC541F-1C9C-4308-BA1C-197D9F0766A7}"/>
+                <a16:creationId xmlns:a16="http://schemas.microsoft.com/office/drawing/2014/main" id="{C6644380-5942-4C2A-8334-58422C2E5C1A}"/>
               </a:ext>
             </a:extLst>
           </p:cNvPr>
@@ -6156,7 +6158,7 @@
           <p:cNvPr id="7" name="p12-question">
             <a:extLst xmlns:a="http://schemas.openxmlformats.org/drawingml/2006/main">
               <a:ext uri="{FF2B5EF4-FFF2-40B4-BE49-F238E27FC236}">
-                <a16:creationId xmlns:a16="http://schemas.microsoft.com/office/drawing/2014/main" id="{090C166A-A0C6-4F8F-8C0A-0AFB67417F8F}"/>
+                <a16:creationId xmlns:a16="http://schemas.microsoft.com/office/drawing/2014/main" id="{46D2D8D0-81D8-46A7-BC87-3076283C7B1E}"/>
               </a:ext>
             </a:extLst>
           </p:cNvPr>
@@ -6211,7 +6213,7 @@
           <p:cNvPr id="8" name="p12-c0">
             <a:extLst xmlns:a="http://schemas.openxmlformats.org/drawingml/2006/main">
               <a:ext uri="{FF2B5EF4-FFF2-40B4-BE49-F238E27FC236}">
-                <a16:creationId xmlns:a16="http://schemas.microsoft.com/office/drawing/2014/main" id="{E8C3D66B-8423-4055-887C-8B305BC4CA4C}"/>
+                <a16:creationId xmlns:a16="http://schemas.microsoft.com/office/drawing/2014/main" id="{67B6689D-7821-418B-BBD5-94A9F11D67EE}"/>
               </a:ext>
             </a:extLst>
           </p:cNvPr>
@@ -6268,7 +6270,7 @@
           <p:cNvPr id="9" name="p12-ct0">
             <a:extLst xmlns:a="http://schemas.openxmlformats.org/drawingml/2006/main">
               <a:ext uri="{FF2B5EF4-FFF2-40B4-BE49-F238E27FC236}">
-                <a16:creationId xmlns:a16="http://schemas.microsoft.com/office/drawing/2014/main" id="{092AF625-EAD9-4A68-BC4D-49BC4A39481B}"/>
+                <a16:creationId xmlns:a16="http://schemas.microsoft.com/office/drawing/2014/main" id="{737CA568-8749-4AE9-B5B0-FEC7A83AF97D}"/>
               </a:ext>
             </a:extLst>
           </p:cNvPr>
@@ -6327,7 +6329,7 @@
           <p:cNvPr id="10" name="p12-c1">
             <a:extLst xmlns:a="http://schemas.openxmlformats.org/drawingml/2006/main">
               <a:ext uri="{FF2B5EF4-FFF2-40B4-BE49-F238E27FC236}">
-                <a16:creationId xmlns:a16="http://schemas.microsoft.com/office/drawing/2014/main" id="{3A0E8755-0F08-47CA-8F22-EE67C610ECC2}"/>
+                <a16:creationId xmlns:a16="http://schemas.microsoft.com/office/drawing/2014/main" id="{1F48A2D0-9C1C-4A37-84F4-45C3FB7B41ED}"/>
               </a:ext>
             </a:extLst>
           </p:cNvPr>
@@ -6384,7 +6386,7 @@
           <p:cNvPr id="11" name="p12-ct1">
             <a:extLst xmlns:a="http://schemas.openxmlformats.org/drawingml/2006/main">
               <a:ext uri="{FF2B5EF4-FFF2-40B4-BE49-F238E27FC236}">
-                <a16:creationId xmlns:a16="http://schemas.microsoft.com/office/drawing/2014/main" id="{E676A2F2-D861-4F05-B4E3-9C89CBD0FA67}"/>
+                <a16:creationId xmlns:a16="http://schemas.microsoft.com/office/drawing/2014/main" id="{A14345DF-3D69-4112-907E-06AA9BCC0D22}"/>
               </a:ext>
             </a:extLst>
           </p:cNvPr>
@@ -6443,7 +6445,7 @@
           <p:cNvPr id="12" name="p12-c2">
             <a:extLst xmlns:a="http://schemas.openxmlformats.org/drawingml/2006/main">
               <a:ext uri="{FF2B5EF4-FFF2-40B4-BE49-F238E27FC236}">
-                <a16:creationId xmlns:a16="http://schemas.microsoft.com/office/drawing/2014/main" id="{CCD46096-690A-44EE-AD4A-552B7BF75342}"/>
+                <a16:creationId xmlns:a16="http://schemas.microsoft.com/office/drawing/2014/main" id="{495BBDA4-6E7C-4420-B5CA-B367F34EE950}"/>
               </a:ext>
             </a:extLst>
           </p:cNvPr>
@@ -6500,7 +6502,7 @@
           <p:cNvPr id="13" name="p12-ct2">
             <a:extLst xmlns:a="http://schemas.openxmlformats.org/drawingml/2006/main">
               <a:ext uri="{FF2B5EF4-FFF2-40B4-BE49-F238E27FC236}">
-                <a16:creationId xmlns:a16="http://schemas.microsoft.com/office/drawing/2014/main" id="{F3C1814C-7B17-4E00-84EC-53760677BB7C}"/>
+                <a16:creationId xmlns:a16="http://schemas.microsoft.com/office/drawing/2014/main" id="{DEC4DB76-6B3E-4898-99CE-FD4552931B03}"/>
               </a:ext>
             </a:extLst>
           </p:cNvPr>
@@ -6559,7 +6561,7 @@
           <p:cNvPr id="14" name="p12-c3">
             <a:extLst xmlns:a="http://schemas.openxmlformats.org/drawingml/2006/main">
               <a:ext uri="{FF2B5EF4-FFF2-40B4-BE49-F238E27FC236}">
-                <a16:creationId xmlns:a16="http://schemas.microsoft.com/office/drawing/2014/main" id="{28217CCF-879A-45CB-9C30-4579E1CB96E6}"/>
+                <a16:creationId xmlns:a16="http://schemas.microsoft.com/office/drawing/2014/main" id="{46782821-188C-4AEF-9DE7-B6A76FE6CD18}"/>
               </a:ext>
             </a:extLst>
           </p:cNvPr>
@@ -6616,7 +6618,7 @@
           <p:cNvPr id="15" name="p12-ct3">
             <a:extLst xmlns:a="http://schemas.openxmlformats.org/drawingml/2006/main">
               <a:ext uri="{FF2B5EF4-FFF2-40B4-BE49-F238E27FC236}">
-                <a16:creationId xmlns:a16="http://schemas.microsoft.com/office/drawing/2014/main" id="{4D4E92C9-42E8-4C80-82EE-777988CCB71E}"/>
+                <a16:creationId xmlns:a16="http://schemas.microsoft.com/office/drawing/2014/main" id="{E7527AEF-0812-4AD2-BA49-C174287C26DF}"/>
               </a:ext>
             </a:extLst>
           </p:cNvPr>
@@ -6675,7 +6677,7 @@
           <p:cNvPr id="16" name="p12-c4">
             <a:extLst xmlns:a="http://schemas.openxmlformats.org/drawingml/2006/main">
               <a:ext uri="{FF2B5EF4-FFF2-40B4-BE49-F238E27FC236}">
-                <a16:creationId xmlns:a16="http://schemas.microsoft.com/office/drawing/2014/main" id="{D432F7B2-8773-4AAB-AA4B-329A211CF1E8}"/>
+                <a16:creationId xmlns:a16="http://schemas.microsoft.com/office/drawing/2014/main" id="{5924D25F-108A-448A-A66D-704E9040EC84}"/>
               </a:ext>
             </a:extLst>
           </p:cNvPr>
@@ -6732,7 +6734,7 @@
           <p:cNvPr id="17" name="p12-ct4">
             <a:extLst xmlns:a="http://schemas.openxmlformats.org/drawingml/2006/main">
               <a:ext uri="{FF2B5EF4-FFF2-40B4-BE49-F238E27FC236}">
-                <a16:creationId xmlns:a16="http://schemas.microsoft.com/office/drawing/2014/main" id="{F8F4530E-DF93-420A-B8C2-180ECF87CBE1}"/>
+                <a16:creationId xmlns:a16="http://schemas.microsoft.com/office/drawing/2014/main" id="{196A192B-885E-4CAF-AFD2-4014C279BA32}"/>
               </a:ext>
             </a:extLst>
           </p:cNvPr>
@@ -6791,7 +6793,7 @@
           <p:cNvPr id="18" name="p12-main-arrow">
             <a:extLst xmlns:a="http://schemas.openxmlformats.org/drawingml/2006/main">
               <a:ext uri="{FF2B5EF4-FFF2-40B4-BE49-F238E27FC236}">
-                <a16:creationId xmlns:a16="http://schemas.microsoft.com/office/drawing/2014/main" id="{5289A1F5-2448-4972-8CD7-145CF8DCF648}"/>
+                <a16:creationId xmlns:a16="http://schemas.microsoft.com/office/drawing/2014/main" id="{D745B93C-39DA-487B-A0E3-93CC795324CD}"/>
               </a:ext>
             </a:extLst>
           </p:cNvPr>
@@ -6844,7 +6846,7 @@
           <p:cNvPr id="19" name="p12-matrix-h-0">
             <a:extLst xmlns:a="http://schemas.openxmlformats.org/drawingml/2006/main">
               <a:ext uri="{FF2B5EF4-FFF2-40B4-BE49-F238E27FC236}">
-                <a16:creationId xmlns:a16="http://schemas.microsoft.com/office/drawing/2014/main" id="{664DFF50-68AB-4C82-8459-07D2C02F8CB4}"/>
+                <a16:creationId xmlns:a16="http://schemas.microsoft.com/office/drawing/2014/main" id="{36BE54C3-92E5-4E34-91A8-E8BE09E1F1B9}"/>
               </a:ext>
             </a:extLst>
           </p:cNvPr>
@@ -6899,7 +6901,7 @@
           <p:cNvPr id="20" name="p12-matrix-h-1">
             <a:extLst xmlns:a="http://schemas.openxmlformats.org/drawingml/2006/main">
               <a:ext uri="{FF2B5EF4-FFF2-40B4-BE49-F238E27FC236}">
-                <a16:creationId xmlns:a16="http://schemas.microsoft.com/office/drawing/2014/main" id="{3B4E3068-2C33-495C-B8A6-27DA9F327360}"/>
+                <a16:creationId xmlns:a16="http://schemas.microsoft.com/office/drawing/2014/main" id="{8CFCADEF-DCA3-43D8-A18F-48E922D24079}"/>
               </a:ext>
             </a:extLst>
           </p:cNvPr>
@@ -6954,7 +6956,7 @@
           <p:cNvPr id="21" name="p12-matrix-h-2">
             <a:extLst xmlns:a="http://schemas.openxmlformats.org/drawingml/2006/main">
               <a:ext uri="{FF2B5EF4-FFF2-40B4-BE49-F238E27FC236}">
-                <a16:creationId xmlns:a16="http://schemas.microsoft.com/office/drawing/2014/main" id="{3CFA7147-EAB8-4957-A13C-101D24BA165C}"/>
+                <a16:creationId xmlns:a16="http://schemas.microsoft.com/office/drawing/2014/main" id="{B13621FA-7CA5-4E30-8366-9A133B5195AB}"/>
               </a:ext>
             </a:extLst>
           </p:cNvPr>
@@ -7009,7 +7011,7 @@
           <p:cNvPr id="22" name="p12-matrix-h-3">
             <a:extLst xmlns:a="http://schemas.openxmlformats.org/drawingml/2006/main">
               <a:ext uri="{FF2B5EF4-FFF2-40B4-BE49-F238E27FC236}">
-                <a16:creationId xmlns:a16="http://schemas.microsoft.com/office/drawing/2014/main" id="{A46F3DCC-87F2-41D4-A591-F785353641C5}"/>
+                <a16:creationId xmlns:a16="http://schemas.microsoft.com/office/drawing/2014/main" id="{CC73CEB1-C05C-4EFA-80A7-AB77D2AE77A4}"/>
               </a:ext>
             </a:extLst>
           </p:cNvPr>
@@ -7064,7 +7066,7 @@
           <p:cNvPr id="23" name="p12-matrix-r0-0">
             <a:extLst xmlns:a="http://schemas.openxmlformats.org/drawingml/2006/main">
               <a:ext uri="{FF2B5EF4-FFF2-40B4-BE49-F238E27FC236}">
-                <a16:creationId xmlns:a16="http://schemas.microsoft.com/office/drawing/2014/main" id="{0C4A9DE9-19EB-42C8-BCC8-A72F3B3B8094}"/>
+                <a16:creationId xmlns:a16="http://schemas.microsoft.com/office/drawing/2014/main" id="{D08F3D9F-1435-4ABD-B468-EEC11660653B}"/>
               </a:ext>
             </a:extLst>
           </p:cNvPr>
@@ -7125,7 +7127,7 @@
           <p:cNvPr id="24" name="p12-matrix-r0-1">
             <a:extLst xmlns:a="http://schemas.openxmlformats.org/drawingml/2006/main">
               <a:ext uri="{FF2B5EF4-FFF2-40B4-BE49-F238E27FC236}">
-                <a16:creationId xmlns:a16="http://schemas.microsoft.com/office/drawing/2014/main" id="{4D9722A4-6F93-4044-85BD-49AD47B0BEA5}"/>
+                <a16:creationId xmlns:a16="http://schemas.microsoft.com/office/drawing/2014/main" id="{F39AFE3B-E446-4C58-B8E1-56484A4C2CA6}"/>
               </a:ext>
             </a:extLst>
           </p:cNvPr>
@@ -7186,7 +7188,7 @@
           <p:cNvPr id="25" name="p12-matrix-r0-2">
             <a:extLst xmlns:a="http://schemas.openxmlformats.org/drawingml/2006/main">
               <a:ext uri="{FF2B5EF4-FFF2-40B4-BE49-F238E27FC236}">
-                <a16:creationId xmlns:a16="http://schemas.microsoft.com/office/drawing/2014/main" id="{857C1593-1F08-4006-82E0-72B28FED2748}"/>
+                <a16:creationId xmlns:a16="http://schemas.microsoft.com/office/drawing/2014/main" id="{27F6339A-BAB8-4D6D-A386-87BED2FE2C56}"/>
               </a:ext>
             </a:extLst>
           </p:cNvPr>
@@ -7247,7 +7249,7 @@
           <p:cNvPr id="26" name="p12-matrix-r0-3">
             <a:extLst xmlns:a="http://schemas.openxmlformats.org/drawingml/2006/main">
               <a:ext uri="{FF2B5EF4-FFF2-40B4-BE49-F238E27FC236}">
-                <a16:creationId xmlns:a16="http://schemas.microsoft.com/office/drawing/2014/main" id="{9AC2A6B4-D508-4E4E-B729-4742682C7D6B}"/>
+                <a16:creationId xmlns:a16="http://schemas.microsoft.com/office/drawing/2014/main" id="{0B1AD25E-4773-49D4-A9E3-63CA4824CB65}"/>
               </a:ext>
             </a:extLst>
           </p:cNvPr>
@@ -7308,7 +7310,7 @@
           <p:cNvPr id="27" name="p12-matrix-r1-0">
             <a:extLst xmlns:a="http://schemas.openxmlformats.org/drawingml/2006/main">
               <a:ext uri="{FF2B5EF4-FFF2-40B4-BE49-F238E27FC236}">
-                <a16:creationId xmlns:a16="http://schemas.microsoft.com/office/drawing/2014/main" id="{EB807128-E52F-4B2E-9C9B-CEC895414F21}"/>
+                <a16:creationId xmlns:a16="http://schemas.microsoft.com/office/drawing/2014/main" id="{09664624-9BC1-4850-BC89-2495F241B3B0}"/>
               </a:ext>
             </a:extLst>
           </p:cNvPr>
@@ -7369,7 +7371,7 @@
           <p:cNvPr id="28" name="p12-matrix-r1-1">
             <a:extLst xmlns:a="http://schemas.openxmlformats.org/drawingml/2006/main">
               <a:ext uri="{FF2B5EF4-FFF2-40B4-BE49-F238E27FC236}">
-                <a16:creationId xmlns:a16="http://schemas.microsoft.com/office/drawing/2014/main" id="{C8B9B1A0-47A4-4A34-A582-6773BDABA54C}"/>
+                <a16:creationId xmlns:a16="http://schemas.microsoft.com/office/drawing/2014/main" id="{2894348F-307D-4673-9084-72ACFA3D8DA0}"/>
               </a:ext>
             </a:extLst>
           </p:cNvPr>
@@ -7430,7 +7432,7 @@
           <p:cNvPr id="29" name="p12-matrix-r1-2">
             <a:extLst xmlns:a="http://schemas.openxmlformats.org/drawingml/2006/main">
               <a:ext uri="{FF2B5EF4-FFF2-40B4-BE49-F238E27FC236}">
-                <a16:creationId xmlns:a16="http://schemas.microsoft.com/office/drawing/2014/main" id="{3B2BB975-9FE8-40C1-84E2-263060109A3C}"/>
+                <a16:creationId xmlns:a16="http://schemas.microsoft.com/office/drawing/2014/main" id="{600AF2E5-41EF-4700-AC40-B24C3ABE8827}"/>
               </a:ext>
             </a:extLst>
           </p:cNvPr>
@@ -7491,7 +7493,7 @@
           <p:cNvPr id="30" name="p12-matrix-r1-3">
             <a:extLst xmlns:a="http://schemas.openxmlformats.org/drawingml/2006/main">
               <a:ext uri="{FF2B5EF4-FFF2-40B4-BE49-F238E27FC236}">
-                <a16:creationId xmlns:a16="http://schemas.microsoft.com/office/drawing/2014/main" id="{6EECB6D7-96C0-4871-9604-B728D2E3E2DB}"/>
+                <a16:creationId xmlns:a16="http://schemas.microsoft.com/office/drawing/2014/main" id="{BE4A315D-5B3B-4EF7-80C3-FE9C603BA151}"/>
               </a:ext>
             </a:extLst>
           </p:cNvPr>
@@ -7552,7 +7554,7 @@
           <p:cNvPr id="31" name="p12-matrix-r2-0">
             <a:extLst xmlns:a="http://schemas.openxmlformats.org/drawingml/2006/main">
               <a:ext uri="{FF2B5EF4-FFF2-40B4-BE49-F238E27FC236}">
-                <a16:creationId xmlns:a16="http://schemas.microsoft.com/office/drawing/2014/main" id="{50F8AA7E-8FC7-4689-B16A-BABB8F214EFD}"/>
+                <a16:creationId xmlns:a16="http://schemas.microsoft.com/office/drawing/2014/main" id="{0CD52309-9649-46C2-BA42-51122DEBAC4A}"/>
               </a:ext>
             </a:extLst>
           </p:cNvPr>
@@ -7613,7 +7615,7 @@
           <p:cNvPr id="32" name="p12-matrix-r2-1">
             <a:extLst xmlns:a="http://schemas.openxmlformats.org/drawingml/2006/main">
               <a:ext uri="{FF2B5EF4-FFF2-40B4-BE49-F238E27FC236}">
-                <a16:creationId xmlns:a16="http://schemas.microsoft.com/office/drawing/2014/main" id="{3F100E86-5CC6-493D-ADE6-5F6203AD5FB1}"/>
+                <a16:creationId xmlns:a16="http://schemas.microsoft.com/office/drawing/2014/main" id="{AC0AF11A-D70C-477A-828C-F06760EB97AD}"/>
               </a:ext>
             </a:extLst>
           </p:cNvPr>
@@ -7674,7 +7676,7 @@
           <p:cNvPr id="33" name="p12-matrix-r2-2">
             <a:extLst xmlns:a="http://schemas.openxmlformats.org/drawingml/2006/main">
               <a:ext uri="{FF2B5EF4-FFF2-40B4-BE49-F238E27FC236}">
-                <a16:creationId xmlns:a16="http://schemas.microsoft.com/office/drawing/2014/main" id="{3E782BAF-5460-4542-90F8-AA8130BE4C39}"/>
+                <a16:creationId xmlns:a16="http://schemas.microsoft.com/office/drawing/2014/main" id="{FA8EF1AF-602E-4C85-A8FB-2357C71E99A2}"/>
               </a:ext>
             </a:extLst>
           </p:cNvPr>
@@ -7735,7 +7737,7 @@
           <p:cNvPr id="34" name="p12-matrix-r2-3">
             <a:extLst xmlns:a="http://schemas.openxmlformats.org/drawingml/2006/main">
               <a:ext uri="{FF2B5EF4-FFF2-40B4-BE49-F238E27FC236}">
-                <a16:creationId xmlns:a16="http://schemas.microsoft.com/office/drawing/2014/main" id="{FFEA9AEF-5BD5-4338-A578-5D8109881CA9}"/>
+                <a16:creationId xmlns:a16="http://schemas.microsoft.com/office/drawing/2014/main" id="{1A86D978-6D07-4957-B873-797999D91524}"/>
               </a:ext>
             </a:extLst>
           </p:cNvPr>
@@ -7796,7 +7798,7 @@
           <p:cNvPr id="35" name="p12-matrix-r3-0">
             <a:extLst xmlns:a="http://schemas.openxmlformats.org/drawingml/2006/main">
               <a:ext uri="{FF2B5EF4-FFF2-40B4-BE49-F238E27FC236}">
-                <a16:creationId xmlns:a16="http://schemas.microsoft.com/office/drawing/2014/main" id="{D4364395-6971-4060-A3C5-530E09468F48}"/>
+                <a16:creationId xmlns:a16="http://schemas.microsoft.com/office/drawing/2014/main" id="{AC6BF59A-B50E-4BDA-A804-8792F2906FE7}"/>
               </a:ext>
             </a:extLst>
           </p:cNvPr>
@@ -7857,7 +7859,7 @@
           <p:cNvPr id="36" name="p12-matrix-r3-1">
             <a:extLst xmlns:a="http://schemas.openxmlformats.org/drawingml/2006/main">
               <a:ext uri="{FF2B5EF4-FFF2-40B4-BE49-F238E27FC236}">
-                <a16:creationId xmlns:a16="http://schemas.microsoft.com/office/drawing/2014/main" id="{2D5519EA-50EE-4431-9777-A311B20B65A9}"/>
+                <a16:creationId xmlns:a16="http://schemas.microsoft.com/office/drawing/2014/main" id="{16EC7D0E-BB61-4A41-B1F6-1DB413E5EA76}"/>
               </a:ext>
             </a:extLst>
           </p:cNvPr>
@@ -7918,7 +7920,7 @@
           <p:cNvPr id="37" name="p12-matrix-r3-2">
             <a:extLst xmlns:a="http://schemas.openxmlformats.org/drawingml/2006/main">
               <a:ext uri="{FF2B5EF4-FFF2-40B4-BE49-F238E27FC236}">
-                <a16:creationId xmlns:a16="http://schemas.microsoft.com/office/drawing/2014/main" id="{A6FC849F-C5A9-4F44-BDB0-125556B61731}"/>
+                <a16:creationId xmlns:a16="http://schemas.microsoft.com/office/drawing/2014/main" id="{F66AF1F8-CAE4-4F34-974F-DDAFE029B140}"/>
               </a:ext>
             </a:extLst>
           </p:cNvPr>
@@ -7979,7 +7981,7 @@
           <p:cNvPr id="38" name="p12-matrix-r3-3">
             <a:extLst xmlns:a="http://schemas.openxmlformats.org/drawingml/2006/main">
               <a:ext uri="{FF2B5EF4-FFF2-40B4-BE49-F238E27FC236}">
-                <a16:creationId xmlns:a16="http://schemas.microsoft.com/office/drawing/2014/main" id="{DF67A42F-F66A-4225-BE8D-8C374B306FC9}"/>
+                <a16:creationId xmlns:a16="http://schemas.microsoft.com/office/drawing/2014/main" id="{BA9FD395-0011-41E4-9175-46A9BF20C516}"/>
               </a:ext>
             </a:extLst>
           </p:cNvPr>
@@ -8040,7 +8042,7 @@
           <p:cNvPr id="39" name="p12-matrix-r4-0">
             <a:extLst xmlns:a="http://schemas.openxmlformats.org/drawingml/2006/main">
               <a:ext uri="{FF2B5EF4-FFF2-40B4-BE49-F238E27FC236}">
-                <a16:creationId xmlns:a16="http://schemas.microsoft.com/office/drawing/2014/main" id="{0F218AE4-FF50-42D5-BB71-40FFEC052E67}"/>
+                <a16:creationId xmlns:a16="http://schemas.microsoft.com/office/drawing/2014/main" id="{98E8D1B6-F5D3-4585-A0C1-BB68AF26193B}"/>
               </a:ext>
             </a:extLst>
           </p:cNvPr>
@@ -8101,7 +8103,7 @@
           <p:cNvPr id="40" name="p12-matrix-r4-1">
             <a:extLst xmlns:a="http://schemas.openxmlformats.org/drawingml/2006/main">
               <a:ext uri="{FF2B5EF4-FFF2-40B4-BE49-F238E27FC236}">
-                <a16:creationId xmlns:a16="http://schemas.microsoft.com/office/drawing/2014/main" id="{FFAB44D4-0A1E-486C-9846-57F18ED7B445}"/>
+                <a16:creationId xmlns:a16="http://schemas.microsoft.com/office/drawing/2014/main" id="{E2351F5A-6C85-4EEB-8A66-7053A1ADC491}"/>
               </a:ext>
             </a:extLst>
           </p:cNvPr>
@@ -8162,7 +8164,7 @@
           <p:cNvPr id="41" name="p12-matrix-r4-2">
             <a:extLst xmlns:a="http://schemas.openxmlformats.org/drawingml/2006/main">
               <a:ext uri="{FF2B5EF4-FFF2-40B4-BE49-F238E27FC236}">
-                <a16:creationId xmlns:a16="http://schemas.microsoft.com/office/drawing/2014/main" id="{F129DD5B-CBA5-4AED-946A-AE1298FC6F61}"/>
+                <a16:creationId xmlns:a16="http://schemas.microsoft.com/office/drawing/2014/main" id="{BA167911-36A8-4AB2-B92A-E1E064D79AC3}"/>
               </a:ext>
             </a:extLst>
           </p:cNvPr>
@@ -8223,7 +8225,7 @@
           <p:cNvPr id="42" name="p12-matrix-r4-3">
             <a:extLst xmlns:a="http://schemas.openxmlformats.org/drawingml/2006/main">
               <a:ext uri="{FF2B5EF4-FFF2-40B4-BE49-F238E27FC236}">
-                <a16:creationId xmlns:a16="http://schemas.microsoft.com/office/drawing/2014/main" id="{20EB84EE-5E87-4F08-83A5-2C7FBDC47855}"/>
+                <a16:creationId xmlns:a16="http://schemas.microsoft.com/office/drawing/2014/main" id="{2FBABA6F-BDA1-4474-9722-EF3157A84E6A}"/>
               </a:ext>
             </a:extLst>
           </p:cNvPr>
@@ -8337,7 +8339,7 @@
                 <a:ea typeface="Microsoft YaHei"/>
                 <a:cs typeface="Microsoft YaHei"/>
               </a:rPr>
-              <a:t>演示：矩阵进入证据地图与空白检验</a:t>
+              <a:t>演示：矩阵 → 证据地图 → 空白候选 → 三步检验</a:t>
             </a:r>
             <a:endParaRPr/>
           </a:p>
@@ -8376,7 +8378,7 @@
           <p:cNvPr id="6" name="p13-virtual">
             <a:extLst xmlns:a="http://schemas.openxmlformats.org/drawingml/2006/main">
               <a:ext uri="{FF2B5EF4-FFF2-40B4-BE49-F238E27FC236}">
-                <a16:creationId xmlns:a16="http://schemas.microsoft.com/office/drawing/2014/main" id="{160527B6-CC2D-4A7D-9164-9DBDA1F696A9}"/>
+                <a16:creationId xmlns:a16="http://schemas.microsoft.com/office/drawing/2014/main" id="{2A2910CD-4285-4A41-9120-E720167355CD}"/>
               </a:ext>
             </a:extLst>
           </p:cNvPr>
@@ -8433,7 +8435,7 @@
           <p:cNvPr id="7" name="p13-map-h-0">
             <a:extLst xmlns:a="http://schemas.openxmlformats.org/drawingml/2006/main">
               <a:ext uri="{FF2B5EF4-FFF2-40B4-BE49-F238E27FC236}">
-                <a16:creationId xmlns:a16="http://schemas.microsoft.com/office/drawing/2014/main" id="{E8C611F8-CAD5-48E2-8F40-2BA9C4892597}"/>
+                <a16:creationId xmlns:a16="http://schemas.microsoft.com/office/drawing/2014/main" id="{624B32ED-D0EC-49B8-91B1-3E66F156C821}"/>
               </a:ext>
             </a:extLst>
           </p:cNvPr>
@@ -8488,7 +8490,7 @@
           <p:cNvPr id="8" name="p13-map-h-1">
             <a:extLst xmlns:a="http://schemas.openxmlformats.org/drawingml/2006/main">
               <a:ext uri="{FF2B5EF4-FFF2-40B4-BE49-F238E27FC236}">
-                <a16:creationId xmlns:a16="http://schemas.microsoft.com/office/drawing/2014/main" id="{B51114D1-49E2-4C77-A023-6E2E76995F97}"/>
+                <a16:creationId xmlns:a16="http://schemas.microsoft.com/office/drawing/2014/main" id="{479062D6-BDF7-4CE6-B07B-CBE61B049672}"/>
               </a:ext>
             </a:extLst>
           </p:cNvPr>
@@ -8543,7 +8545,7 @@
           <p:cNvPr id="9" name="p13-map-h-2">
             <a:extLst xmlns:a="http://schemas.openxmlformats.org/drawingml/2006/main">
               <a:ext uri="{FF2B5EF4-FFF2-40B4-BE49-F238E27FC236}">
-                <a16:creationId xmlns:a16="http://schemas.microsoft.com/office/drawing/2014/main" id="{53924E46-2AAF-4EE6-BE91-07A77FC433EC}"/>
+                <a16:creationId xmlns:a16="http://schemas.microsoft.com/office/drawing/2014/main" id="{D08DF1AC-F13E-4D5B-B8BD-18738F98BB82}"/>
               </a:ext>
             </a:extLst>
           </p:cNvPr>
@@ -8598,7 +8600,7 @@
           <p:cNvPr id="10" name="p13-map-h-3">
             <a:extLst xmlns:a="http://schemas.openxmlformats.org/drawingml/2006/main">
               <a:ext uri="{FF2B5EF4-FFF2-40B4-BE49-F238E27FC236}">
-                <a16:creationId xmlns:a16="http://schemas.microsoft.com/office/drawing/2014/main" id="{A963B963-3C20-4B63-8378-3AB3FF3D5422}"/>
+                <a16:creationId xmlns:a16="http://schemas.microsoft.com/office/drawing/2014/main" id="{5FF07736-B986-4930-9C7E-C53EB861855F}"/>
               </a:ext>
             </a:extLst>
           </p:cNvPr>
@@ -8653,7 +8655,7 @@
           <p:cNvPr id="11" name="p13-map-r0-0">
             <a:extLst xmlns:a="http://schemas.openxmlformats.org/drawingml/2006/main">
               <a:ext uri="{FF2B5EF4-FFF2-40B4-BE49-F238E27FC236}">
-                <a16:creationId xmlns:a16="http://schemas.microsoft.com/office/drawing/2014/main" id="{5C6568F4-899F-4018-9962-C0F2AC5BAC50}"/>
+                <a16:creationId xmlns:a16="http://schemas.microsoft.com/office/drawing/2014/main" id="{3F89699B-7A2C-4B91-A91B-A724A6AB07F8}"/>
               </a:ext>
             </a:extLst>
           </p:cNvPr>
@@ -8714,7 +8716,7 @@
           <p:cNvPr id="12" name="p13-map-r0-1">
             <a:extLst xmlns:a="http://schemas.openxmlformats.org/drawingml/2006/main">
               <a:ext uri="{FF2B5EF4-FFF2-40B4-BE49-F238E27FC236}">
-                <a16:creationId xmlns:a16="http://schemas.microsoft.com/office/drawing/2014/main" id="{DBFB566B-4DA4-400F-B657-393D0458A0AE}"/>
+                <a16:creationId xmlns:a16="http://schemas.microsoft.com/office/drawing/2014/main" id="{48FC27D5-C37B-4109-BBC8-5C41A53F5770}"/>
               </a:ext>
             </a:extLst>
           </p:cNvPr>
@@ -8775,7 +8777,7 @@
           <p:cNvPr id="13" name="p13-map-r0-2">
             <a:extLst xmlns:a="http://schemas.openxmlformats.org/drawingml/2006/main">
               <a:ext uri="{FF2B5EF4-FFF2-40B4-BE49-F238E27FC236}">
-                <a16:creationId xmlns:a16="http://schemas.microsoft.com/office/drawing/2014/main" id="{A6DBC55C-2907-4493-BDC4-43FC0C03719D}"/>
+                <a16:creationId xmlns:a16="http://schemas.microsoft.com/office/drawing/2014/main" id="{512BF2B2-F701-4AA1-89BF-54A1FE20CC61}"/>
               </a:ext>
             </a:extLst>
           </p:cNvPr>
@@ -8836,7 +8838,7 @@
           <p:cNvPr id="14" name="p13-map-r0-3">
             <a:extLst xmlns:a="http://schemas.openxmlformats.org/drawingml/2006/main">
               <a:ext uri="{FF2B5EF4-FFF2-40B4-BE49-F238E27FC236}">
-                <a16:creationId xmlns:a16="http://schemas.microsoft.com/office/drawing/2014/main" id="{922BC721-A35A-4EE1-B6DB-CBEC5B7E597D}"/>
+                <a16:creationId xmlns:a16="http://schemas.microsoft.com/office/drawing/2014/main" id="{2EF5DB17-261D-47B3-9AD3-043780331EAD}"/>
               </a:ext>
             </a:extLst>
           </p:cNvPr>
@@ -8897,7 +8899,7 @@
           <p:cNvPr id="15" name="p13-map-r1-0">
             <a:extLst xmlns:a="http://schemas.openxmlformats.org/drawingml/2006/main">
               <a:ext uri="{FF2B5EF4-FFF2-40B4-BE49-F238E27FC236}">
-                <a16:creationId xmlns:a16="http://schemas.microsoft.com/office/drawing/2014/main" id="{D8224D02-3CAB-4419-BE4B-03DC9951D4DB}"/>
+                <a16:creationId xmlns:a16="http://schemas.microsoft.com/office/drawing/2014/main" id="{774BDBD5-D2F2-4172-8274-4FD18B18F107}"/>
               </a:ext>
             </a:extLst>
           </p:cNvPr>
@@ -8958,7 +8960,7 @@
           <p:cNvPr id="16" name="p13-map-r1-1">
             <a:extLst xmlns:a="http://schemas.openxmlformats.org/drawingml/2006/main">
               <a:ext uri="{FF2B5EF4-FFF2-40B4-BE49-F238E27FC236}">
-                <a16:creationId xmlns:a16="http://schemas.microsoft.com/office/drawing/2014/main" id="{7310F25F-1AD8-444E-9FBD-76AE56170F60}"/>
+                <a16:creationId xmlns:a16="http://schemas.microsoft.com/office/drawing/2014/main" id="{C9ADF08E-A1F2-46F6-98E4-439C435F95AE}"/>
               </a:ext>
             </a:extLst>
           </p:cNvPr>
@@ -9019,7 +9021,7 @@
           <p:cNvPr id="17" name="p13-map-r1-2">
             <a:extLst xmlns:a="http://schemas.openxmlformats.org/drawingml/2006/main">
               <a:ext uri="{FF2B5EF4-FFF2-40B4-BE49-F238E27FC236}">
-                <a16:creationId xmlns:a16="http://schemas.microsoft.com/office/drawing/2014/main" id="{7A8196C5-D25A-4A89-BFC3-6403449E2126}"/>
+                <a16:creationId xmlns:a16="http://schemas.microsoft.com/office/drawing/2014/main" id="{33FE2F92-6369-412B-BC2D-C22D0547EAF0}"/>
               </a:ext>
             </a:extLst>
           </p:cNvPr>
@@ -9080,7 +9082,7 @@
           <p:cNvPr id="18" name="p13-map-r1-3">
             <a:extLst xmlns:a="http://schemas.openxmlformats.org/drawingml/2006/main">
               <a:ext uri="{FF2B5EF4-FFF2-40B4-BE49-F238E27FC236}">
-                <a16:creationId xmlns:a16="http://schemas.microsoft.com/office/drawing/2014/main" id="{DB91061E-EF0F-4ADA-B8FF-DBC25AEBB585}"/>
+                <a16:creationId xmlns:a16="http://schemas.microsoft.com/office/drawing/2014/main" id="{649E747D-D550-4E74-B659-D7DAF1485814}"/>
               </a:ext>
             </a:extLst>
           </p:cNvPr>
@@ -9141,7 +9143,7 @@
           <p:cNvPr id="19" name="p13-map-r2-0">
             <a:extLst xmlns:a="http://schemas.openxmlformats.org/drawingml/2006/main">
               <a:ext uri="{FF2B5EF4-FFF2-40B4-BE49-F238E27FC236}">
-                <a16:creationId xmlns:a16="http://schemas.microsoft.com/office/drawing/2014/main" id="{FF2A5EB7-76E3-4037-83A6-FAA148D41969}"/>
+                <a16:creationId xmlns:a16="http://schemas.microsoft.com/office/drawing/2014/main" id="{4939ADA0-E5EA-4C4C-AA78-BCB691601CA4}"/>
               </a:ext>
             </a:extLst>
           </p:cNvPr>
@@ -9202,7 +9204,7 @@
           <p:cNvPr id="20" name="p13-map-r2-1">
             <a:extLst xmlns:a="http://schemas.openxmlformats.org/drawingml/2006/main">
               <a:ext uri="{FF2B5EF4-FFF2-40B4-BE49-F238E27FC236}">
-                <a16:creationId xmlns:a16="http://schemas.microsoft.com/office/drawing/2014/main" id="{D8B622AD-CBB9-4AAE-8031-48624ED0B29E}"/>
+                <a16:creationId xmlns:a16="http://schemas.microsoft.com/office/drawing/2014/main" id="{E4344845-6282-4DEC-88D1-B404022BC08C}"/>
               </a:ext>
             </a:extLst>
           </p:cNvPr>
@@ -9263,7 +9265,7 @@
           <p:cNvPr id="21" name="p13-map-r2-2">
             <a:extLst xmlns:a="http://schemas.openxmlformats.org/drawingml/2006/main">
               <a:ext uri="{FF2B5EF4-FFF2-40B4-BE49-F238E27FC236}">
-                <a16:creationId xmlns:a16="http://schemas.microsoft.com/office/drawing/2014/main" id="{C22B790C-6029-462D-BE18-B3B65C49DF77}"/>
+                <a16:creationId xmlns:a16="http://schemas.microsoft.com/office/drawing/2014/main" id="{8FD6B4E0-28B5-4244-980D-7936CAEEC6C6}"/>
               </a:ext>
             </a:extLst>
           </p:cNvPr>
@@ -9324,7 +9326,7 @@
           <p:cNvPr id="22" name="p13-map-r2-3">
             <a:extLst xmlns:a="http://schemas.openxmlformats.org/drawingml/2006/main">
               <a:ext uri="{FF2B5EF4-FFF2-40B4-BE49-F238E27FC236}">
-                <a16:creationId xmlns:a16="http://schemas.microsoft.com/office/drawing/2014/main" id="{54FC522B-630D-439B-BAA7-0EC50A443F35}"/>
+                <a16:creationId xmlns:a16="http://schemas.microsoft.com/office/drawing/2014/main" id="{5220C8D9-538C-4470-8FBD-6E05AF1BDCA5}"/>
               </a:ext>
             </a:extLst>
           </p:cNvPr>
@@ -9385,7 +9387,7 @@
           <p:cNvPr id="23" name="p13-map-r3-0">
             <a:extLst xmlns:a="http://schemas.openxmlformats.org/drawingml/2006/main">
               <a:ext uri="{FF2B5EF4-FFF2-40B4-BE49-F238E27FC236}">
-                <a16:creationId xmlns:a16="http://schemas.microsoft.com/office/drawing/2014/main" id="{C07BD114-3E63-46A2-96EB-45E1D60E8BEB}"/>
+                <a16:creationId xmlns:a16="http://schemas.microsoft.com/office/drawing/2014/main" id="{E9F1FC38-BF70-4A53-B6C9-5B3A27C4E42D}"/>
               </a:ext>
             </a:extLst>
           </p:cNvPr>
@@ -9446,7 +9448,7 @@
           <p:cNvPr id="24" name="p13-map-r3-1">
             <a:extLst xmlns:a="http://schemas.openxmlformats.org/drawingml/2006/main">
               <a:ext uri="{FF2B5EF4-FFF2-40B4-BE49-F238E27FC236}">
-                <a16:creationId xmlns:a16="http://schemas.microsoft.com/office/drawing/2014/main" id="{D2C14ABD-6A33-49F5-AD2B-9E9BDBFAEEC6}"/>
+                <a16:creationId xmlns:a16="http://schemas.microsoft.com/office/drawing/2014/main" id="{C5E34B8D-2B3D-46CB-92AA-FD1ADB569DAF}"/>
               </a:ext>
             </a:extLst>
           </p:cNvPr>
@@ -9507,7 +9509,7 @@
           <p:cNvPr id="25" name="p13-map-r3-2">
             <a:extLst xmlns:a="http://schemas.openxmlformats.org/drawingml/2006/main">
               <a:ext uri="{FF2B5EF4-FFF2-40B4-BE49-F238E27FC236}">
-                <a16:creationId xmlns:a16="http://schemas.microsoft.com/office/drawing/2014/main" id="{A8F54DA4-E47D-4135-BE7F-06A635457BD1}"/>
+                <a16:creationId xmlns:a16="http://schemas.microsoft.com/office/drawing/2014/main" id="{53DA6A2D-1AB6-426B-A258-C6AE95795F3F}"/>
               </a:ext>
             </a:extLst>
           </p:cNvPr>
@@ -9568,7 +9570,7 @@
           <p:cNvPr id="26" name="p13-map-r3-3">
             <a:extLst xmlns:a="http://schemas.openxmlformats.org/drawingml/2006/main">
               <a:ext uri="{FF2B5EF4-FFF2-40B4-BE49-F238E27FC236}">
-                <a16:creationId xmlns:a16="http://schemas.microsoft.com/office/drawing/2014/main" id="{E7C17E4D-FF45-43B6-9170-49CBD4938520}"/>
+                <a16:creationId xmlns:a16="http://schemas.microsoft.com/office/drawing/2014/main" id="{060B1955-CE4A-47DD-BA2A-546793547D84}"/>
               </a:ext>
             </a:extLst>
           </p:cNvPr>
@@ -9629,7 +9631,7 @@
           <p:cNvPr id="27" name="p13-map-r4-0">
             <a:extLst xmlns:a="http://schemas.openxmlformats.org/drawingml/2006/main">
               <a:ext uri="{FF2B5EF4-FFF2-40B4-BE49-F238E27FC236}">
-                <a16:creationId xmlns:a16="http://schemas.microsoft.com/office/drawing/2014/main" id="{DC347340-58E9-4802-997B-FDD4D2332BE1}"/>
+                <a16:creationId xmlns:a16="http://schemas.microsoft.com/office/drawing/2014/main" id="{3F1FB14E-D972-414A-A810-0299068840A9}"/>
               </a:ext>
             </a:extLst>
           </p:cNvPr>
@@ -9690,7 +9692,7 @@
           <p:cNvPr id="28" name="p13-map-r4-1">
             <a:extLst xmlns:a="http://schemas.openxmlformats.org/drawingml/2006/main">
               <a:ext uri="{FF2B5EF4-FFF2-40B4-BE49-F238E27FC236}">
-                <a16:creationId xmlns:a16="http://schemas.microsoft.com/office/drawing/2014/main" id="{FF067924-39F4-4F45-B1BF-A6DCE3BDA21E}"/>
+                <a16:creationId xmlns:a16="http://schemas.microsoft.com/office/drawing/2014/main" id="{AB60F33E-4568-479B-9C76-14935CF12C66}"/>
               </a:ext>
             </a:extLst>
           </p:cNvPr>
@@ -9751,7 +9753,7 @@
           <p:cNvPr id="29" name="p13-map-r4-2">
             <a:extLst xmlns:a="http://schemas.openxmlformats.org/drawingml/2006/main">
               <a:ext uri="{FF2B5EF4-FFF2-40B4-BE49-F238E27FC236}">
-                <a16:creationId xmlns:a16="http://schemas.microsoft.com/office/drawing/2014/main" id="{16B40E07-8AD6-49F6-BAAF-F1F57026009B}"/>
+                <a16:creationId xmlns:a16="http://schemas.microsoft.com/office/drawing/2014/main" id="{EB0A085D-ADAD-4C87-881F-1817B3831FDD}"/>
               </a:ext>
             </a:extLst>
           </p:cNvPr>
@@ -9812,7 +9814,7 @@
           <p:cNvPr id="30" name="p13-map-r4-3">
             <a:extLst xmlns:a="http://schemas.openxmlformats.org/drawingml/2006/main">
               <a:ext uri="{FF2B5EF4-FFF2-40B4-BE49-F238E27FC236}">
-                <a16:creationId xmlns:a16="http://schemas.microsoft.com/office/drawing/2014/main" id="{D9512A28-8DB9-4099-9549-5816CA7F50BA}"/>
+                <a16:creationId xmlns:a16="http://schemas.microsoft.com/office/drawing/2014/main" id="{91EB78D4-6719-46E5-B0FF-D83E8FC86A77}"/>
               </a:ext>
             </a:extLst>
           </p:cNvPr>
@@ -9873,7 +9875,7 @@
           <p:cNvPr id="31" name="p13-th0">
             <a:extLst xmlns:a="http://schemas.openxmlformats.org/drawingml/2006/main">
               <a:ext uri="{FF2B5EF4-FFF2-40B4-BE49-F238E27FC236}">
-                <a16:creationId xmlns:a16="http://schemas.microsoft.com/office/drawing/2014/main" id="{612647E9-1500-49D2-9558-06CD126D6677}"/>
+                <a16:creationId xmlns:a16="http://schemas.microsoft.com/office/drawing/2014/main" id="{984383DA-9125-41BB-89EE-9798D103FB6E}"/>
               </a:ext>
             </a:extLst>
           </p:cNvPr>
@@ -9930,7 +9932,7 @@
           <p:cNvPr id="32" name="p13-td0">
             <a:extLst xmlns:a="http://schemas.openxmlformats.org/drawingml/2006/main">
               <a:ext uri="{FF2B5EF4-FFF2-40B4-BE49-F238E27FC236}">
-                <a16:creationId xmlns:a16="http://schemas.microsoft.com/office/drawing/2014/main" id="{FEB23A42-F4F9-4216-9E31-CB06687FAD7C}"/>
+                <a16:creationId xmlns:a16="http://schemas.microsoft.com/office/drawing/2014/main" id="{1AFEDC62-B7BB-4B6D-BBE4-21FFA53E7C97}"/>
               </a:ext>
             </a:extLst>
           </p:cNvPr>
@@ -9989,7 +9991,7 @@
           <p:cNvPr id="33" name="p13-th1">
             <a:extLst xmlns:a="http://schemas.openxmlformats.org/drawingml/2006/main">
               <a:ext uri="{FF2B5EF4-FFF2-40B4-BE49-F238E27FC236}">
-                <a16:creationId xmlns:a16="http://schemas.microsoft.com/office/drawing/2014/main" id="{C2D5859F-43FE-4868-919B-DA17BCD73C59}"/>
+                <a16:creationId xmlns:a16="http://schemas.microsoft.com/office/drawing/2014/main" id="{0C0D5551-9E39-4FEE-A7FF-641E8A595620}"/>
               </a:ext>
             </a:extLst>
           </p:cNvPr>
@@ -10046,7 +10048,7 @@
           <p:cNvPr id="34" name="p13-td1">
             <a:extLst xmlns:a="http://schemas.openxmlformats.org/drawingml/2006/main">
               <a:ext uri="{FF2B5EF4-FFF2-40B4-BE49-F238E27FC236}">
-                <a16:creationId xmlns:a16="http://schemas.microsoft.com/office/drawing/2014/main" id="{35D8E4E5-55FA-45DE-9140-72A77CF7D8E9}"/>
+                <a16:creationId xmlns:a16="http://schemas.microsoft.com/office/drawing/2014/main" id="{66EA804E-22FC-4484-B6CC-AC68C0BF16FF}"/>
               </a:ext>
             </a:extLst>
           </p:cNvPr>
@@ -10105,7 +10107,7 @@
           <p:cNvPr id="35" name="p13-th2">
             <a:extLst xmlns:a="http://schemas.openxmlformats.org/drawingml/2006/main">
               <a:ext uri="{FF2B5EF4-FFF2-40B4-BE49-F238E27FC236}">
-                <a16:creationId xmlns:a16="http://schemas.microsoft.com/office/drawing/2014/main" id="{45B62999-C016-4B8E-A74A-F39FFE67C6C3}"/>
+                <a16:creationId xmlns:a16="http://schemas.microsoft.com/office/drawing/2014/main" id="{CCDD1EE1-71D9-426F-805F-46D7159D2216}"/>
               </a:ext>
             </a:extLst>
           </p:cNvPr>
@@ -10162,7 +10164,7 @@
           <p:cNvPr id="36" name="p13-td2">
             <a:extLst xmlns:a="http://schemas.openxmlformats.org/drawingml/2006/main">
               <a:ext uri="{FF2B5EF4-FFF2-40B4-BE49-F238E27FC236}">
-                <a16:creationId xmlns:a16="http://schemas.microsoft.com/office/drawing/2014/main" id="{53A313A1-4FBA-41B9-958D-0867E1410559}"/>
+                <a16:creationId xmlns:a16="http://schemas.microsoft.com/office/drawing/2014/main" id="{1F000FF6-6168-4E51-9572-471C0EC64CE4}"/>
               </a:ext>
             </a:extLst>
           </p:cNvPr>
@@ -10221,7 +10223,7 @@
           <p:cNvPr id="37" name="p13-warning">
             <a:extLst xmlns:a="http://schemas.openxmlformats.org/drawingml/2006/main">
               <a:ext uri="{FF2B5EF4-FFF2-40B4-BE49-F238E27FC236}">
-                <a16:creationId xmlns:a16="http://schemas.microsoft.com/office/drawing/2014/main" id="{9208E8A0-FEC2-49A9-AA7D-DCF8CDB472FF}"/>
+                <a16:creationId xmlns:a16="http://schemas.microsoft.com/office/drawing/2014/main" id="{2FFC814E-FBC7-4CA4-9A64-902FCEBF15F0}"/>
               </a:ext>
             </a:extLst>
           </p:cNvPr>
@@ -10366,7 +10368,7 @@
           <p:cNvPr id="6" name="p14-virtual">
             <a:extLst xmlns:a="http://schemas.openxmlformats.org/drawingml/2006/main">
               <a:ext uri="{FF2B5EF4-FFF2-40B4-BE49-F238E27FC236}">
-                <a16:creationId xmlns:a16="http://schemas.microsoft.com/office/drawing/2014/main" id="{70171A13-2AB3-40C6-9EF8-E296D6F4B2F3}"/>
+                <a16:creationId xmlns:a16="http://schemas.microsoft.com/office/drawing/2014/main" id="{35F04BCC-D6AC-468B-B8E3-C22FC5A4056D}"/>
               </a:ext>
             </a:extLst>
           </p:cNvPr>
@@ -10423,7 +10425,7 @@
           <p:cNvPr id="7" name="p14-bad">
             <a:extLst xmlns:a="http://schemas.openxmlformats.org/drawingml/2006/main">
               <a:ext uri="{FF2B5EF4-FFF2-40B4-BE49-F238E27FC236}">
-                <a16:creationId xmlns:a16="http://schemas.microsoft.com/office/drawing/2014/main" id="{026AD720-4222-4D6D-B8E7-863427677F0B}"/>
+                <a16:creationId xmlns:a16="http://schemas.microsoft.com/office/drawing/2014/main" id="{6F9BDF22-B17A-4ACF-A346-7E1D565E02BA}"/>
               </a:ext>
             </a:extLst>
           </p:cNvPr>
@@ -10482,7 +10484,7 @@
           <p:cNvPr id="8" name="p14-ah0">
             <a:extLst xmlns:a="http://schemas.openxmlformats.org/drawingml/2006/main">
               <a:ext uri="{FF2B5EF4-FFF2-40B4-BE49-F238E27FC236}">
-                <a16:creationId xmlns:a16="http://schemas.microsoft.com/office/drawing/2014/main" id="{EDF030E7-3334-4E3F-A355-282EBA343F79}"/>
+                <a16:creationId xmlns:a16="http://schemas.microsoft.com/office/drawing/2014/main" id="{5AE8F1CA-6AF0-4729-96AB-44509C870318}"/>
               </a:ext>
             </a:extLst>
           </p:cNvPr>
@@ -10539,7 +10541,7 @@
           <p:cNvPr id="9" name="p14-ad0">
             <a:extLst xmlns:a="http://schemas.openxmlformats.org/drawingml/2006/main">
               <a:ext uri="{FF2B5EF4-FFF2-40B4-BE49-F238E27FC236}">
-                <a16:creationId xmlns:a16="http://schemas.microsoft.com/office/drawing/2014/main" id="{E933432E-0C3F-49A3-9252-B3D4A9CB23F7}"/>
+                <a16:creationId xmlns:a16="http://schemas.microsoft.com/office/drawing/2014/main" id="{04D37297-BBF2-479A-848E-C64CFDBBA082}"/>
               </a:ext>
             </a:extLst>
           </p:cNvPr>
@@ -10598,7 +10600,7 @@
           <p:cNvPr id="10" name="p14-ah1">
             <a:extLst xmlns:a="http://schemas.openxmlformats.org/drawingml/2006/main">
               <a:ext uri="{FF2B5EF4-FFF2-40B4-BE49-F238E27FC236}">
-                <a16:creationId xmlns:a16="http://schemas.microsoft.com/office/drawing/2014/main" id="{6BE3C36F-C47A-4E08-A268-82F74316358F}"/>
+                <a16:creationId xmlns:a16="http://schemas.microsoft.com/office/drawing/2014/main" id="{2641AC77-DD58-4C6C-8B8E-6688B80EA1F0}"/>
               </a:ext>
             </a:extLst>
           </p:cNvPr>
@@ -10655,7 +10657,7 @@
           <p:cNvPr id="11" name="p14-ad1">
             <a:extLst xmlns:a="http://schemas.openxmlformats.org/drawingml/2006/main">
               <a:ext uri="{FF2B5EF4-FFF2-40B4-BE49-F238E27FC236}">
-                <a16:creationId xmlns:a16="http://schemas.microsoft.com/office/drawing/2014/main" id="{C16C95D9-FDB5-4A7E-A695-38F76113DFF7}"/>
+                <a16:creationId xmlns:a16="http://schemas.microsoft.com/office/drawing/2014/main" id="{274AEAFA-0357-4C74-B176-C351D2D0B650}"/>
               </a:ext>
             </a:extLst>
           </p:cNvPr>
@@ -10714,7 +10716,7 @@
           <p:cNvPr id="12" name="p14-ah2">
             <a:extLst xmlns:a="http://schemas.openxmlformats.org/drawingml/2006/main">
               <a:ext uri="{FF2B5EF4-FFF2-40B4-BE49-F238E27FC236}">
-                <a16:creationId xmlns:a16="http://schemas.microsoft.com/office/drawing/2014/main" id="{B009C5D3-532F-43B9-B8A8-49950D43A1F3}"/>
+                <a16:creationId xmlns:a16="http://schemas.microsoft.com/office/drawing/2014/main" id="{5DD2532C-03A4-42A8-9D7B-D30C00EF260D}"/>
               </a:ext>
             </a:extLst>
           </p:cNvPr>
@@ -10771,7 +10773,7 @@
           <p:cNvPr id="13" name="p14-ad2">
             <a:extLst xmlns:a="http://schemas.openxmlformats.org/drawingml/2006/main">
               <a:ext uri="{FF2B5EF4-FFF2-40B4-BE49-F238E27FC236}">
-                <a16:creationId xmlns:a16="http://schemas.microsoft.com/office/drawing/2014/main" id="{38F4E77B-6A43-4987-8515-2FB152B3A7C5}"/>
+                <a16:creationId xmlns:a16="http://schemas.microsoft.com/office/drawing/2014/main" id="{22DE6979-CBB3-4AF9-95E1-4F1F3A477029}"/>
               </a:ext>
             </a:extLst>
           </p:cNvPr>
@@ -10830,7 +10832,7 @@
           <p:cNvPr id="14" name="p14-ah3">
             <a:extLst xmlns:a="http://schemas.openxmlformats.org/drawingml/2006/main">
               <a:ext uri="{FF2B5EF4-FFF2-40B4-BE49-F238E27FC236}">
-                <a16:creationId xmlns:a16="http://schemas.microsoft.com/office/drawing/2014/main" id="{1CE22E6D-4AD9-43F6-9A8D-0A2786AA2CA3}"/>
+                <a16:creationId xmlns:a16="http://schemas.microsoft.com/office/drawing/2014/main" id="{67AE617E-34ED-4BD5-AD6D-F36F60DFFA20}"/>
               </a:ext>
             </a:extLst>
           </p:cNvPr>
@@ -10887,7 +10889,7 @@
           <p:cNvPr id="15" name="p14-ad3">
             <a:extLst xmlns:a="http://schemas.openxmlformats.org/drawingml/2006/main">
               <a:ext uri="{FF2B5EF4-FFF2-40B4-BE49-F238E27FC236}">
-                <a16:creationId xmlns:a16="http://schemas.microsoft.com/office/drawing/2014/main" id="{42AFD60A-708F-491D-95CA-9E6DE8057558}"/>
+                <a16:creationId xmlns:a16="http://schemas.microsoft.com/office/drawing/2014/main" id="{E5E12F25-8AA1-4707-B7FA-AD0381FB6070}"/>
               </a:ext>
             </a:extLst>
           </p:cNvPr>
@@ -10946,7 +10948,7 @@
           <p:cNvPr id="16" name="p14-label">
             <a:extLst xmlns:a="http://schemas.openxmlformats.org/drawingml/2006/main">
               <a:ext uri="{FF2B5EF4-FFF2-40B4-BE49-F238E27FC236}">
-                <a16:creationId xmlns:a16="http://schemas.microsoft.com/office/drawing/2014/main" id="{0494C4FF-CFE9-436A-B1A3-C422CF65CAA2}"/>
+                <a16:creationId xmlns:a16="http://schemas.microsoft.com/office/drawing/2014/main" id="{A4634ACB-E35E-4724-8CE0-765463D9AC98}"/>
               </a:ext>
             </a:extLst>
           </p:cNvPr>
@@ -11001,7 +11003,7 @@
           <p:cNvPr id="17" name="p14-s0">
             <a:extLst xmlns:a="http://schemas.openxmlformats.org/drawingml/2006/main">
               <a:ext uri="{FF2B5EF4-FFF2-40B4-BE49-F238E27FC236}">
-                <a16:creationId xmlns:a16="http://schemas.microsoft.com/office/drawing/2014/main" id="{20A574B3-B01D-49F6-9C6E-F54748129591}"/>
+                <a16:creationId xmlns:a16="http://schemas.microsoft.com/office/drawing/2014/main" id="{F6889F87-6760-425A-A9F5-529FDC09D747}"/>
               </a:ext>
             </a:extLst>
           </p:cNvPr>
@@ -11060,7 +11062,7 @@
           <p:cNvPr id="18" name="p14-s1">
             <a:extLst xmlns:a="http://schemas.openxmlformats.org/drawingml/2006/main">
               <a:ext uri="{FF2B5EF4-FFF2-40B4-BE49-F238E27FC236}">
-                <a16:creationId xmlns:a16="http://schemas.microsoft.com/office/drawing/2014/main" id="{F83F3B11-494F-4ECA-BBA0-59F10ABE1838}"/>
+                <a16:creationId xmlns:a16="http://schemas.microsoft.com/office/drawing/2014/main" id="{3527489B-454F-434D-9EDF-472E251ACF83}"/>
               </a:ext>
             </a:extLst>
           </p:cNvPr>
@@ -11119,7 +11121,7 @@
           <p:cNvPr id="19" name="p14-s2">
             <a:extLst xmlns:a="http://schemas.openxmlformats.org/drawingml/2006/main">
               <a:ext uri="{FF2B5EF4-FFF2-40B4-BE49-F238E27FC236}">
-                <a16:creationId xmlns:a16="http://schemas.microsoft.com/office/drawing/2014/main" id="{135BD67B-898B-40D3-B854-2B72E32CD263}"/>
+                <a16:creationId xmlns:a16="http://schemas.microsoft.com/office/drawing/2014/main" id="{C29433FA-3939-40C7-ACEE-946B8A0A96EC}"/>
               </a:ext>
             </a:extLst>
           </p:cNvPr>
@@ -11178,7 +11180,7 @@
           <p:cNvPr id="20" name="p14-s3">
             <a:extLst xmlns:a="http://schemas.openxmlformats.org/drawingml/2006/main">
               <a:ext uri="{FF2B5EF4-FFF2-40B4-BE49-F238E27FC236}">
-                <a16:creationId xmlns:a16="http://schemas.microsoft.com/office/drawing/2014/main" id="{C9C38A89-E8B9-4BD6-AF24-D5214B4A753D}"/>
+                <a16:creationId xmlns:a16="http://schemas.microsoft.com/office/drawing/2014/main" id="{5DC3D4C9-1C51-4F0E-80E8-707B974E1D49}"/>
               </a:ext>
             </a:extLst>
           </p:cNvPr>
@@ -11237,7 +11239,7 @@
           <p:cNvPr id="21" name="p14-bottom">
             <a:extLst xmlns:a="http://schemas.openxmlformats.org/drawingml/2006/main">
               <a:ext uri="{FF2B5EF4-FFF2-40B4-BE49-F238E27FC236}">
-                <a16:creationId xmlns:a16="http://schemas.microsoft.com/office/drawing/2014/main" id="{0DEC16F5-52C4-4CF3-8D49-011F9C22EF1F}"/>
+                <a16:creationId xmlns:a16="http://schemas.microsoft.com/office/drawing/2014/main" id="{425971AA-019D-4BFB-8D94-4C994E6AA787}"/>
               </a:ext>
             </a:extLst>
           </p:cNvPr>
@@ -11265,14 +11267,14 @@
           <a:lstStyle xmlns:a="http://schemas.openxmlformats.org/drawingml/2006/main"/>
           <a:p xmlns:a="http://schemas.openxmlformats.org/drawingml/2006/main">
             <a:pPr algn="ctr">
-              <a:defRPr sz="1650" b="1">
+              <a:defRPr sz="1575" b="1">
                 <a:solidFill>
                   <a:srgbClr val="C8161E"/>
                 </a:solidFill>
               </a:defRPr>
             </a:pPr>
             <a:r>
-              <a:rPr sz="1650" b="1">
+              <a:rPr sz="1575" b="1">
                 <a:solidFill>
                   <a:srgbClr val="C8161E"/>
                 </a:solidFill>
@@ -11280,7 +11282,7 @@
                 <a:ea typeface="Microsoft YaHei"/>
                 <a:cs typeface="Microsoft YaHei"/>
               </a:rPr>
-              <a:t>只有 verified 条目进入四句草稿；pending / rejected 留在线索区。</a:t>
+              <a:t>verified 与保留限定的 caveat 可进入四句草稿；pending 仅线索，rejected 仅审计。</a:t>
             </a:r>
           </a:p>
         </p:txBody>
@@ -11343,7 +11345,7 @@
                 <a:ea typeface="Microsoft YaHei"/>
                 <a:cs typeface="Microsoft YaHei"/>
               </a:rPr>
-              <a:t>演示判断点与失败路径</a:t>
+              <a:t>演示判断点与失败演示</a:t>
             </a:r>
             <a:endParaRPr/>
           </a:p>
@@ -11382,7 +11384,7 @@
           <p:cNvPr id="6" name="p15-virtual">
             <a:extLst xmlns:a="http://schemas.openxmlformats.org/drawingml/2006/main">
               <a:ext uri="{FF2B5EF4-FFF2-40B4-BE49-F238E27FC236}">
-                <a16:creationId xmlns:a16="http://schemas.microsoft.com/office/drawing/2014/main" id="{E82629EA-C0CE-4718-ACD1-4AB77D339AE7}"/>
+                <a16:creationId xmlns:a16="http://schemas.microsoft.com/office/drawing/2014/main" id="{0FC621FC-D6C0-4503-AFBE-3BE802DBFFB4}"/>
               </a:ext>
             </a:extLst>
           </p:cNvPr>
@@ -11439,7 +11441,7 @@
           <p:cNvPr id="7" name="p15-q0">
             <a:extLst xmlns:a="http://schemas.openxmlformats.org/drawingml/2006/main">
               <a:ext uri="{FF2B5EF4-FFF2-40B4-BE49-F238E27FC236}">
-                <a16:creationId xmlns:a16="http://schemas.microsoft.com/office/drawing/2014/main" id="{B20D191D-8F35-4BDB-B038-9FFD10686FEC}"/>
+                <a16:creationId xmlns:a16="http://schemas.microsoft.com/office/drawing/2014/main" id="{BE536FC1-B122-4D3B-8E96-05B4162B30A6}"/>
               </a:ext>
             </a:extLst>
           </p:cNvPr>
@@ -11498,7 +11500,7 @@
           <p:cNvPr id="8" name="p15-q1">
             <a:extLst xmlns:a="http://schemas.openxmlformats.org/drawingml/2006/main">
               <a:ext uri="{FF2B5EF4-FFF2-40B4-BE49-F238E27FC236}">
-                <a16:creationId xmlns:a16="http://schemas.microsoft.com/office/drawing/2014/main" id="{29DC5DCB-821A-4F37-ACB5-82B91986469F}"/>
+                <a16:creationId xmlns:a16="http://schemas.microsoft.com/office/drawing/2014/main" id="{E7F8CD2B-13BA-4EFA-BE2F-02E456C3D036}"/>
               </a:ext>
             </a:extLst>
           </p:cNvPr>
@@ -11557,7 +11559,7 @@
           <p:cNvPr id="9" name="p15-q2">
             <a:extLst xmlns:a="http://schemas.openxmlformats.org/drawingml/2006/main">
               <a:ext uri="{FF2B5EF4-FFF2-40B4-BE49-F238E27FC236}">
-                <a16:creationId xmlns:a16="http://schemas.microsoft.com/office/drawing/2014/main" id="{40D66B81-B693-4C2C-9863-DB337B4D3595}"/>
+                <a16:creationId xmlns:a16="http://schemas.microsoft.com/office/drawing/2014/main" id="{A0242E8C-BC5B-4F08-926D-BC4AA7EEAB2E}"/>
               </a:ext>
             </a:extLst>
           </p:cNvPr>
@@ -11616,7 +11618,7 @@
           <p:cNvPr id="10" name="p15-q3">
             <a:extLst xmlns:a="http://schemas.openxmlformats.org/drawingml/2006/main">
               <a:ext uri="{FF2B5EF4-FFF2-40B4-BE49-F238E27FC236}">
-                <a16:creationId xmlns:a16="http://schemas.microsoft.com/office/drawing/2014/main" id="{38C52D0B-8EF9-4A9D-BE1E-6EA4ABBAB952}"/>
+                <a16:creationId xmlns:a16="http://schemas.microsoft.com/office/drawing/2014/main" id="{C52BE177-CA95-4F74-A825-26A8E3929F74}"/>
               </a:ext>
             </a:extLst>
           </p:cNvPr>
@@ -11675,7 +11677,7 @@
           <p:cNvPr id="11" name="p15-fail-h">
             <a:extLst xmlns:a="http://schemas.openxmlformats.org/drawingml/2006/main">
               <a:ext uri="{FF2B5EF4-FFF2-40B4-BE49-F238E27FC236}">
-                <a16:creationId xmlns:a16="http://schemas.microsoft.com/office/drawing/2014/main" id="{F7761706-8CF4-458A-A351-B32866E6ECE8}"/>
+                <a16:creationId xmlns:a16="http://schemas.microsoft.com/office/drawing/2014/main" id="{402EBD14-ABDB-4811-BC0F-D095FF9C85D8}"/>
               </a:ext>
             </a:extLst>
           </p:cNvPr>
@@ -11730,7 +11732,7 @@
           <p:cNvPr id="12" name="p15-f0">
             <a:extLst xmlns:a="http://schemas.openxmlformats.org/drawingml/2006/main">
               <a:ext uri="{FF2B5EF4-FFF2-40B4-BE49-F238E27FC236}">
-                <a16:creationId xmlns:a16="http://schemas.microsoft.com/office/drawing/2014/main" id="{041AAB2C-E290-4E28-878E-6999C453807C}"/>
+                <a16:creationId xmlns:a16="http://schemas.microsoft.com/office/drawing/2014/main" id="{6CB2922E-9A99-42F9-A064-F1EA2BFF91C0}"/>
               </a:ext>
             </a:extLst>
           </p:cNvPr>
@@ -11789,7 +11791,7 @@
           <p:cNvPr id="13" name="p15-fa0">
             <a:extLst xmlns:a="http://schemas.openxmlformats.org/drawingml/2006/main">
               <a:ext uri="{FF2B5EF4-FFF2-40B4-BE49-F238E27FC236}">
-                <a16:creationId xmlns:a16="http://schemas.microsoft.com/office/drawing/2014/main" id="{82CBE982-A023-4C79-860A-3468534EC779}"/>
+                <a16:creationId xmlns:a16="http://schemas.microsoft.com/office/drawing/2014/main" id="{97BAF8EA-4BED-4004-A3EE-C44441DA49CE}"/>
               </a:ext>
             </a:extLst>
           </p:cNvPr>
@@ -11842,7 +11844,7 @@
           <p:cNvPr id="14" name="p15-f1">
             <a:extLst xmlns:a="http://schemas.openxmlformats.org/drawingml/2006/main">
               <a:ext uri="{FF2B5EF4-FFF2-40B4-BE49-F238E27FC236}">
-                <a16:creationId xmlns:a16="http://schemas.microsoft.com/office/drawing/2014/main" id="{13160064-9A8A-41DD-858A-F6C4BDD9699A}"/>
+                <a16:creationId xmlns:a16="http://schemas.microsoft.com/office/drawing/2014/main" id="{49323B27-2E87-46C9-B4B9-32B8F945F664}"/>
               </a:ext>
             </a:extLst>
           </p:cNvPr>
@@ -11901,7 +11903,7 @@
           <p:cNvPr id="15" name="p15-fa1">
             <a:extLst xmlns:a="http://schemas.openxmlformats.org/drawingml/2006/main">
               <a:ext uri="{FF2B5EF4-FFF2-40B4-BE49-F238E27FC236}">
-                <a16:creationId xmlns:a16="http://schemas.microsoft.com/office/drawing/2014/main" id="{47832C69-CD8B-4031-BCA2-F658E90AF1E0}"/>
+                <a16:creationId xmlns:a16="http://schemas.microsoft.com/office/drawing/2014/main" id="{ADA07B01-DFBB-48C8-AD03-67DAE3544C20}"/>
               </a:ext>
             </a:extLst>
           </p:cNvPr>
@@ -11954,7 +11956,7 @@
           <p:cNvPr id="16" name="p15-f2">
             <a:extLst xmlns:a="http://schemas.openxmlformats.org/drawingml/2006/main">
               <a:ext uri="{FF2B5EF4-FFF2-40B4-BE49-F238E27FC236}">
-                <a16:creationId xmlns:a16="http://schemas.microsoft.com/office/drawing/2014/main" id="{636F07EF-F28F-4A51-A101-70AA9808BBBA}"/>
+                <a16:creationId xmlns:a16="http://schemas.microsoft.com/office/drawing/2014/main" id="{CADBF163-AE52-49A6-86A5-66A633F36C78}"/>
               </a:ext>
             </a:extLst>
           </p:cNvPr>
@@ -12013,7 +12015,7 @@
           <p:cNvPr id="17" name="p15-fa2">
             <a:extLst xmlns:a="http://schemas.openxmlformats.org/drawingml/2006/main">
               <a:ext uri="{FF2B5EF4-FFF2-40B4-BE49-F238E27FC236}">
-                <a16:creationId xmlns:a16="http://schemas.microsoft.com/office/drawing/2014/main" id="{007ADC48-8BD9-4259-96EE-A986C060F18D}"/>
+                <a16:creationId xmlns:a16="http://schemas.microsoft.com/office/drawing/2014/main" id="{11BCA84B-952A-441C-A61A-0F6E3E07B1D7}"/>
               </a:ext>
             </a:extLst>
           </p:cNvPr>
@@ -12066,7 +12068,7 @@
           <p:cNvPr id="18" name="p15-f3">
             <a:extLst xmlns:a="http://schemas.openxmlformats.org/drawingml/2006/main">
               <a:ext uri="{FF2B5EF4-FFF2-40B4-BE49-F238E27FC236}">
-                <a16:creationId xmlns:a16="http://schemas.microsoft.com/office/drawing/2014/main" id="{5B0ED2C6-B69F-42E4-93A5-5C63198211B1}"/>
+                <a16:creationId xmlns:a16="http://schemas.microsoft.com/office/drawing/2014/main" id="{52813B77-888A-4FFE-94F0-FFA85166A067}"/>
               </a:ext>
             </a:extLst>
           </p:cNvPr>
@@ -12125,7 +12127,7 @@
           <p:cNvPr id="19" name="p15-bottom">
             <a:extLst xmlns:a="http://schemas.openxmlformats.org/drawingml/2006/main">
               <a:ext uri="{FF2B5EF4-FFF2-40B4-BE49-F238E27FC236}">
-                <a16:creationId xmlns:a16="http://schemas.microsoft.com/office/drawing/2014/main" id="{B8C9CF62-CA69-454F-9B98-A9E92D921A3F}"/>
+                <a16:creationId xmlns:a16="http://schemas.microsoft.com/office/drawing/2014/main" id="{EE6C6DBE-6792-432F-A283-D48C25DEA5F8}"/>
               </a:ext>
             </a:extLst>
           </p:cNvPr>
@@ -12270,7 +12272,7 @@
           <p:cNvPr id="6" name="p16-goal">
             <a:extLst xmlns:a="http://schemas.openxmlformats.org/drawingml/2006/main">
               <a:ext uri="{FF2B5EF4-FFF2-40B4-BE49-F238E27FC236}">
-                <a16:creationId xmlns:a16="http://schemas.microsoft.com/office/drawing/2014/main" id="{8E4D804F-E696-4B63-8177-A4EAC7F111D4}"/>
+                <a16:creationId xmlns:a16="http://schemas.microsoft.com/office/drawing/2014/main" id="{20500C7E-0B15-4252-B32D-FEBD2D5BBFAF}"/>
               </a:ext>
             </a:extLst>
           </p:cNvPr>
@@ -12325,7 +12327,7 @@
           <p:cNvPr id="7" name="p16-n0">
             <a:extLst xmlns:a="http://schemas.openxmlformats.org/drawingml/2006/main">
               <a:ext uri="{FF2B5EF4-FFF2-40B4-BE49-F238E27FC236}">
-                <a16:creationId xmlns:a16="http://schemas.microsoft.com/office/drawing/2014/main" id="{78B9C5A1-173B-48FD-962E-D53A3BFBA2C4}"/>
+                <a16:creationId xmlns:a16="http://schemas.microsoft.com/office/drawing/2014/main" id="{C90A12CF-B137-4819-9977-58B030F951C2}"/>
               </a:ext>
             </a:extLst>
           </p:cNvPr>
@@ -12382,7 +12384,7 @@
           <p:cNvPr id="8" name="p16-t0">
             <a:extLst xmlns:a="http://schemas.openxmlformats.org/drawingml/2006/main">
               <a:ext uri="{FF2B5EF4-FFF2-40B4-BE49-F238E27FC236}">
-                <a16:creationId xmlns:a16="http://schemas.microsoft.com/office/drawing/2014/main" id="{64AC8362-78C7-4B8C-9643-EA77B43D2673}"/>
+                <a16:creationId xmlns:a16="http://schemas.microsoft.com/office/drawing/2014/main" id="{7A4906D7-260F-4828-BBBE-419D3FF475E2}"/>
               </a:ext>
             </a:extLst>
           </p:cNvPr>
@@ -12431,7 +12433,7 @@
                 <a:ea typeface="Microsoft YaHei"/>
                 <a:cs typeface="Microsoft YaHei"/>
               </a:rPr>
-              <a:t>写 2-3 个子问题</a:t>
+              <a:t>选 1 个子问题</a:t>
             </a:r>
           </a:p>
         </p:txBody>
@@ -12441,7 +12443,7 @@
           <p:cNvPr id="9" name="p16-n1">
             <a:extLst xmlns:a="http://schemas.openxmlformats.org/drawingml/2006/main">
               <a:ext uri="{FF2B5EF4-FFF2-40B4-BE49-F238E27FC236}">
-                <a16:creationId xmlns:a16="http://schemas.microsoft.com/office/drawing/2014/main" id="{017DEC46-7C38-41BB-BA30-C6DC71ADAE2B}"/>
+                <a16:creationId xmlns:a16="http://schemas.microsoft.com/office/drawing/2014/main" id="{5E7EF07E-6DE6-4861-B21D-A325096AE9F7}"/>
               </a:ext>
             </a:extLst>
           </p:cNvPr>
@@ -12498,7 +12500,7 @@
           <p:cNvPr id="10" name="p16-t1">
             <a:extLst xmlns:a="http://schemas.openxmlformats.org/drawingml/2006/main">
               <a:ext uri="{FF2B5EF4-FFF2-40B4-BE49-F238E27FC236}">
-                <a16:creationId xmlns:a16="http://schemas.microsoft.com/office/drawing/2014/main" id="{50F5694F-DEB1-4B61-BF76-72F5B29B06A1}"/>
+                <a16:creationId xmlns:a16="http://schemas.microsoft.com/office/drawing/2014/main" id="{6603F944-4A76-428B-97D5-BD4E639458B4}"/>
               </a:ext>
             </a:extLst>
           </p:cNvPr>
@@ -12547,7 +12549,7 @@
                 <a:ea typeface="Microsoft YaHei"/>
                 <a:cs typeface="Microsoft YaHei"/>
               </a:rPr>
-              <a:t>填 2-3 张已核验阅读卡</a:t>
+              <a:t>取 2 张 verified / caveat 卡</a:t>
             </a:r>
           </a:p>
         </p:txBody>
@@ -12557,7 +12559,7 @@
           <p:cNvPr id="11" name="p16-n2">
             <a:extLst xmlns:a="http://schemas.openxmlformats.org/drawingml/2006/main">
               <a:ext uri="{FF2B5EF4-FFF2-40B4-BE49-F238E27FC236}">
-                <a16:creationId xmlns:a16="http://schemas.microsoft.com/office/drawing/2014/main" id="{B1EDBF51-E861-4A4D-9648-FF370449618F}"/>
+                <a16:creationId xmlns:a16="http://schemas.microsoft.com/office/drawing/2014/main" id="{1B9A71BE-59D8-43ED-8CDA-3D290FC70E02}"/>
               </a:ext>
             </a:extLst>
           </p:cNvPr>
@@ -12614,7 +12616,7 @@
           <p:cNvPr id="12" name="p16-t2">
             <a:extLst xmlns:a="http://schemas.openxmlformats.org/drawingml/2006/main">
               <a:ext uri="{FF2B5EF4-FFF2-40B4-BE49-F238E27FC236}">
-                <a16:creationId xmlns:a16="http://schemas.microsoft.com/office/drawing/2014/main" id="{A67B1434-B22C-486B-B57B-0F8B1AE09BD7}"/>
+                <a16:creationId xmlns:a16="http://schemas.microsoft.com/office/drawing/2014/main" id="{360B515A-6E12-4168-AD7C-A1F8435E64D8}"/>
               </a:ext>
             </a:extLst>
           </p:cNvPr>
@@ -12663,7 +12665,7 @@
                 <a:ea typeface="Microsoft YaHei"/>
                 <a:cs typeface="Microsoft YaHei"/>
               </a:rPr>
-              <a:t>抽取四视图地图</a:t>
+              <a:t>填窄矩阵</a:t>
             </a:r>
           </a:p>
         </p:txBody>
@@ -12673,7 +12675,7 @@
           <p:cNvPr id="13" name="p16-n3">
             <a:extLst xmlns:a="http://schemas.openxmlformats.org/drawingml/2006/main">
               <a:ext uri="{FF2B5EF4-FFF2-40B4-BE49-F238E27FC236}">
-                <a16:creationId xmlns:a16="http://schemas.microsoft.com/office/drawing/2014/main" id="{7F54EB59-4872-4D02-9A8F-6BA8E160AB43}"/>
+                <a16:creationId xmlns:a16="http://schemas.microsoft.com/office/drawing/2014/main" id="{40A05565-C455-4E3D-ACA3-543C3C04B613}"/>
               </a:ext>
             </a:extLst>
           </p:cNvPr>
@@ -12730,7 +12732,7 @@
           <p:cNvPr id="14" name="p16-t3">
             <a:extLst xmlns:a="http://schemas.openxmlformats.org/drawingml/2006/main">
               <a:ext uri="{FF2B5EF4-FFF2-40B4-BE49-F238E27FC236}">
-                <a16:creationId xmlns:a16="http://schemas.microsoft.com/office/drawing/2014/main" id="{F459874A-88BA-42AE-BFF6-708F27614654}"/>
+                <a16:creationId xmlns:a16="http://schemas.microsoft.com/office/drawing/2014/main" id="{CF4F5C05-37F7-472B-A744-31272DBA8158}"/>
               </a:ext>
             </a:extLst>
           </p:cNvPr>
@@ -12779,7 +12781,7 @@
                 <a:ea typeface="Microsoft YaHei"/>
                 <a:cs typeface="Microsoft YaHei"/>
               </a:rPr>
-              <a:t>记录一个空白首轮检验</a:t>
+              <a:t>写 2 行证据地图</a:t>
             </a:r>
           </a:p>
         </p:txBody>
@@ -12789,7 +12791,7 @@
           <p:cNvPr id="15" name="p16-n4">
             <a:extLst xmlns:a="http://schemas.openxmlformats.org/drawingml/2006/main">
               <a:ext uri="{FF2B5EF4-FFF2-40B4-BE49-F238E27FC236}">
-                <a16:creationId xmlns:a16="http://schemas.microsoft.com/office/drawing/2014/main" id="{9AB0D2DB-5099-4814-A8BD-9B9D47214FB1}"/>
+                <a16:creationId xmlns:a16="http://schemas.microsoft.com/office/drawing/2014/main" id="{B05462A1-553C-4F30-8062-F8323E417399}"/>
               </a:ext>
             </a:extLst>
           </p:cNvPr>
@@ -12846,7 +12848,7 @@
           <p:cNvPr id="16" name="p16-t4">
             <a:extLst xmlns:a="http://schemas.openxmlformats.org/drawingml/2006/main">
               <a:ext uri="{FF2B5EF4-FFF2-40B4-BE49-F238E27FC236}">
-                <a16:creationId xmlns:a16="http://schemas.microsoft.com/office/drawing/2014/main" id="{5CABCAB5-DB30-461E-952E-9297BBD7F0E1}"/>
+                <a16:creationId xmlns:a16="http://schemas.microsoft.com/office/drawing/2014/main" id="{1D1362B1-9E16-4214-A532-F510DEB11E3D}"/>
               </a:ext>
             </a:extLst>
           </p:cNvPr>
@@ -12905,7 +12907,7 @@
           <p:cNvPr id="17" name="p16-n5">
             <a:extLst xmlns:a="http://schemas.openxmlformats.org/drawingml/2006/main">
               <a:ext uri="{FF2B5EF4-FFF2-40B4-BE49-F238E27FC236}">
-                <a16:creationId xmlns:a16="http://schemas.microsoft.com/office/drawing/2014/main" id="{98BADA3F-C0AD-47B1-AA95-A7CF7FB23724}"/>
+                <a16:creationId xmlns:a16="http://schemas.microsoft.com/office/drawing/2014/main" id="{A077026E-1136-4FCA-99CC-5B9D7382F268}"/>
               </a:ext>
             </a:extLst>
           </p:cNvPr>
@@ -12962,7 +12964,7 @@
           <p:cNvPr id="18" name="p16-t5">
             <a:extLst xmlns:a="http://schemas.openxmlformats.org/drawingml/2006/main">
               <a:ext uri="{FF2B5EF4-FFF2-40B4-BE49-F238E27FC236}">
-                <a16:creationId xmlns:a16="http://schemas.microsoft.com/office/drawing/2014/main" id="{F3C5F914-7E74-4AF7-91D4-EF7E6F66F3C8}"/>
+                <a16:creationId xmlns:a16="http://schemas.microsoft.com/office/drawing/2014/main" id="{F89C2F19-927E-40B4-B8B2-7E7BBF09D757}"/>
               </a:ext>
             </a:extLst>
           </p:cNvPr>
@@ -13011,7 +13013,7 @@
                 <a:ea typeface="Microsoft YaHei"/>
                 <a:cs typeface="Microsoft YaHei"/>
               </a:rPr>
-              <a:t>核验一条 AI 归纳</a:t>
+              <a:t>留 1 条空白候选线索</a:t>
             </a:r>
           </a:p>
         </p:txBody>
@@ -13021,7 +13023,7 @@
           <p:cNvPr id="19" name="p16-n6">
             <a:extLst xmlns:a="http://schemas.openxmlformats.org/drawingml/2006/main">
               <a:ext uri="{FF2B5EF4-FFF2-40B4-BE49-F238E27FC236}">
-                <a16:creationId xmlns:a16="http://schemas.microsoft.com/office/drawing/2014/main" id="{F8AAFC9F-9B10-4799-9EB4-B40088675676}"/>
+                <a16:creationId xmlns:a16="http://schemas.microsoft.com/office/drawing/2014/main" id="{A9C445FC-EC13-420A-B992-A3B7FB867560}"/>
               </a:ext>
             </a:extLst>
           </p:cNvPr>
@@ -13078,7 +13080,7 @@
           <p:cNvPr id="20" name="p16-t6">
             <a:extLst xmlns:a="http://schemas.openxmlformats.org/drawingml/2006/main">
               <a:ext uri="{FF2B5EF4-FFF2-40B4-BE49-F238E27FC236}">
-                <a16:creationId xmlns:a16="http://schemas.microsoft.com/office/drawing/2014/main" id="{B58CDD6B-F8D2-497D-9B55-90F7ADED823E}"/>
+                <a16:creationId xmlns:a16="http://schemas.microsoft.com/office/drawing/2014/main" id="{2448CA20-1C7F-45C6-8EDD-30FB12771E28}"/>
               </a:ext>
             </a:extLst>
           </p:cNvPr>
@@ -13137,19 +13139,19 @@
           <p:cNvPr id="21" name="p16-time">
             <a:extLst xmlns:a="http://schemas.openxmlformats.org/drawingml/2006/main">
               <a:ext uri="{FF2B5EF4-FFF2-40B4-BE49-F238E27FC236}">
-                <a16:creationId xmlns:a16="http://schemas.microsoft.com/office/drawing/2014/main" id="{5725F362-A1CE-409F-B397-CA3B51A1B963}"/>
-              </a:ext>
-            </a:extLst>
-          </p:cNvPr>
-          <p:cNvSpPr>
-            <a:spLocks xmlns:a="http://schemas.openxmlformats.org/drawingml/2006/main" noGrp="1"/>
-          </p:cNvSpPr>
-          <p:nvPr/>
-        </p:nvSpPr>
-        <p:spPr>
-          <a:xfrm xmlns:a="http://schemas.openxmlformats.org/drawingml/2006/main">
-            <a:off x="1428750" y="4953000"/>
-            <a:ext cx="9334500" cy="571500"/>
+                <a16:creationId xmlns:a16="http://schemas.microsoft.com/office/drawing/2014/main" id="{5488F7D7-FD7A-46EA-9400-260F6223FE61}"/>
+              </a:ext>
+            </a:extLst>
+          </p:cNvPr>
+          <p:cNvSpPr>
+            <a:spLocks xmlns:a="http://schemas.openxmlformats.org/drawingml/2006/main" noGrp="1"/>
+          </p:cNvSpPr>
+          <p:nvPr/>
+        </p:nvSpPr>
+        <p:spPr>
+          <a:xfrm xmlns:a="http://schemas.openxmlformats.org/drawingml/2006/main">
+            <a:off x="1143000" y="4953000"/>
+            <a:ext cx="9906000" cy="571500"/>
           </a:xfrm>
           <a:prstGeom xmlns:a="http://schemas.openxmlformats.org/drawingml/2006/main" prst="rect">
             <a:avLst/>
@@ -13167,14 +13169,14 @@
           <a:lstStyle xmlns:a="http://schemas.openxmlformats.org/drawingml/2006/main"/>
           <a:p xmlns:a="http://schemas.openxmlformats.org/drawingml/2006/main">
             <a:pPr algn="ctr">
-              <a:defRPr sz="1650" b="1">
+              <a:defRPr sz="1575" b="1">
                 <a:solidFill>
                   <a:srgbClr val="C8161E"/>
                 </a:solidFill>
               </a:defRPr>
             </a:pPr>
             <a:r>
-              <a:rPr sz="1650" b="1">
+              <a:rPr sz="1575" b="1">
                 <a:solidFill>
                   <a:srgbClr val="C8161E"/>
                 </a:solidFill>
@@ -13182,7 +13184,7 @@
                 <a:ea typeface="Microsoft YaHei"/>
                 <a:cs typeface="Microsoft YaHei"/>
               </a:rPr>
-              <a:t>5 分矩阵 → 7 分地图 → 6 分空白 → 5 分四句 → 4 分核验与保存</a:t>
+              <a:t>6 分窄矩阵 → 7 分 2 行地图 → 8 分四句 → 6 分 AI 审计与保存；空白只留候选线索</a:t>
             </a:r>
           </a:p>
         </p:txBody>
@@ -13245,7 +13247,7 @@
                 <a:ea typeface="Microsoft YaHei"/>
                 <a:cs typeface="Microsoft YaHei"/>
               </a:rPr>
-              <a:t>实践停留页：最小综述闭环</a:t>
+              <a:t>实践停留页：模板</a:t>
             </a:r>
             <a:endParaRPr/>
           </a:p>
@@ -13284,7 +13286,7 @@
           <p:cNvPr id="6" name="p17-zone1-h">
             <a:extLst xmlns:a="http://schemas.openxmlformats.org/drawingml/2006/main">
               <a:ext uri="{FF2B5EF4-FFF2-40B4-BE49-F238E27FC236}">
-                <a16:creationId xmlns:a16="http://schemas.microsoft.com/office/drawing/2014/main" id="{5EA83AEB-9F60-4AF2-9020-EEEFF732A5FC}"/>
+                <a16:creationId xmlns:a16="http://schemas.microsoft.com/office/drawing/2014/main" id="{C7865108-5FCE-41C2-8A53-373E2633AF1C}"/>
               </a:ext>
             </a:extLst>
           </p:cNvPr>
@@ -13296,7 +13298,7 @@
         <p:spPr>
           <a:xfrm xmlns:a="http://schemas.openxmlformats.org/drawingml/2006/main">
             <a:off x="523875" y="914400"/>
-            <a:ext cx="1714500" cy="400050"/>
+            <a:ext cx="1809750" cy="438150"/>
           </a:xfrm>
           <a:prstGeom xmlns:a="http://schemas.openxmlformats.org/drawingml/2006/main" prst="rect">
             <a:avLst/>
@@ -13339,19 +13341,19 @@
           <p:cNvPr id="7" name="p17-zone1">
             <a:extLst xmlns:a="http://schemas.openxmlformats.org/drawingml/2006/main">
               <a:ext uri="{FF2B5EF4-FFF2-40B4-BE49-F238E27FC236}">
-                <a16:creationId xmlns:a16="http://schemas.microsoft.com/office/drawing/2014/main" id="{8FB57FB8-AC1F-4E10-ACC8-8B4660CCBEC9}"/>
-              </a:ext>
-            </a:extLst>
-          </p:cNvPr>
-          <p:cNvSpPr>
-            <a:spLocks xmlns:a="http://schemas.openxmlformats.org/drawingml/2006/main" noGrp="1"/>
-          </p:cNvSpPr>
-          <p:nvPr/>
-        </p:nvSpPr>
-        <p:spPr>
-          <a:xfrm xmlns:a="http://schemas.openxmlformats.org/drawingml/2006/main">
-            <a:off x="2333625" y="914400"/>
-            <a:ext cx="9239250" cy="400050"/>
+                <a16:creationId xmlns:a16="http://schemas.microsoft.com/office/drawing/2014/main" id="{B948DE66-569D-45E1-94ED-9B3ECB675794}"/>
+              </a:ext>
+            </a:extLst>
+          </p:cNvPr>
+          <p:cNvSpPr>
+            <a:spLocks xmlns:a="http://schemas.openxmlformats.org/drawingml/2006/main" noGrp="1"/>
+          </p:cNvSpPr>
+          <p:nvPr/>
+        </p:nvSpPr>
+        <p:spPr>
+          <a:xfrm xmlns:a="http://schemas.openxmlformats.org/drawingml/2006/main">
+            <a:off x="2428875" y="914400"/>
+            <a:ext cx="9144000" cy="438150"/>
           </a:xfrm>
           <a:prstGeom xmlns:a="http://schemas.openxmlformats.org/drawingml/2006/main" prst="rect">
             <a:avLst/>
@@ -13371,14 +13373,14 @@
           <a:lstStyle xmlns:a="http://schemas.openxmlformats.org/drawingml/2006/main"/>
           <a:p xmlns:a="http://schemas.openxmlformats.org/drawingml/2006/main">
             <a:pPr algn="l">
-              <a:defRPr sz="1350" b="0">
-                <a:solidFill>
-                  <a:srgbClr val="263746"/>
-                </a:solidFill>
-              </a:defRPr>
-            </a:pPr>
-            <a:r>
-              <a:rPr sz="1350" b="0">
+              <a:defRPr sz="1500" b="0">
+                <a:solidFill>
+                  <a:srgbClr val="263746"/>
+                </a:solidFill>
+              </a:defRPr>
+            </a:pPr>
+            <a:r>
+              <a:rPr sz="1500" b="0">
                 <a:solidFill>
                   <a:srgbClr val="263746"/>
                 </a:solidFill>
@@ -13386,7 +13388,7 @@
                 <a:ea typeface="Consolas"/>
                 <a:cs typeface="Consolas"/>
               </a:rPr>
-              <a:t>材料（核验后）｜子问题 a｜子问题 b｜子问题 c｜候选角色</a:t>
+              <a:t>1 个子问题｜2 张 verified / caveat 阅读卡｜材料 × 子问题 × 角色</a:t>
             </a:r>
           </a:p>
         </p:txBody>
@@ -13396,19 +13398,19 @@
           <p:cNvPr id="8" name="p17-zone2-h">
             <a:extLst xmlns:a="http://schemas.openxmlformats.org/drawingml/2006/main">
               <a:ext uri="{FF2B5EF4-FFF2-40B4-BE49-F238E27FC236}">
-                <a16:creationId xmlns:a16="http://schemas.microsoft.com/office/drawing/2014/main" id="{43E5AD2C-413B-4074-A500-E0D40911B3F6}"/>
-              </a:ext>
-            </a:extLst>
-          </p:cNvPr>
-          <p:cNvSpPr>
-            <a:spLocks xmlns:a="http://schemas.openxmlformats.org/drawingml/2006/main" noGrp="1"/>
-          </p:cNvSpPr>
-          <p:nvPr/>
-        </p:nvSpPr>
-        <p:spPr>
-          <a:xfrm xmlns:a="http://schemas.openxmlformats.org/drawingml/2006/main">
-            <a:off x="523875" y="1524000"/>
-            <a:ext cx="1714500" cy="400050"/>
+                <a16:creationId xmlns:a16="http://schemas.microsoft.com/office/drawing/2014/main" id="{ED12CD09-F533-4B7B-9765-6BB702F28E99}"/>
+              </a:ext>
+            </a:extLst>
+          </p:cNvPr>
+          <p:cNvSpPr>
+            <a:spLocks xmlns:a="http://schemas.openxmlformats.org/drawingml/2006/main" noGrp="1"/>
+          </p:cNvSpPr>
+          <p:nvPr/>
+        </p:nvSpPr>
+        <p:spPr>
+          <a:xfrm xmlns:a="http://schemas.openxmlformats.org/drawingml/2006/main">
+            <a:off x="523875" y="1581150"/>
+            <a:ext cx="1809750" cy="438150"/>
           </a:xfrm>
           <a:prstGeom xmlns:a="http://schemas.openxmlformats.org/drawingml/2006/main" prst="rect">
             <a:avLst/>
@@ -13441,7 +13443,7 @@
                 <a:ea typeface="Microsoft YaHei"/>
                 <a:cs typeface="Microsoft YaHei"/>
               </a:rPr>
-              <a:t>2｜四视图地图</a:t>
+              <a:t>2｜证据地图</a:t>
             </a:r>
           </a:p>
         </p:txBody>
@@ -13451,19 +13453,19 @@
           <p:cNvPr id="9" name="p17-zone2">
             <a:extLst xmlns:a="http://schemas.openxmlformats.org/drawingml/2006/main">
               <a:ext uri="{FF2B5EF4-FFF2-40B4-BE49-F238E27FC236}">
-                <a16:creationId xmlns:a16="http://schemas.microsoft.com/office/drawing/2014/main" id="{7E1CB1C2-FFF7-4CDF-A33F-C140C150B118}"/>
-              </a:ext>
-            </a:extLst>
-          </p:cNvPr>
-          <p:cNvSpPr>
-            <a:spLocks xmlns:a="http://schemas.openxmlformats.org/drawingml/2006/main" noGrp="1"/>
-          </p:cNvSpPr>
-          <p:nvPr/>
-        </p:nvSpPr>
-        <p:spPr>
-          <a:xfrm xmlns:a="http://schemas.openxmlformats.org/drawingml/2006/main">
-            <a:off x="2333625" y="1524000"/>
-            <a:ext cx="9239250" cy="400050"/>
+                <a16:creationId xmlns:a16="http://schemas.microsoft.com/office/drawing/2014/main" id="{BDB618A0-7C98-40C3-B9AE-C034DFC4C79F}"/>
+              </a:ext>
+            </a:extLst>
+          </p:cNvPr>
+          <p:cNvSpPr>
+            <a:spLocks xmlns:a="http://schemas.openxmlformats.org/drawingml/2006/main" noGrp="1"/>
+          </p:cNvSpPr>
+          <p:nvPr/>
+        </p:nvSpPr>
+        <p:spPr>
+          <a:xfrm xmlns:a="http://schemas.openxmlformats.org/drawingml/2006/main">
+            <a:off x="2428875" y="1581150"/>
+            <a:ext cx="9144000" cy="438150"/>
           </a:xfrm>
           <a:prstGeom xmlns:a="http://schemas.openxmlformats.org/drawingml/2006/main" prst="rect">
             <a:avLst/>
@@ -13483,14 +13485,14 @@
           <a:lstStyle xmlns:a="http://schemas.openxmlformats.org/drawingml/2006/main"/>
           <a:p xmlns:a="http://schemas.openxmlformats.org/drawingml/2006/main">
             <a:pPr algn="l">
-              <a:defRPr sz="1350" b="0">
-                <a:solidFill>
-                  <a:srgbClr val="263746"/>
-                </a:solidFill>
-              </a:defRPr>
-            </a:pPr>
-            <a:r>
-              <a:rPr sz="1350" b="0">
+              <a:defRPr sz="1425" b="0">
+                <a:solidFill>
+                  <a:srgbClr val="263746"/>
+                </a:solidFill>
+              </a:defRPr>
+            </a:pPr>
+            <a:r>
+              <a:rPr sz="1425" b="0">
                 <a:solidFill>
                   <a:srgbClr val="263746"/>
                 </a:solidFill>
@@ -13498,7 +13500,7 @@
                 <a:ea typeface="Consolas"/>
                 <a:cs typeface="Consolas"/>
               </a:rPr>
-              <a:t>编号｜子问题｜材料｜原文位置｜主张｜直接/补充/冲突/空白｜局限｜状态</a:t>
+              <a:t>只写 2 行：编号｜子问题｜材料｜原文位置｜主张｜角色｜局限｜四态</a:t>
             </a:r>
           </a:p>
         </p:txBody>
@@ -13508,19 +13510,19 @@
           <p:cNvPr id="10" name="p17-zone3-h">
             <a:extLst xmlns:a="http://schemas.openxmlformats.org/drawingml/2006/main">
               <a:ext uri="{FF2B5EF4-FFF2-40B4-BE49-F238E27FC236}">
-                <a16:creationId xmlns:a16="http://schemas.microsoft.com/office/drawing/2014/main" id="{E9395411-FECA-41C7-A8B5-C101A22A8380}"/>
-              </a:ext>
-            </a:extLst>
-          </p:cNvPr>
-          <p:cNvSpPr>
-            <a:spLocks xmlns:a="http://schemas.openxmlformats.org/drawingml/2006/main" noGrp="1"/>
-          </p:cNvSpPr>
-          <p:nvPr/>
-        </p:nvSpPr>
-        <p:spPr>
-          <a:xfrm xmlns:a="http://schemas.openxmlformats.org/drawingml/2006/main">
-            <a:off x="523875" y="2133600"/>
-            <a:ext cx="1714500" cy="400050"/>
+                <a16:creationId xmlns:a16="http://schemas.microsoft.com/office/drawing/2014/main" id="{8D3B67D3-727A-49CC-89DD-FB09806B8742}"/>
+              </a:ext>
+            </a:extLst>
+          </p:cNvPr>
+          <p:cNvSpPr>
+            <a:spLocks xmlns:a="http://schemas.openxmlformats.org/drawingml/2006/main" noGrp="1"/>
+          </p:cNvSpPr>
+          <p:nvPr/>
+        </p:nvSpPr>
+        <p:spPr>
+          <a:xfrm xmlns:a="http://schemas.openxmlformats.org/drawingml/2006/main">
+            <a:off x="523875" y="2247900"/>
+            <a:ext cx="1809750" cy="438150"/>
           </a:xfrm>
           <a:prstGeom xmlns:a="http://schemas.openxmlformats.org/drawingml/2006/main" prst="rect">
             <a:avLst/>
@@ -13553,7 +13555,7 @@
                 <a:ea typeface="Microsoft YaHei"/>
                 <a:cs typeface="Microsoft YaHei"/>
               </a:rPr>
-              <a:t>3｜空白首轮检验</a:t>
+              <a:t>3｜空白线索</a:t>
             </a:r>
           </a:p>
         </p:txBody>
@@ -13563,19 +13565,19 @@
           <p:cNvPr id="11" name="p17-zone3">
             <a:extLst xmlns:a="http://schemas.openxmlformats.org/drawingml/2006/main">
               <a:ext uri="{FF2B5EF4-FFF2-40B4-BE49-F238E27FC236}">
-                <a16:creationId xmlns:a16="http://schemas.microsoft.com/office/drawing/2014/main" id="{1484E71D-3969-4A83-BA20-B8A5317EB4F5}"/>
-              </a:ext>
-            </a:extLst>
-          </p:cNvPr>
-          <p:cNvSpPr>
-            <a:spLocks xmlns:a="http://schemas.openxmlformats.org/drawingml/2006/main" noGrp="1"/>
-          </p:cNvSpPr>
-          <p:nvPr/>
-        </p:nvSpPr>
-        <p:spPr>
-          <a:xfrm xmlns:a="http://schemas.openxmlformats.org/drawingml/2006/main">
-            <a:off x="2333625" y="2133600"/>
-            <a:ext cx="9239250" cy="400050"/>
+                <a16:creationId xmlns:a16="http://schemas.microsoft.com/office/drawing/2014/main" id="{9A2F52BB-B73D-4864-86D1-B1509F9DE2DC}"/>
+              </a:ext>
+            </a:extLst>
+          </p:cNvPr>
+          <p:cNvSpPr>
+            <a:spLocks xmlns:a="http://schemas.openxmlformats.org/drawingml/2006/main" noGrp="1"/>
+          </p:cNvSpPr>
+          <p:nvPr/>
+        </p:nvSpPr>
+        <p:spPr>
+          <a:xfrm xmlns:a="http://schemas.openxmlformats.org/drawingml/2006/main">
+            <a:off x="2428875" y="2247900"/>
+            <a:ext cx="9144000" cy="438150"/>
           </a:xfrm>
           <a:prstGeom xmlns:a="http://schemas.openxmlformats.org/drawingml/2006/main" prst="rect">
             <a:avLst/>
@@ -13595,14 +13597,14 @@
           <a:lstStyle xmlns:a="http://schemas.openxmlformats.org/drawingml/2006/main"/>
           <a:p xmlns:a="http://schemas.openxmlformats.org/drawingml/2006/main">
             <a:pPr algn="l">
-              <a:defRPr sz="1350" b="0">
-                <a:solidFill>
-                  <a:srgbClr val="263746"/>
-                </a:solidFill>
-              </a:defRPr>
-            </a:pPr>
-            <a:r>
-              <a:rPr sz="1350" b="0">
+              <a:defRPr sz="1425" b="0">
+                <a:solidFill>
+                  <a:srgbClr val="263746"/>
+                </a:solidFill>
+              </a:defRPr>
+            </a:pPr>
+            <a:r>
+              <a:rPr sz="1425" b="0">
                 <a:solidFill>
                   <a:srgbClr val="263746"/>
                 </a:solidFill>
@@ -13610,7 +13612,7 @@
                 <a:ea typeface="Consolas"/>
                 <a:cs typeface="Consolas"/>
               </a:rPr>
-              <a:t>真实性：式/库/日期/命中/筛选　｜　重要性：缺它影响哪条主张　｜　可行性：最小验证</a:t>
+              <a:t>只留 1 条 pending 候选 + 下一次窄检索动作；三步完整检验在第 6 课前完成</a:t>
             </a:r>
           </a:p>
         </p:txBody>
@@ -13620,19 +13622,19 @@
           <p:cNvPr id="12" name="p17-zone4-h">
             <a:extLst xmlns:a="http://schemas.openxmlformats.org/drawingml/2006/main">
               <a:ext uri="{FF2B5EF4-FFF2-40B4-BE49-F238E27FC236}">
-                <a16:creationId xmlns:a16="http://schemas.microsoft.com/office/drawing/2014/main" id="{B238E701-C838-4C71-BE04-B595EA771C19}"/>
-              </a:ext>
-            </a:extLst>
-          </p:cNvPr>
-          <p:cNvSpPr>
-            <a:spLocks xmlns:a="http://schemas.openxmlformats.org/drawingml/2006/main" noGrp="1"/>
-          </p:cNvSpPr>
-          <p:nvPr/>
-        </p:nvSpPr>
-        <p:spPr>
-          <a:xfrm xmlns:a="http://schemas.openxmlformats.org/drawingml/2006/main">
-            <a:off x="523875" y="2743200"/>
-            <a:ext cx="1714500" cy="400050"/>
+                <a16:creationId xmlns:a16="http://schemas.microsoft.com/office/drawing/2014/main" id="{E2D3F2B6-46E2-4E30-BD6F-2DC50AA5BCFF}"/>
+              </a:ext>
+            </a:extLst>
+          </p:cNvPr>
+          <p:cNvSpPr>
+            <a:spLocks xmlns:a="http://schemas.openxmlformats.org/drawingml/2006/main" noGrp="1"/>
+          </p:cNvSpPr>
+          <p:nvPr/>
+        </p:nvSpPr>
+        <p:spPr>
+          <a:xfrm xmlns:a="http://schemas.openxmlformats.org/drawingml/2006/main">
+            <a:off x="523875" y="2914650"/>
+            <a:ext cx="1809750" cy="438150"/>
           </a:xfrm>
           <a:prstGeom xmlns:a="http://schemas.openxmlformats.org/drawingml/2006/main" prst="rect">
             <a:avLst/>
@@ -13665,7 +13667,7 @@
                 <a:ea typeface="Microsoft YaHei"/>
                 <a:cs typeface="Microsoft YaHei"/>
               </a:rPr>
-              <a:t>4｜四句 mini review</a:t>
+              <a:t>4｜四句草稿</a:t>
             </a:r>
           </a:p>
         </p:txBody>
@@ -13675,23 +13677,23 @@
           <p:cNvPr id="13" name="p17-four0">
             <a:extLst xmlns:a="http://schemas.openxmlformats.org/drawingml/2006/main">
               <a:ext uri="{FF2B5EF4-FFF2-40B4-BE49-F238E27FC236}">
-                <a16:creationId xmlns:a16="http://schemas.microsoft.com/office/drawing/2014/main" id="{F247BC49-93BB-48A5-8952-286C60B7879F}"/>
-              </a:ext>
-            </a:extLst>
-          </p:cNvPr>
-          <p:cNvSpPr>
-            <a:spLocks xmlns:a="http://schemas.openxmlformats.org/drawingml/2006/main" noGrp="1"/>
-          </p:cNvSpPr>
-          <p:nvPr/>
-        </p:nvSpPr>
-        <p:spPr>
-          <a:xfrm xmlns:a="http://schemas.openxmlformats.org/drawingml/2006/main">
-            <a:off x="2333625" y="2743200"/>
-            <a:ext cx="2190750" cy="400050"/>
+                <a16:creationId xmlns:a16="http://schemas.microsoft.com/office/drawing/2014/main" id="{0FE20D0F-0A27-4063-BF45-32A1337D2E72}"/>
+              </a:ext>
+            </a:extLst>
+          </p:cNvPr>
+          <p:cNvSpPr>
+            <a:spLocks xmlns:a="http://schemas.openxmlformats.org/drawingml/2006/main" noGrp="1"/>
+          </p:cNvSpPr>
+          <p:nvPr/>
+        </p:nvSpPr>
+        <p:spPr>
+          <a:xfrm xmlns:a="http://schemas.openxmlformats.org/drawingml/2006/main">
+            <a:off x="2428875" y="2914650"/>
+            <a:ext cx="2171700" cy="438150"/>
           </a:xfrm>
           <a:prstGeom xmlns:a="http://schemas.openxmlformats.org/drawingml/2006/main" prst="roundRect">
             <a:avLst>
-              <a:gd name="adj" fmla="val 19048"/>
+              <a:gd name="adj" fmla="val 17391"/>
             </a:avLst>
           </a:prstGeom>
           <a:solidFill xmlns:a="http://schemas.openxmlformats.org/drawingml/2006/main">
@@ -13734,23 +13736,23 @@
           <p:cNvPr id="14" name="p17-four1">
             <a:extLst xmlns:a="http://schemas.openxmlformats.org/drawingml/2006/main">
               <a:ext uri="{FF2B5EF4-FFF2-40B4-BE49-F238E27FC236}">
-                <a16:creationId xmlns:a16="http://schemas.microsoft.com/office/drawing/2014/main" id="{0093C9C9-E61F-402F-B765-71FC72FC5ACD}"/>
-              </a:ext>
-            </a:extLst>
-          </p:cNvPr>
-          <p:cNvSpPr>
-            <a:spLocks xmlns:a="http://schemas.openxmlformats.org/drawingml/2006/main" noGrp="1"/>
-          </p:cNvSpPr>
-          <p:nvPr/>
-        </p:nvSpPr>
-        <p:spPr>
-          <a:xfrm xmlns:a="http://schemas.openxmlformats.org/drawingml/2006/main">
-            <a:off x="4638675" y="2743200"/>
-            <a:ext cx="2190750" cy="400050"/>
+                <a16:creationId xmlns:a16="http://schemas.microsoft.com/office/drawing/2014/main" id="{830A7CD8-0499-4B7D-A419-3EFCDC41C703}"/>
+              </a:ext>
+            </a:extLst>
+          </p:cNvPr>
+          <p:cNvSpPr>
+            <a:spLocks xmlns:a="http://schemas.openxmlformats.org/drawingml/2006/main" noGrp="1"/>
+          </p:cNvSpPr>
+          <p:nvPr/>
+        </p:nvSpPr>
+        <p:spPr>
+          <a:xfrm xmlns:a="http://schemas.openxmlformats.org/drawingml/2006/main">
+            <a:off x="4714875" y="2914650"/>
+            <a:ext cx="2171700" cy="438150"/>
           </a:xfrm>
           <a:prstGeom xmlns:a="http://schemas.openxmlformats.org/drawingml/2006/main" prst="roundRect">
             <a:avLst>
-              <a:gd name="adj" fmla="val 19048"/>
+              <a:gd name="adj" fmla="val 17391"/>
             </a:avLst>
           </a:prstGeom>
           <a:solidFill xmlns:a="http://schemas.openxmlformats.org/drawingml/2006/main">
@@ -13793,23 +13795,23 @@
           <p:cNvPr id="15" name="p17-four2">
             <a:extLst xmlns:a="http://schemas.openxmlformats.org/drawingml/2006/main">
               <a:ext uri="{FF2B5EF4-FFF2-40B4-BE49-F238E27FC236}">
-                <a16:creationId xmlns:a16="http://schemas.microsoft.com/office/drawing/2014/main" id="{3055FD7F-594E-473B-BFFE-404D436DA5A5}"/>
-              </a:ext>
-            </a:extLst>
-          </p:cNvPr>
-          <p:cNvSpPr>
-            <a:spLocks xmlns:a="http://schemas.openxmlformats.org/drawingml/2006/main" noGrp="1"/>
-          </p:cNvSpPr>
-          <p:nvPr/>
-        </p:nvSpPr>
-        <p:spPr>
-          <a:xfrm xmlns:a="http://schemas.openxmlformats.org/drawingml/2006/main">
-            <a:off x="6943725" y="2743200"/>
-            <a:ext cx="2190750" cy="400050"/>
+                <a16:creationId xmlns:a16="http://schemas.microsoft.com/office/drawing/2014/main" id="{61065160-0C5A-41D8-8AB4-A239B9178557}"/>
+              </a:ext>
+            </a:extLst>
+          </p:cNvPr>
+          <p:cNvSpPr>
+            <a:spLocks xmlns:a="http://schemas.openxmlformats.org/drawingml/2006/main" noGrp="1"/>
+          </p:cNvSpPr>
+          <p:nvPr/>
+        </p:nvSpPr>
+        <p:spPr>
+          <a:xfrm xmlns:a="http://schemas.openxmlformats.org/drawingml/2006/main">
+            <a:off x="7000875" y="2914650"/>
+            <a:ext cx="2171700" cy="438150"/>
           </a:xfrm>
           <a:prstGeom xmlns:a="http://schemas.openxmlformats.org/drawingml/2006/main" prst="roundRect">
             <a:avLst>
-              <a:gd name="adj" fmla="val 19048"/>
+              <a:gd name="adj" fmla="val 17391"/>
             </a:avLst>
           </a:prstGeom>
           <a:solidFill xmlns:a="http://schemas.openxmlformats.org/drawingml/2006/main">
@@ -13852,23 +13854,23 @@
           <p:cNvPr id="16" name="p17-four3">
             <a:extLst xmlns:a="http://schemas.openxmlformats.org/drawingml/2006/main">
               <a:ext uri="{FF2B5EF4-FFF2-40B4-BE49-F238E27FC236}">
-                <a16:creationId xmlns:a16="http://schemas.microsoft.com/office/drawing/2014/main" id="{836C15FE-FE92-4DC7-885A-83C78A236ADB}"/>
-              </a:ext>
-            </a:extLst>
-          </p:cNvPr>
-          <p:cNvSpPr>
-            <a:spLocks xmlns:a="http://schemas.openxmlformats.org/drawingml/2006/main" noGrp="1"/>
-          </p:cNvSpPr>
-          <p:nvPr/>
-        </p:nvSpPr>
-        <p:spPr>
-          <a:xfrm xmlns:a="http://schemas.openxmlformats.org/drawingml/2006/main">
-            <a:off x="9248775" y="2743200"/>
-            <a:ext cx="2190750" cy="400050"/>
+                <a16:creationId xmlns:a16="http://schemas.microsoft.com/office/drawing/2014/main" id="{7962BF4E-C19F-4FAB-BCFE-BA29CEEBDA05}"/>
+              </a:ext>
+            </a:extLst>
+          </p:cNvPr>
+          <p:cNvSpPr>
+            <a:spLocks xmlns:a="http://schemas.openxmlformats.org/drawingml/2006/main" noGrp="1"/>
+          </p:cNvSpPr>
+          <p:nvPr/>
+        </p:nvSpPr>
+        <p:spPr>
+          <a:xfrm xmlns:a="http://schemas.openxmlformats.org/drawingml/2006/main">
+            <a:off x="9286875" y="2914650"/>
+            <a:ext cx="2171700" cy="438150"/>
           </a:xfrm>
           <a:prstGeom xmlns:a="http://schemas.openxmlformats.org/drawingml/2006/main" prst="roundRect">
             <a:avLst>
-              <a:gd name="adj" fmla="val 19048"/>
+              <a:gd name="adj" fmla="val 17391"/>
             </a:avLst>
           </a:prstGeom>
           <a:solidFill xmlns:a="http://schemas.openxmlformats.org/drawingml/2006/main">
@@ -13911,18 +13913,18 @@
           <p:cNvPr id="17" name="p17-work-h">
             <a:extLst xmlns:a="http://schemas.openxmlformats.org/drawingml/2006/main">
               <a:ext uri="{FF2B5EF4-FFF2-40B4-BE49-F238E27FC236}">
-                <a16:creationId xmlns:a16="http://schemas.microsoft.com/office/drawing/2014/main" id="{4092AA06-8594-4BDA-83B6-32E87434D87F}"/>
-              </a:ext>
-            </a:extLst>
-          </p:cNvPr>
-          <p:cNvSpPr>
-            <a:spLocks xmlns:a="http://schemas.openxmlformats.org/drawingml/2006/main" noGrp="1"/>
-          </p:cNvSpPr>
-          <p:nvPr/>
-        </p:nvSpPr>
-        <p:spPr>
-          <a:xfrm xmlns:a="http://schemas.openxmlformats.org/drawingml/2006/main">
-            <a:off x="523875" y="3562350"/>
+                <a16:creationId xmlns:a16="http://schemas.microsoft.com/office/drawing/2014/main" id="{A1E3AAAD-F300-4460-8E5F-B84DD73F1F22}"/>
+              </a:ext>
+            </a:extLst>
+          </p:cNvPr>
+          <p:cNvSpPr>
+            <a:spLocks xmlns:a="http://schemas.openxmlformats.org/drawingml/2006/main" noGrp="1"/>
+          </p:cNvSpPr>
+          <p:nvPr/>
+        </p:nvSpPr>
+        <p:spPr>
+          <a:xfrm xmlns:a="http://schemas.openxmlformats.org/drawingml/2006/main">
+            <a:off x="523875" y="3714750"/>
             <a:ext cx="2095500" cy="476250"/>
           </a:xfrm>
           <a:prstGeom xmlns:a="http://schemas.openxmlformats.org/drawingml/2006/main" prst="rect">
@@ -13966,19 +13968,19 @@
           <p:cNvPr id="18" name="p17-m0">
             <a:extLst xmlns:a="http://schemas.openxmlformats.org/drawingml/2006/main">
               <a:ext uri="{FF2B5EF4-FFF2-40B4-BE49-F238E27FC236}">
-                <a16:creationId xmlns:a16="http://schemas.microsoft.com/office/drawing/2014/main" id="{62F06C0D-E679-48B5-B1EB-683C84658936}"/>
-              </a:ext>
-            </a:extLst>
-          </p:cNvPr>
-          <p:cNvSpPr>
-            <a:spLocks xmlns:a="http://schemas.openxmlformats.org/drawingml/2006/main" noGrp="1"/>
-          </p:cNvSpPr>
-          <p:nvPr/>
-        </p:nvSpPr>
-        <p:spPr>
-          <a:xfrm xmlns:a="http://schemas.openxmlformats.org/drawingml/2006/main">
-            <a:off x="2905125" y="3524250"/>
-            <a:ext cx="571500" cy="495300"/>
+                <a16:creationId xmlns:a16="http://schemas.microsoft.com/office/drawing/2014/main" id="{74B5A6DD-4AFB-4C68-8E45-1554E707D7B4}"/>
+              </a:ext>
+            </a:extLst>
+          </p:cNvPr>
+          <p:cNvSpPr>
+            <a:spLocks xmlns:a="http://schemas.openxmlformats.org/drawingml/2006/main" noGrp="1"/>
+          </p:cNvSpPr>
+          <p:nvPr/>
+        </p:nvSpPr>
+        <p:spPr>
+          <a:xfrm xmlns:a="http://schemas.openxmlformats.org/drawingml/2006/main">
+            <a:off x="3143250" y="3695700"/>
+            <a:ext cx="609600" cy="495300"/>
           </a:xfrm>
           <a:prstGeom xmlns:a="http://schemas.openxmlformats.org/drawingml/2006/main" prst="roundRect">
             <a:avLst>
@@ -14013,7 +14015,7 @@
                 <a:ea typeface="Microsoft YaHei"/>
                 <a:cs typeface="Microsoft YaHei"/>
               </a:rPr>
-              <a:t>5′</a:t>
+              <a:t>6′</a:t>
             </a:r>
           </a:p>
         </p:txBody>
@@ -14023,19 +14025,19 @@
           <p:cNvPr id="19" name="p17-p0">
             <a:extLst xmlns:a="http://schemas.openxmlformats.org/drawingml/2006/main">
               <a:ext uri="{FF2B5EF4-FFF2-40B4-BE49-F238E27FC236}">
-                <a16:creationId xmlns:a16="http://schemas.microsoft.com/office/drawing/2014/main" id="{927AF4A1-3CF4-4A11-A7DF-8527BD3224C9}"/>
-              </a:ext>
-            </a:extLst>
-          </p:cNvPr>
-          <p:cNvSpPr>
-            <a:spLocks xmlns:a="http://schemas.openxmlformats.org/drawingml/2006/main" noGrp="1"/>
-          </p:cNvSpPr>
-          <p:nvPr/>
-        </p:nvSpPr>
-        <p:spPr>
-          <a:xfrm xmlns:a="http://schemas.openxmlformats.org/drawingml/2006/main">
-            <a:off x="3533775" y="3524250"/>
-            <a:ext cx="952500" cy="495300"/>
+                <a16:creationId xmlns:a16="http://schemas.microsoft.com/office/drawing/2014/main" id="{7C3A2A2F-69CD-49BA-8887-3D484655D6BC}"/>
+              </a:ext>
+            </a:extLst>
+          </p:cNvPr>
+          <p:cNvSpPr>
+            <a:spLocks xmlns:a="http://schemas.openxmlformats.org/drawingml/2006/main" noGrp="1"/>
+          </p:cNvSpPr>
+          <p:nvPr/>
+        </p:nvSpPr>
+        <p:spPr>
+          <a:xfrm xmlns:a="http://schemas.openxmlformats.org/drawingml/2006/main">
+            <a:off x="3810000" y="3695700"/>
+            <a:ext cx="1143000" cy="495300"/>
           </a:xfrm>
           <a:prstGeom xmlns:a="http://schemas.openxmlformats.org/drawingml/2006/main" prst="roundRect">
             <a:avLst>
@@ -14082,19 +14084,19 @@
           <p:cNvPr id="20" name="p17-m1">
             <a:extLst xmlns:a="http://schemas.openxmlformats.org/drawingml/2006/main">
               <a:ext uri="{FF2B5EF4-FFF2-40B4-BE49-F238E27FC236}">
-                <a16:creationId xmlns:a16="http://schemas.microsoft.com/office/drawing/2014/main" id="{F20539C3-33BB-4633-94EE-E2C1FECEBF0D}"/>
-              </a:ext>
-            </a:extLst>
-          </p:cNvPr>
-          <p:cNvSpPr>
-            <a:spLocks xmlns:a="http://schemas.openxmlformats.org/drawingml/2006/main" noGrp="1"/>
-          </p:cNvSpPr>
-          <p:nvPr/>
-        </p:nvSpPr>
-        <p:spPr>
-          <a:xfrm xmlns:a="http://schemas.openxmlformats.org/drawingml/2006/main">
-            <a:off x="4581525" y="3524250"/>
-            <a:ext cx="571500" cy="495300"/>
+                <a16:creationId xmlns:a16="http://schemas.microsoft.com/office/drawing/2014/main" id="{9516E928-67A5-4662-B004-B3C471E45D35}"/>
+              </a:ext>
+            </a:extLst>
+          </p:cNvPr>
+          <p:cNvSpPr>
+            <a:spLocks xmlns:a="http://schemas.openxmlformats.org/drawingml/2006/main" noGrp="1"/>
+          </p:cNvSpPr>
+          <p:nvPr/>
+        </p:nvSpPr>
+        <p:spPr>
+          <a:xfrm xmlns:a="http://schemas.openxmlformats.org/drawingml/2006/main">
+            <a:off x="5143500" y="3695700"/>
+            <a:ext cx="609600" cy="495300"/>
           </a:xfrm>
           <a:prstGeom xmlns:a="http://schemas.openxmlformats.org/drawingml/2006/main" prst="roundRect">
             <a:avLst>
@@ -14139,19 +14141,19 @@
           <p:cNvPr id="21" name="p17-p1">
             <a:extLst xmlns:a="http://schemas.openxmlformats.org/drawingml/2006/main">
               <a:ext uri="{FF2B5EF4-FFF2-40B4-BE49-F238E27FC236}">
-                <a16:creationId xmlns:a16="http://schemas.microsoft.com/office/drawing/2014/main" id="{536C1D3F-534B-480E-8D17-EE1593E17976}"/>
-              </a:ext>
-            </a:extLst>
-          </p:cNvPr>
-          <p:cNvSpPr>
-            <a:spLocks xmlns:a="http://schemas.openxmlformats.org/drawingml/2006/main" noGrp="1"/>
-          </p:cNvSpPr>
-          <p:nvPr/>
-        </p:nvSpPr>
-        <p:spPr>
-          <a:xfrm xmlns:a="http://schemas.openxmlformats.org/drawingml/2006/main">
-            <a:off x="5210175" y="3524250"/>
-            <a:ext cx="952500" cy="495300"/>
+                <a16:creationId xmlns:a16="http://schemas.microsoft.com/office/drawing/2014/main" id="{B58BB614-73DF-4225-AA47-6430D6FB6471}"/>
+              </a:ext>
+            </a:extLst>
+          </p:cNvPr>
+          <p:cNvSpPr>
+            <a:spLocks xmlns:a="http://schemas.openxmlformats.org/drawingml/2006/main" noGrp="1"/>
+          </p:cNvSpPr>
+          <p:nvPr/>
+        </p:nvSpPr>
+        <p:spPr>
+          <a:xfrm xmlns:a="http://schemas.openxmlformats.org/drawingml/2006/main">
+            <a:off x="5810250" y="3695700"/>
+            <a:ext cx="1143000" cy="495300"/>
           </a:xfrm>
           <a:prstGeom xmlns:a="http://schemas.openxmlformats.org/drawingml/2006/main" prst="roundRect">
             <a:avLst>
@@ -14198,19 +14200,19 @@
           <p:cNvPr id="22" name="p17-m2">
             <a:extLst xmlns:a="http://schemas.openxmlformats.org/drawingml/2006/main">
               <a:ext uri="{FF2B5EF4-FFF2-40B4-BE49-F238E27FC236}">
-                <a16:creationId xmlns:a16="http://schemas.microsoft.com/office/drawing/2014/main" id="{78543F19-777B-45A2-823F-B197EC054589}"/>
-              </a:ext>
-            </a:extLst>
-          </p:cNvPr>
-          <p:cNvSpPr>
-            <a:spLocks xmlns:a="http://schemas.openxmlformats.org/drawingml/2006/main" noGrp="1"/>
-          </p:cNvSpPr>
-          <p:nvPr/>
-        </p:nvSpPr>
-        <p:spPr>
-          <a:xfrm xmlns:a="http://schemas.openxmlformats.org/drawingml/2006/main">
-            <a:off x="6257925" y="3524250"/>
-            <a:ext cx="571500" cy="495300"/>
+                <a16:creationId xmlns:a16="http://schemas.microsoft.com/office/drawing/2014/main" id="{A4D206B7-7A12-43D9-B0CF-913099196505}"/>
+              </a:ext>
+            </a:extLst>
+          </p:cNvPr>
+          <p:cNvSpPr>
+            <a:spLocks xmlns:a="http://schemas.openxmlformats.org/drawingml/2006/main" noGrp="1"/>
+          </p:cNvSpPr>
+          <p:nvPr/>
+        </p:nvSpPr>
+        <p:spPr>
+          <a:xfrm xmlns:a="http://schemas.openxmlformats.org/drawingml/2006/main">
+            <a:off x="7143750" y="3695700"/>
+            <a:ext cx="609600" cy="495300"/>
           </a:xfrm>
           <a:prstGeom xmlns:a="http://schemas.openxmlformats.org/drawingml/2006/main" prst="roundRect">
             <a:avLst>
@@ -14218,7 +14220,7 @@
             </a:avLst>
           </a:prstGeom>
           <a:solidFill xmlns:a="http://schemas.openxmlformats.org/drawingml/2006/main">
-            <a:srgbClr val="A86C12"/>
+            <a:srgbClr val="28745A"/>
           </a:solidFill>
           <a:ln xmlns:a="http://schemas.openxmlformats.org/drawingml/2006/main" w="0">
             <a:noFill/>
@@ -14245,7 +14247,7 @@
                 <a:ea typeface="Microsoft YaHei"/>
                 <a:cs typeface="Microsoft YaHei"/>
               </a:rPr>
-              <a:t>6′</a:t>
+              <a:t>8′</a:t>
             </a:r>
           </a:p>
         </p:txBody>
@@ -14255,19 +14257,19 @@
           <p:cNvPr id="23" name="p17-p2">
             <a:extLst xmlns:a="http://schemas.openxmlformats.org/drawingml/2006/main">
               <a:ext uri="{FF2B5EF4-FFF2-40B4-BE49-F238E27FC236}">
-                <a16:creationId xmlns:a16="http://schemas.microsoft.com/office/drawing/2014/main" id="{DB0CDE78-D65A-40C6-A95B-7D6683948CCE}"/>
-              </a:ext>
-            </a:extLst>
-          </p:cNvPr>
-          <p:cNvSpPr>
-            <a:spLocks xmlns:a="http://schemas.openxmlformats.org/drawingml/2006/main" noGrp="1"/>
-          </p:cNvSpPr>
-          <p:nvPr/>
-        </p:nvSpPr>
-        <p:spPr>
-          <a:xfrm xmlns:a="http://schemas.openxmlformats.org/drawingml/2006/main">
-            <a:off x="6886575" y="3524250"/>
-            <a:ext cx="952500" cy="495300"/>
+                <a16:creationId xmlns:a16="http://schemas.microsoft.com/office/drawing/2014/main" id="{CEEEBDB1-CC35-48AE-AAA7-74C544A3D1D6}"/>
+              </a:ext>
+            </a:extLst>
+          </p:cNvPr>
+          <p:cNvSpPr>
+            <a:spLocks xmlns:a="http://schemas.openxmlformats.org/drawingml/2006/main" noGrp="1"/>
+          </p:cNvSpPr>
+          <p:nvPr/>
+        </p:nvSpPr>
+        <p:spPr>
+          <a:xfrm xmlns:a="http://schemas.openxmlformats.org/drawingml/2006/main">
+            <a:off x="7810500" y="3695700"/>
+            <a:ext cx="1143000" cy="495300"/>
           </a:xfrm>
           <a:prstGeom xmlns:a="http://schemas.openxmlformats.org/drawingml/2006/main" prst="roundRect">
             <a:avLst>
@@ -14291,20 +14293,20 @@
             <a:pPr algn="ctr">
               <a:defRPr sz="1425" b="1">
                 <a:solidFill>
-                  <a:srgbClr val="A86C12"/>
+                  <a:srgbClr val="28745A"/>
                 </a:solidFill>
               </a:defRPr>
             </a:pPr>
             <a:r>
               <a:rPr sz="1425" b="1">
                 <a:solidFill>
-                  <a:srgbClr val="A86C12"/>
-                </a:solidFill>
-                <a:latin typeface="Microsoft YaHei"/>
-                <a:ea typeface="Microsoft YaHei"/>
-                <a:cs typeface="Microsoft YaHei"/>
-              </a:rPr>
-              <a:t>空白</a:t>
+                  <a:srgbClr val="28745A"/>
+                </a:solidFill>
+                <a:latin typeface="Microsoft YaHei"/>
+                <a:ea typeface="Microsoft YaHei"/>
+                <a:cs typeface="Microsoft YaHei"/>
+              </a:rPr>
+              <a:t>四句</a:t>
             </a:r>
           </a:p>
         </p:txBody>
@@ -14314,19 +14316,19 @@
           <p:cNvPr id="24" name="p17-m3">
             <a:extLst xmlns:a="http://schemas.openxmlformats.org/drawingml/2006/main">
               <a:ext uri="{FF2B5EF4-FFF2-40B4-BE49-F238E27FC236}">
-                <a16:creationId xmlns:a16="http://schemas.microsoft.com/office/drawing/2014/main" id="{3ECA660D-B383-4FB4-BE56-3F82BFFB0345}"/>
-              </a:ext>
-            </a:extLst>
-          </p:cNvPr>
-          <p:cNvSpPr>
-            <a:spLocks xmlns:a="http://schemas.openxmlformats.org/drawingml/2006/main" noGrp="1"/>
-          </p:cNvSpPr>
-          <p:nvPr/>
-        </p:nvSpPr>
-        <p:spPr>
-          <a:xfrm xmlns:a="http://schemas.openxmlformats.org/drawingml/2006/main">
-            <a:off x="7934325" y="3524250"/>
-            <a:ext cx="571500" cy="495300"/>
+                <a16:creationId xmlns:a16="http://schemas.microsoft.com/office/drawing/2014/main" id="{2FC868F3-2865-4897-9F00-8F5705DDF8C0}"/>
+              </a:ext>
+            </a:extLst>
+          </p:cNvPr>
+          <p:cNvSpPr>
+            <a:spLocks xmlns:a="http://schemas.openxmlformats.org/drawingml/2006/main" noGrp="1"/>
+          </p:cNvSpPr>
+          <p:nvPr/>
+        </p:nvSpPr>
+        <p:spPr>
+          <a:xfrm xmlns:a="http://schemas.openxmlformats.org/drawingml/2006/main">
+            <a:off x="9144000" y="3695700"/>
+            <a:ext cx="609600" cy="495300"/>
           </a:xfrm>
           <a:prstGeom xmlns:a="http://schemas.openxmlformats.org/drawingml/2006/main" prst="roundRect">
             <a:avLst>
@@ -14334,7 +14336,7 @@
             </a:avLst>
           </a:prstGeom>
           <a:solidFill xmlns:a="http://schemas.openxmlformats.org/drawingml/2006/main">
-            <a:srgbClr val="28745A"/>
+            <a:srgbClr val="C8161E"/>
           </a:solidFill>
           <a:ln xmlns:a="http://schemas.openxmlformats.org/drawingml/2006/main" w="0">
             <a:noFill/>
@@ -14361,7 +14363,7 @@
                 <a:ea typeface="Microsoft YaHei"/>
                 <a:cs typeface="Microsoft YaHei"/>
               </a:rPr>
-              <a:t>5′</a:t>
+              <a:t>6′</a:t>
             </a:r>
           </a:p>
         </p:txBody>
@@ -14371,19 +14373,19 @@
           <p:cNvPr id="25" name="p17-p3">
             <a:extLst xmlns:a="http://schemas.openxmlformats.org/drawingml/2006/main">
               <a:ext uri="{FF2B5EF4-FFF2-40B4-BE49-F238E27FC236}">
-                <a16:creationId xmlns:a16="http://schemas.microsoft.com/office/drawing/2014/main" id="{56C1F4E9-1399-43E9-B925-271ECB5DB3F2}"/>
-              </a:ext>
-            </a:extLst>
-          </p:cNvPr>
-          <p:cNvSpPr>
-            <a:spLocks xmlns:a="http://schemas.openxmlformats.org/drawingml/2006/main" noGrp="1"/>
-          </p:cNvSpPr>
-          <p:nvPr/>
-        </p:nvSpPr>
-        <p:spPr>
-          <a:xfrm xmlns:a="http://schemas.openxmlformats.org/drawingml/2006/main">
-            <a:off x="8562975" y="3524250"/>
-            <a:ext cx="952500" cy="495300"/>
+                <a16:creationId xmlns:a16="http://schemas.microsoft.com/office/drawing/2014/main" id="{1CF5C20A-7A19-413E-B7E5-83A45A81A46B}"/>
+              </a:ext>
+            </a:extLst>
+          </p:cNvPr>
+          <p:cNvSpPr>
+            <a:spLocks xmlns:a="http://schemas.openxmlformats.org/drawingml/2006/main" noGrp="1"/>
+          </p:cNvSpPr>
+          <p:nvPr/>
+        </p:nvSpPr>
+        <p:spPr>
+          <a:xfrm xmlns:a="http://schemas.openxmlformats.org/drawingml/2006/main">
+            <a:off x="9810750" y="3695700"/>
+            <a:ext cx="1143000" cy="495300"/>
           </a:xfrm>
           <a:prstGeom xmlns:a="http://schemas.openxmlformats.org/drawingml/2006/main" prst="roundRect">
             <a:avLst>
@@ -14407,107 +14409,48 @@
             <a:pPr algn="ctr">
               <a:defRPr sz="1425" b="1">
                 <a:solidFill>
-                  <a:srgbClr val="28745A"/>
+                  <a:srgbClr val="C8161E"/>
                 </a:solidFill>
               </a:defRPr>
             </a:pPr>
             <a:r>
               <a:rPr sz="1425" b="1">
                 <a:solidFill>
-                  <a:srgbClr val="28745A"/>
-                </a:solidFill>
-                <a:latin typeface="Microsoft YaHei"/>
-                <a:ea typeface="Microsoft YaHei"/>
-                <a:cs typeface="Microsoft YaHei"/>
-              </a:rPr>
-              <a:t>四句</a:t>
-            </a:r>
-          </a:p>
-        </p:txBody>
-      </p:sp>
-      <p:sp>
-        <p:nvSpPr>
-          <p:cNvPr id="26" name="p17-m4">
-            <a:extLst xmlns:a="http://schemas.openxmlformats.org/drawingml/2006/main">
-              <a:ext uri="{FF2B5EF4-FFF2-40B4-BE49-F238E27FC236}">
-                <a16:creationId xmlns:a16="http://schemas.microsoft.com/office/drawing/2014/main" id="{5BADA80D-D07C-42D7-819B-4C355E41ED06}"/>
-              </a:ext>
-            </a:extLst>
-          </p:cNvPr>
-          <p:cNvSpPr>
-            <a:spLocks xmlns:a="http://schemas.openxmlformats.org/drawingml/2006/main" noGrp="1"/>
-          </p:cNvSpPr>
-          <p:nvPr/>
-        </p:nvSpPr>
-        <p:spPr>
-          <a:xfrm xmlns:a="http://schemas.openxmlformats.org/drawingml/2006/main">
-            <a:off x="9610725" y="3524250"/>
-            <a:ext cx="571500" cy="495300"/>
-          </a:xfrm>
-          <a:prstGeom xmlns:a="http://schemas.openxmlformats.org/drawingml/2006/main" prst="roundRect">
-            <a:avLst>
-              <a:gd name="adj" fmla="val 15385"/>
-            </a:avLst>
-          </a:prstGeom>
-          <a:solidFill xmlns:a="http://schemas.openxmlformats.org/drawingml/2006/main">
-            <a:srgbClr val="C8161E"/>
-          </a:solidFill>
-          <a:ln xmlns:a="http://schemas.openxmlformats.org/drawingml/2006/main" w="0">
-            <a:noFill/>
-            <a:prstDash val="solid"/>
-          </a:ln>
-        </p:spPr>
-        <p:txBody>
-          <a:bodyPr xmlns:a="http://schemas.openxmlformats.org/drawingml/2006/main" lIns="76200" tIns="38100" rIns="76200" bIns="38100" anchor="ctr"/>
-          <a:lstStyle xmlns:a="http://schemas.openxmlformats.org/drawingml/2006/main"/>
-          <a:p xmlns:a="http://schemas.openxmlformats.org/drawingml/2006/main">
-            <a:pPr algn="ctr">
-              <a:defRPr sz="1350" b="1">
-                <a:solidFill>
-                  <a:srgbClr val="FFFFFF"/>
-                </a:solidFill>
-              </a:defRPr>
-            </a:pPr>
-            <a:r>
-              <a:rPr sz="1350" b="1">
-                <a:solidFill>
-                  <a:srgbClr val="FFFFFF"/>
-                </a:solidFill>
-                <a:latin typeface="Microsoft YaHei"/>
-                <a:ea typeface="Microsoft YaHei"/>
-                <a:cs typeface="Microsoft YaHei"/>
-              </a:rPr>
-              <a:t>4′</a:t>
-            </a:r>
-          </a:p>
-        </p:txBody>
-      </p:sp>
-      <p:sp>
-        <p:nvSpPr>
-          <p:cNvPr id="27" name="p17-p4">
-            <a:extLst xmlns:a="http://schemas.openxmlformats.org/drawingml/2006/main">
-              <a:ext uri="{FF2B5EF4-FFF2-40B4-BE49-F238E27FC236}">
-                <a16:creationId xmlns:a16="http://schemas.microsoft.com/office/drawing/2014/main" id="{59C462E1-6933-4BAE-B749-7C9848518080}"/>
-              </a:ext>
-            </a:extLst>
-          </p:cNvPr>
-          <p:cNvSpPr>
-            <a:spLocks xmlns:a="http://schemas.openxmlformats.org/drawingml/2006/main" noGrp="1"/>
-          </p:cNvSpPr>
-          <p:nvPr/>
-        </p:nvSpPr>
-        <p:spPr>
-          <a:xfrm xmlns:a="http://schemas.openxmlformats.org/drawingml/2006/main">
-            <a:off x="10239375" y="3524250"/>
-            <a:ext cx="952500" cy="495300"/>
-          </a:xfrm>
-          <a:prstGeom xmlns:a="http://schemas.openxmlformats.org/drawingml/2006/main" prst="roundRect">
-            <a:avLst>
-              <a:gd name="adj" fmla="val 15385"/>
-            </a:avLst>
-          </a:prstGeom>
-          <a:solidFill xmlns:a="http://schemas.openxmlformats.org/drawingml/2006/main">
-            <a:srgbClr val="FFFFFF"/>
+                  <a:srgbClr val="C8161E"/>
+                </a:solidFill>
+                <a:latin typeface="Microsoft YaHei"/>
+                <a:ea typeface="Microsoft YaHei"/>
+                <a:cs typeface="Microsoft YaHei"/>
+              </a:rPr>
+              <a:t>审计/保存</a:t>
+            </a:r>
+          </a:p>
+        </p:txBody>
+      </p:sp>
+      <p:sp>
+        <p:nvSpPr>
+          <p:cNvPr id="26" name="p17-log">
+            <a:extLst xmlns:a="http://schemas.openxmlformats.org/drawingml/2006/main">
+              <a:ext uri="{FF2B5EF4-FFF2-40B4-BE49-F238E27FC236}">
+                <a16:creationId xmlns:a16="http://schemas.microsoft.com/office/drawing/2014/main" id="{EDA8A1AF-3FC7-4C99-BE5A-9D20DC4A3DAE}"/>
+              </a:ext>
+            </a:extLst>
+          </p:cNvPr>
+          <p:cNvSpPr>
+            <a:spLocks xmlns:a="http://schemas.openxmlformats.org/drawingml/2006/main" noGrp="1"/>
+          </p:cNvSpPr>
+          <p:nvPr/>
+        </p:nvSpPr>
+        <p:spPr>
+          <a:xfrm xmlns:a="http://schemas.openxmlformats.org/drawingml/2006/main">
+            <a:off x="952500" y="4457700"/>
+            <a:ext cx="10287000" cy="438150"/>
+          </a:xfrm>
+          <a:prstGeom xmlns:a="http://schemas.openxmlformats.org/drawingml/2006/main" prst="rect">
+            <a:avLst/>
+          </a:prstGeom>
+          <a:solidFill xmlns:a="http://schemas.openxmlformats.org/drawingml/2006/main">
+            <a:srgbClr val="F3F6F7"/>
           </a:solidFill>
           <a:ln xmlns:a="http://schemas.openxmlformats.org/drawingml/2006/main" w="9525">
             <a:solidFill>
@@ -14521,63 +14464,6 @@
           <a:lstStyle xmlns:a="http://schemas.openxmlformats.org/drawingml/2006/main"/>
           <a:p xmlns:a="http://schemas.openxmlformats.org/drawingml/2006/main">
             <a:pPr algn="ctr">
-              <a:defRPr sz="1425" b="1">
-                <a:solidFill>
-                  <a:srgbClr val="C8161E"/>
-                </a:solidFill>
-              </a:defRPr>
-            </a:pPr>
-            <a:r>
-              <a:rPr sz="1425" b="1">
-                <a:solidFill>
-                  <a:srgbClr val="C8161E"/>
-                </a:solidFill>
-                <a:latin typeface="Microsoft YaHei"/>
-                <a:ea typeface="Microsoft YaHei"/>
-                <a:cs typeface="Microsoft YaHei"/>
-              </a:rPr>
-              <a:t>核验/保存</a:t>
-            </a:r>
-          </a:p>
-        </p:txBody>
-      </p:sp>
-      <p:sp>
-        <p:nvSpPr>
-          <p:cNvPr id="28" name="p17-log">
-            <a:extLst xmlns:a="http://schemas.openxmlformats.org/drawingml/2006/main">
-              <a:ext uri="{FF2B5EF4-FFF2-40B4-BE49-F238E27FC236}">
-                <a16:creationId xmlns:a16="http://schemas.microsoft.com/office/drawing/2014/main" id="{753B8349-DD6F-4656-AEB3-E55919E6400F}"/>
-              </a:ext>
-            </a:extLst>
-          </p:cNvPr>
-          <p:cNvSpPr>
-            <a:spLocks xmlns:a="http://schemas.openxmlformats.org/drawingml/2006/main" noGrp="1"/>
-          </p:cNvSpPr>
-          <p:nvPr/>
-        </p:nvSpPr>
-        <p:spPr>
-          <a:xfrm xmlns:a="http://schemas.openxmlformats.org/drawingml/2006/main">
-            <a:off x="952500" y="4400550"/>
-            <a:ext cx="10287000" cy="457200"/>
-          </a:xfrm>
-          <a:prstGeom xmlns:a="http://schemas.openxmlformats.org/drawingml/2006/main" prst="rect">
-            <a:avLst/>
-          </a:prstGeom>
-          <a:solidFill xmlns:a="http://schemas.openxmlformats.org/drawingml/2006/main">
-            <a:srgbClr val="F3F6F7"/>
-          </a:solidFill>
-          <a:ln xmlns:a="http://schemas.openxmlformats.org/drawingml/2006/main" w="9525">
-            <a:solidFill>
-              <a:srgbClr val="D6DDE2"/>
-            </a:solidFill>
-            <a:prstDash val="solid"/>
-          </a:ln>
-        </p:spPr>
-        <p:txBody>
-          <a:bodyPr xmlns:a="http://schemas.openxmlformats.org/drawingml/2006/main" lIns="76200" tIns="38100" rIns="76200" bIns="38100" anchor="ctr"/>
-          <a:lstStyle xmlns:a="http://schemas.openxmlformats.org/drawingml/2006/main"/>
-          <a:p xmlns:a="http://schemas.openxmlformats.org/drawingml/2006/main">
-            <a:pPr algn="ctr">
               <a:defRPr sz="1425" b="0">
                 <a:solidFill>
                   <a:srgbClr val="263746"/>
@@ -14600,22 +14486,22 @@
       </p:sp>
       <p:sp>
         <p:nvSpPr>
-          <p:cNvPr id="29" name="p17-save">
-            <a:extLst xmlns:a="http://schemas.openxmlformats.org/drawingml/2006/main">
-              <a:ext uri="{FF2B5EF4-FFF2-40B4-BE49-F238E27FC236}">
-                <a16:creationId xmlns:a16="http://schemas.microsoft.com/office/drawing/2014/main" id="{E9B35E79-4FCA-42ED-9FB9-736DAECB87D3}"/>
-              </a:ext>
-            </a:extLst>
-          </p:cNvPr>
-          <p:cNvSpPr>
-            <a:spLocks xmlns:a="http://schemas.openxmlformats.org/drawingml/2006/main" noGrp="1"/>
-          </p:cNvSpPr>
-          <p:nvPr/>
-        </p:nvSpPr>
-        <p:spPr>
-          <a:xfrm xmlns:a="http://schemas.openxmlformats.org/drawingml/2006/main">
-            <a:off x="1190625" y="5029200"/>
-            <a:ext cx="9810750" cy="514350"/>
+          <p:cNvPr id="27" name="p17-save">
+            <a:extLst xmlns:a="http://schemas.openxmlformats.org/drawingml/2006/main">
+              <a:ext uri="{FF2B5EF4-FFF2-40B4-BE49-F238E27FC236}">
+                <a16:creationId xmlns:a16="http://schemas.microsoft.com/office/drawing/2014/main" id="{242F3F82-6BA9-4C7D-904C-C9ACA218A276}"/>
+              </a:ext>
+            </a:extLst>
+          </p:cNvPr>
+          <p:cNvSpPr>
+            <a:spLocks xmlns:a="http://schemas.openxmlformats.org/drawingml/2006/main" noGrp="1"/>
+          </p:cNvSpPr>
+          <p:nvPr/>
+        </p:nvSpPr>
+        <p:spPr>
+          <a:xfrm xmlns:a="http://schemas.openxmlformats.org/drawingml/2006/main">
+            <a:off x="1000125" y="5067300"/>
+            <a:ext cx="10191750" cy="514350"/>
           </a:xfrm>
           <a:prstGeom xmlns:a="http://schemas.openxmlformats.org/drawingml/2006/main" prst="rect">
             <a:avLst/>
@@ -14633,14 +14519,14 @@
           <a:lstStyle xmlns:a="http://schemas.openxmlformats.org/drawingml/2006/main"/>
           <a:p xmlns:a="http://schemas.openxmlformats.org/drawingml/2006/main">
             <a:pPr algn="ctr">
-              <a:defRPr sz="1575" b="1">
+              <a:defRPr sz="1500" b="1">
                 <a:solidFill>
                   <a:srgbClr val="C8161E"/>
                 </a:solidFill>
               </a:defRPr>
             </a:pPr>
             <a:r>
-              <a:rPr sz="1575" b="1">
+              <a:rPr sz="1500" b="1">
                 <a:solidFill>
                   <a:srgbClr val="C8161E"/>
                 </a:solidFill>
@@ -14648,7 +14534,7 @@
                 <a:ea typeface="Microsoft YaHei"/>
                 <a:cs typeface="Microsoft YaHei"/>
               </a:rPr>
-              <a:t>写入 evidence-map.md 或 notes/　｜　网络失败：用预录样例或纸面模板继续</a:t>
+              <a:t>课堂最低产出完成即可｜网络失败：用预录样例或纸面模板继续｜第 6 课前补齐三步空白检验</a:t>
             </a:r>
           </a:p>
         </p:txBody>
@@ -14750,7 +14636,7 @@
           <p:cNvPr id="6" name="p18-n0">
             <a:extLst xmlns:a="http://schemas.openxmlformats.org/drawingml/2006/main">
               <a:ext uri="{FF2B5EF4-FFF2-40B4-BE49-F238E27FC236}">
-                <a16:creationId xmlns:a16="http://schemas.microsoft.com/office/drawing/2014/main" id="{87074726-1DAC-4F57-96BD-E57BE8C729D5}"/>
+                <a16:creationId xmlns:a16="http://schemas.microsoft.com/office/drawing/2014/main" id="{F3F0E612-1C0E-4724-AA01-A0364E1B8D8F}"/>
               </a:ext>
             </a:extLst>
           </p:cNvPr>
@@ -14807,7 +14693,7 @@
           <p:cNvPr id="7" name="p18-h0">
             <a:extLst xmlns:a="http://schemas.openxmlformats.org/drawingml/2006/main">
               <a:ext uri="{FF2B5EF4-FFF2-40B4-BE49-F238E27FC236}">
-                <a16:creationId xmlns:a16="http://schemas.microsoft.com/office/drawing/2014/main" id="{F6FDEC7B-4146-4A3E-A94A-D676945AE8AF}"/>
+                <a16:creationId xmlns:a16="http://schemas.microsoft.com/office/drawing/2014/main" id="{5E2037C3-722D-4D2C-8FA2-068392B5C9AA}"/>
               </a:ext>
             </a:extLst>
           </p:cNvPr>
@@ -14864,7 +14750,7 @@
           <p:cNvPr id="8" name="p18-d0">
             <a:extLst xmlns:a="http://schemas.openxmlformats.org/drawingml/2006/main">
               <a:ext uri="{FF2B5EF4-FFF2-40B4-BE49-F238E27FC236}">
-                <a16:creationId xmlns:a16="http://schemas.microsoft.com/office/drawing/2014/main" id="{A4383188-46A7-4DAA-8EF8-3D365DB91B6F}"/>
+                <a16:creationId xmlns:a16="http://schemas.microsoft.com/office/drawing/2014/main" id="{26C57F2A-B23A-4F3C-BC88-580457EC4661}"/>
               </a:ext>
             </a:extLst>
           </p:cNvPr>
@@ -14923,7 +14809,7 @@
           <p:cNvPr id="9" name="p18-n1">
             <a:extLst xmlns:a="http://schemas.openxmlformats.org/drawingml/2006/main">
               <a:ext uri="{FF2B5EF4-FFF2-40B4-BE49-F238E27FC236}">
-                <a16:creationId xmlns:a16="http://schemas.microsoft.com/office/drawing/2014/main" id="{39D76D86-0096-4A24-84CA-16ED85D195AD}"/>
+                <a16:creationId xmlns:a16="http://schemas.microsoft.com/office/drawing/2014/main" id="{ABBF8A35-5C33-45FF-9469-D9218CDB71C8}"/>
               </a:ext>
             </a:extLst>
           </p:cNvPr>
@@ -14980,7 +14866,7 @@
           <p:cNvPr id="10" name="p18-h1">
             <a:extLst xmlns:a="http://schemas.openxmlformats.org/drawingml/2006/main">
               <a:ext uri="{FF2B5EF4-FFF2-40B4-BE49-F238E27FC236}">
-                <a16:creationId xmlns:a16="http://schemas.microsoft.com/office/drawing/2014/main" id="{530FA112-673B-4D1F-93BC-22DFF27C7BAE}"/>
+                <a16:creationId xmlns:a16="http://schemas.microsoft.com/office/drawing/2014/main" id="{C76F83DE-C206-443B-AF4C-7202866D8438}"/>
               </a:ext>
             </a:extLst>
           </p:cNvPr>
@@ -15037,7 +14923,7 @@
           <p:cNvPr id="11" name="p18-d1">
             <a:extLst xmlns:a="http://schemas.openxmlformats.org/drawingml/2006/main">
               <a:ext uri="{FF2B5EF4-FFF2-40B4-BE49-F238E27FC236}">
-                <a16:creationId xmlns:a16="http://schemas.microsoft.com/office/drawing/2014/main" id="{F01A256C-3A6B-4E6C-84AD-434DBB21B6D6}"/>
+                <a16:creationId xmlns:a16="http://schemas.microsoft.com/office/drawing/2014/main" id="{FAA71AB3-8FE9-418B-9728-A040A3407ABB}"/>
               </a:ext>
             </a:extLst>
           </p:cNvPr>
@@ -15096,7 +14982,7 @@
           <p:cNvPr id="12" name="p18-n2">
             <a:extLst xmlns:a="http://schemas.openxmlformats.org/drawingml/2006/main">
               <a:ext uri="{FF2B5EF4-FFF2-40B4-BE49-F238E27FC236}">
-                <a16:creationId xmlns:a16="http://schemas.microsoft.com/office/drawing/2014/main" id="{04FE48FD-01B3-44AD-9D00-E2162FF4A748}"/>
+                <a16:creationId xmlns:a16="http://schemas.microsoft.com/office/drawing/2014/main" id="{23BB542A-200A-467C-A6F8-6362B9EA90E7}"/>
               </a:ext>
             </a:extLst>
           </p:cNvPr>
@@ -15153,7 +15039,7 @@
           <p:cNvPr id="13" name="p18-h2">
             <a:extLst xmlns:a="http://schemas.openxmlformats.org/drawingml/2006/main">
               <a:ext uri="{FF2B5EF4-FFF2-40B4-BE49-F238E27FC236}">
-                <a16:creationId xmlns:a16="http://schemas.microsoft.com/office/drawing/2014/main" id="{98C9DC86-9F51-49F6-A528-E283C01F302D}"/>
+                <a16:creationId xmlns:a16="http://schemas.microsoft.com/office/drawing/2014/main" id="{B0C729A0-D6E2-46EE-80A1-4A8819A849B4}"/>
               </a:ext>
             </a:extLst>
           </p:cNvPr>
@@ -15210,7 +15096,7 @@
           <p:cNvPr id="14" name="p18-d2">
             <a:extLst xmlns:a="http://schemas.openxmlformats.org/drawingml/2006/main">
               <a:ext uri="{FF2B5EF4-FFF2-40B4-BE49-F238E27FC236}">
-                <a16:creationId xmlns:a16="http://schemas.microsoft.com/office/drawing/2014/main" id="{BC4AEAD2-0C5A-4301-A418-DF3EA72AE2C5}"/>
+                <a16:creationId xmlns:a16="http://schemas.microsoft.com/office/drawing/2014/main" id="{F3B23053-D689-420D-B241-754AAF2A4E32}"/>
               </a:ext>
             </a:extLst>
           </p:cNvPr>
@@ -15269,7 +15155,7 @@
           <p:cNvPr id="15" name="p18-n3">
             <a:extLst xmlns:a="http://schemas.openxmlformats.org/drawingml/2006/main">
               <a:ext uri="{FF2B5EF4-FFF2-40B4-BE49-F238E27FC236}">
-                <a16:creationId xmlns:a16="http://schemas.microsoft.com/office/drawing/2014/main" id="{0D5F2894-CF35-4857-8788-874A3126AEBE}"/>
+                <a16:creationId xmlns:a16="http://schemas.microsoft.com/office/drawing/2014/main" id="{AC22ADB0-EF79-4690-B610-F6BD83932883}"/>
               </a:ext>
             </a:extLst>
           </p:cNvPr>
@@ -15326,7 +15212,7 @@
           <p:cNvPr id="16" name="p18-h3">
             <a:extLst xmlns:a="http://schemas.openxmlformats.org/drawingml/2006/main">
               <a:ext uri="{FF2B5EF4-FFF2-40B4-BE49-F238E27FC236}">
-                <a16:creationId xmlns:a16="http://schemas.microsoft.com/office/drawing/2014/main" id="{AB55370C-8189-4187-BAFA-C669C9D72C78}"/>
+                <a16:creationId xmlns:a16="http://schemas.microsoft.com/office/drawing/2014/main" id="{C0D1EF0E-28CC-4091-82F6-989E639E10C4}"/>
               </a:ext>
             </a:extLst>
           </p:cNvPr>
@@ -15383,7 +15269,7 @@
           <p:cNvPr id="17" name="p18-d3">
             <a:extLst xmlns:a="http://schemas.openxmlformats.org/drawingml/2006/main">
               <a:ext uri="{FF2B5EF4-FFF2-40B4-BE49-F238E27FC236}">
-                <a16:creationId xmlns:a16="http://schemas.microsoft.com/office/drawing/2014/main" id="{409ED6BA-C8A4-4DAD-9F28-0E6CD03893D4}"/>
+                <a16:creationId xmlns:a16="http://schemas.microsoft.com/office/drawing/2014/main" id="{15DB583D-B804-4115-9F55-2F3073D45DCD}"/>
               </a:ext>
             </a:extLst>
           </p:cNvPr>
@@ -15442,7 +15328,7 @@
           <p:cNvPr id="18" name="p18-author-h">
             <a:extLst xmlns:a="http://schemas.openxmlformats.org/drawingml/2006/main">
               <a:ext uri="{FF2B5EF4-FFF2-40B4-BE49-F238E27FC236}">
-                <a16:creationId xmlns:a16="http://schemas.microsoft.com/office/drawing/2014/main" id="{0F5E0110-5E45-4D26-AE84-844C40FA30F1}"/>
+                <a16:creationId xmlns:a16="http://schemas.microsoft.com/office/drawing/2014/main" id="{A82C880D-8475-4B37-80C4-CB7ACF14D0CB}"/>
               </a:ext>
             </a:extLst>
           </p:cNvPr>
@@ -15497,7 +15383,7 @@
           <p:cNvPr id="19" name="p18-s0">
             <a:extLst xmlns:a="http://schemas.openxmlformats.org/drawingml/2006/main">
               <a:ext uri="{FF2B5EF4-FFF2-40B4-BE49-F238E27FC236}">
-                <a16:creationId xmlns:a16="http://schemas.microsoft.com/office/drawing/2014/main" id="{FB5AEDA7-D939-454A-8971-AB5031E1AE27}"/>
+                <a16:creationId xmlns:a16="http://schemas.microsoft.com/office/drawing/2014/main" id="{A639190C-8A27-4349-A230-11E806F939E9}"/>
               </a:ext>
             </a:extLst>
           </p:cNvPr>
@@ -15554,7 +15440,7 @@
           <p:cNvPr id="20" name="p18-s1">
             <a:extLst xmlns:a="http://schemas.openxmlformats.org/drawingml/2006/main">
               <a:ext uri="{FF2B5EF4-FFF2-40B4-BE49-F238E27FC236}">
-                <a16:creationId xmlns:a16="http://schemas.microsoft.com/office/drawing/2014/main" id="{54837DEC-9D61-4C8B-97C9-7F91DBEF6B1D}"/>
+                <a16:creationId xmlns:a16="http://schemas.microsoft.com/office/drawing/2014/main" id="{0A801A94-2F91-452D-81C0-9A1AD0D6DFBD}"/>
               </a:ext>
             </a:extLst>
           </p:cNvPr>
@@ -15611,7 +15497,7 @@
           <p:cNvPr id="21" name="p18-s2">
             <a:extLst xmlns:a="http://schemas.openxmlformats.org/drawingml/2006/main">
               <a:ext uri="{FF2B5EF4-FFF2-40B4-BE49-F238E27FC236}">
-                <a16:creationId xmlns:a16="http://schemas.microsoft.com/office/drawing/2014/main" id="{1B12C93E-A164-4DA7-8A21-4C828ADFCC67}"/>
+                <a16:creationId xmlns:a16="http://schemas.microsoft.com/office/drawing/2014/main" id="{4424C58B-1422-4F0C-B31E-5E7954F586A9}"/>
               </a:ext>
             </a:extLst>
           </p:cNvPr>
@@ -15668,7 +15554,7 @@
           <p:cNvPr id="22" name="p18-bottom">
             <a:extLst xmlns:a="http://schemas.openxmlformats.org/drawingml/2006/main">
               <a:ext uri="{FF2B5EF4-FFF2-40B4-BE49-F238E27FC236}">
-                <a16:creationId xmlns:a16="http://schemas.microsoft.com/office/drawing/2014/main" id="{5293A175-8839-4D37-A442-06A3CBA01BAD}"/>
+                <a16:creationId xmlns:a16="http://schemas.microsoft.com/office/drawing/2014/main" id="{D4C000ED-10ED-421B-B057-92EF7851B0A4}"/>
               </a:ext>
             </a:extLst>
           </p:cNvPr>
@@ -15813,7 +15699,7 @@
           <p:cNvPr id="6" name="p19-in0">
             <a:extLst xmlns:a="http://schemas.openxmlformats.org/drawingml/2006/main">
               <a:ext uri="{FF2B5EF4-FFF2-40B4-BE49-F238E27FC236}">
-                <a16:creationId xmlns:a16="http://schemas.microsoft.com/office/drawing/2014/main" id="{369215A1-0C03-4629-B862-F680DF44C377}"/>
+                <a16:creationId xmlns:a16="http://schemas.microsoft.com/office/drawing/2014/main" id="{940811A6-C9C0-49D8-98E2-75480586704B}"/>
               </a:ext>
             </a:extLst>
           </p:cNvPr>
@@ -15872,7 +15758,7 @@
           <p:cNvPr id="7" name="p19-a0">
             <a:extLst xmlns:a="http://schemas.openxmlformats.org/drawingml/2006/main">
               <a:ext uri="{FF2B5EF4-FFF2-40B4-BE49-F238E27FC236}">
-                <a16:creationId xmlns:a16="http://schemas.microsoft.com/office/drawing/2014/main" id="{124DA012-B3A4-4752-96D8-14F4B8413AEB}"/>
+                <a16:creationId xmlns:a16="http://schemas.microsoft.com/office/drawing/2014/main" id="{5C755EFC-B1D7-49FE-9C1B-28F56079F035}"/>
               </a:ext>
             </a:extLst>
           </p:cNvPr>
@@ -15925,7 +15811,7 @@
           <p:cNvPr id="8" name="p19-in1">
             <a:extLst xmlns:a="http://schemas.openxmlformats.org/drawingml/2006/main">
               <a:ext uri="{FF2B5EF4-FFF2-40B4-BE49-F238E27FC236}">
-                <a16:creationId xmlns:a16="http://schemas.microsoft.com/office/drawing/2014/main" id="{6A7AC7A8-7F0B-4683-A70E-53D06DA52D59}"/>
+                <a16:creationId xmlns:a16="http://schemas.microsoft.com/office/drawing/2014/main" id="{DACF7047-BC74-4A61-B8ED-3E840D01166F}"/>
               </a:ext>
             </a:extLst>
           </p:cNvPr>
@@ -15984,7 +15870,7 @@
           <p:cNvPr id="9" name="p19-a1">
             <a:extLst xmlns:a="http://schemas.openxmlformats.org/drawingml/2006/main">
               <a:ext uri="{FF2B5EF4-FFF2-40B4-BE49-F238E27FC236}">
-                <a16:creationId xmlns:a16="http://schemas.microsoft.com/office/drawing/2014/main" id="{272C7B79-351D-462F-BCAC-FE3243E9EAB1}"/>
+                <a16:creationId xmlns:a16="http://schemas.microsoft.com/office/drawing/2014/main" id="{45AE9DF1-9C35-437D-B8A5-64A43D8ACDA5}"/>
               </a:ext>
             </a:extLst>
           </p:cNvPr>
@@ -16037,7 +15923,7 @@
           <p:cNvPr id="10" name="p19-in2">
             <a:extLst xmlns:a="http://schemas.openxmlformats.org/drawingml/2006/main">
               <a:ext uri="{FF2B5EF4-FFF2-40B4-BE49-F238E27FC236}">
-                <a16:creationId xmlns:a16="http://schemas.microsoft.com/office/drawing/2014/main" id="{2494006A-D2EF-4C24-A030-079AE0716997}"/>
+                <a16:creationId xmlns:a16="http://schemas.microsoft.com/office/drawing/2014/main" id="{EEDA0C80-9A97-4763-9D89-6CB85140DAE5}"/>
               </a:ext>
             </a:extLst>
           </p:cNvPr>
@@ -16096,7 +15982,7 @@
           <p:cNvPr id="11" name="p19-a2">
             <a:extLst xmlns:a="http://schemas.openxmlformats.org/drawingml/2006/main">
               <a:ext uri="{FF2B5EF4-FFF2-40B4-BE49-F238E27FC236}">
-                <a16:creationId xmlns:a16="http://schemas.microsoft.com/office/drawing/2014/main" id="{0720AD51-9E1E-43BE-9A0C-41A9B7CAA77D}"/>
+                <a16:creationId xmlns:a16="http://schemas.microsoft.com/office/drawing/2014/main" id="{6CC0CD8E-5F8E-4776-AB81-23FF0AE411FB}"/>
               </a:ext>
             </a:extLst>
           </p:cNvPr>
@@ -16149,7 +16035,7 @@
           <p:cNvPr id="12" name="p19-gate">
             <a:extLst xmlns:a="http://schemas.openxmlformats.org/drawingml/2006/main">
               <a:ext uri="{FF2B5EF4-FFF2-40B4-BE49-F238E27FC236}">
-                <a16:creationId xmlns:a16="http://schemas.microsoft.com/office/drawing/2014/main" id="{991E241E-73C0-40C4-B006-7789CA0C6E28}"/>
+                <a16:creationId xmlns:a16="http://schemas.microsoft.com/office/drawing/2014/main" id="{957989BC-3BE3-4C89-870C-E9C18BDE7E8C}"/>
               </a:ext>
             </a:extLst>
           </p:cNvPr>
@@ -16234,7 +16120,7 @@
           <p:cNvPr id="13" name="p19-check-h">
             <a:extLst xmlns:a="http://schemas.openxmlformats.org/drawingml/2006/main">
               <a:ext uri="{FF2B5EF4-FFF2-40B4-BE49-F238E27FC236}">
-                <a16:creationId xmlns:a16="http://schemas.microsoft.com/office/drawing/2014/main" id="{0999E4E2-0792-4D23-96D6-472379145EC0}"/>
+                <a16:creationId xmlns:a16="http://schemas.microsoft.com/office/drawing/2014/main" id="{1235EA5C-5F2F-4E73-9F41-5CF0809E0005}"/>
               </a:ext>
             </a:extLst>
           </p:cNvPr>
@@ -16289,7 +16175,7 @@
           <p:cNvPr id="14" name="p19-c0">
             <a:extLst xmlns:a="http://schemas.openxmlformats.org/drawingml/2006/main">
               <a:ext uri="{FF2B5EF4-FFF2-40B4-BE49-F238E27FC236}">
-                <a16:creationId xmlns:a16="http://schemas.microsoft.com/office/drawing/2014/main" id="{C23D2AA3-B833-4606-82E1-0034231637EE}"/>
+                <a16:creationId xmlns:a16="http://schemas.microsoft.com/office/drawing/2014/main" id="{01169736-6079-4888-B41C-C185B005604B}"/>
               </a:ext>
             </a:extLst>
           </p:cNvPr>
@@ -16348,7 +16234,7 @@
           <p:cNvPr id="15" name="p19-c1">
             <a:extLst xmlns:a="http://schemas.openxmlformats.org/drawingml/2006/main">
               <a:ext uri="{FF2B5EF4-FFF2-40B4-BE49-F238E27FC236}">
-                <a16:creationId xmlns:a16="http://schemas.microsoft.com/office/drawing/2014/main" id="{970C8727-B7A6-4801-B62B-B615FB48C3DE}"/>
+                <a16:creationId xmlns:a16="http://schemas.microsoft.com/office/drawing/2014/main" id="{5C7849FA-0655-4E80-AC54-6EC69FD0EC98}"/>
               </a:ext>
             </a:extLst>
           </p:cNvPr>
@@ -16407,7 +16293,7 @@
           <p:cNvPr id="16" name="p19-c2">
             <a:extLst xmlns:a="http://schemas.openxmlformats.org/drawingml/2006/main">
               <a:ext uri="{FF2B5EF4-FFF2-40B4-BE49-F238E27FC236}">
-                <a16:creationId xmlns:a16="http://schemas.microsoft.com/office/drawing/2014/main" id="{84BAA3D6-3A5B-4F3F-AD75-85B530B46BAC}"/>
+                <a16:creationId xmlns:a16="http://schemas.microsoft.com/office/drawing/2014/main" id="{02D49489-B614-4E44-9FF2-03BD72B8F932}"/>
               </a:ext>
             </a:extLst>
           </p:cNvPr>
@@ -16466,7 +16352,7 @@
           <p:cNvPr id="17" name="p19-path">
             <a:extLst xmlns:a="http://schemas.openxmlformats.org/drawingml/2006/main">
               <a:ext uri="{FF2B5EF4-FFF2-40B4-BE49-F238E27FC236}">
-                <a16:creationId xmlns:a16="http://schemas.microsoft.com/office/drawing/2014/main" id="{85799915-87D5-4A54-A252-E572CD3F711D}"/>
+                <a16:creationId xmlns:a16="http://schemas.microsoft.com/office/drawing/2014/main" id="{64B50295-F848-4619-8AAA-22CB217467CF}"/>
               </a:ext>
             </a:extLst>
           </p:cNvPr>
@@ -16525,7 +16411,7 @@
           <p:cNvPr id="18" name="p19-bottom">
             <a:extLst xmlns:a="http://schemas.openxmlformats.org/drawingml/2006/main">
               <a:ext uri="{FF2B5EF4-FFF2-40B4-BE49-F238E27FC236}">
-                <a16:creationId xmlns:a16="http://schemas.microsoft.com/office/drawing/2014/main" id="{4B799BCD-A481-463A-948A-34BB501B2366}"/>
+                <a16:creationId xmlns:a16="http://schemas.microsoft.com/office/drawing/2014/main" id="{949367C9-A2D5-4271-8A08-508FA254EA33}"/>
               </a:ext>
             </a:extLst>
           </p:cNvPr>
@@ -16672,7 +16558,7 @@
           <p:cNvPr id="6" name="p02-left-h">
             <a:extLst xmlns:a="http://schemas.openxmlformats.org/drawingml/2006/main">
               <a:ext uri="{FF2B5EF4-FFF2-40B4-BE49-F238E27FC236}">
-                <a16:creationId xmlns:a16="http://schemas.microsoft.com/office/drawing/2014/main" id="{B1637563-C7CE-410A-8AB8-7D64A2886C35}"/>
+                <a16:creationId xmlns:a16="http://schemas.microsoft.com/office/drawing/2014/main" id="{7DA734E9-5612-4530-9F29-5FDA90FC7210}"/>
               </a:ext>
             </a:extLst>
           </p:cNvPr>
@@ -16727,7 +16613,7 @@
           <p:cNvPr id="7" name="p02-left-0">
             <a:extLst xmlns:a="http://schemas.openxmlformats.org/drawingml/2006/main">
               <a:ext uri="{FF2B5EF4-FFF2-40B4-BE49-F238E27FC236}">
-                <a16:creationId xmlns:a16="http://schemas.microsoft.com/office/drawing/2014/main" id="{6AD4FF24-49A8-4F54-AC49-49AE1C3EDC3C}"/>
+                <a16:creationId xmlns:a16="http://schemas.microsoft.com/office/drawing/2014/main" id="{60BBAC4A-DD1F-4B9D-B4C3-C2154323B494}"/>
               </a:ext>
             </a:extLst>
           </p:cNvPr>
@@ -16786,7 +16672,7 @@
           <p:cNvPr id="8" name="p02-left-1">
             <a:extLst xmlns:a="http://schemas.openxmlformats.org/drawingml/2006/main">
               <a:ext uri="{FF2B5EF4-FFF2-40B4-BE49-F238E27FC236}">
-                <a16:creationId xmlns:a16="http://schemas.microsoft.com/office/drawing/2014/main" id="{C155B050-C474-44EF-9430-0F4E9693FA51}"/>
+                <a16:creationId xmlns:a16="http://schemas.microsoft.com/office/drawing/2014/main" id="{24CF31D1-5D75-4A98-A18B-2B778B9DE09A}"/>
               </a:ext>
             </a:extLst>
           </p:cNvPr>
@@ -16845,7 +16731,7 @@
           <p:cNvPr id="9" name="p02-left-2">
             <a:extLst xmlns:a="http://schemas.openxmlformats.org/drawingml/2006/main">
               <a:ext uri="{FF2B5EF4-FFF2-40B4-BE49-F238E27FC236}">
-                <a16:creationId xmlns:a16="http://schemas.microsoft.com/office/drawing/2014/main" id="{ECAFF831-CE07-41BD-A35D-DABEECEEF242}"/>
+                <a16:creationId xmlns:a16="http://schemas.microsoft.com/office/drawing/2014/main" id="{59A8CD17-9EAB-47CA-97C1-E7B9D6376EAA}"/>
               </a:ext>
             </a:extLst>
           </p:cNvPr>
@@ -16904,7 +16790,7 @@
           <p:cNvPr id="10" name="p02-arrow">
             <a:extLst xmlns:a="http://schemas.openxmlformats.org/drawingml/2006/main">
               <a:ext uri="{FF2B5EF4-FFF2-40B4-BE49-F238E27FC236}">
-                <a16:creationId xmlns:a16="http://schemas.microsoft.com/office/drawing/2014/main" id="{2FD43111-AB2D-4B7F-807F-46CCEB4F972F}"/>
+                <a16:creationId xmlns:a16="http://schemas.microsoft.com/office/drawing/2014/main" id="{BC5CFB5B-86BA-4E0A-9F77-6B8223EA723F}"/>
               </a:ext>
             </a:extLst>
           </p:cNvPr>
@@ -16957,7 +16843,7 @@
           <p:cNvPr id="11" name="p02-right-h">
             <a:extLst xmlns:a="http://schemas.openxmlformats.org/drawingml/2006/main">
               <a:ext uri="{FF2B5EF4-FFF2-40B4-BE49-F238E27FC236}">
-                <a16:creationId xmlns:a16="http://schemas.microsoft.com/office/drawing/2014/main" id="{91E637E9-2B11-467E-8F25-DB60BDF72152}"/>
+                <a16:creationId xmlns:a16="http://schemas.microsoft.com/office/drawing/2014/main" id="{7C8F4FBF-BF4D-4F53-8E0D-7A2815F51E7A}"/>
               </a:ext>
             </a:extLst>
           </p:cNvPr>
@@ -17012,7 +16898,7 @@
           <p:cNvPr id="12" name="p02-right-0">
             <a:extLst xmlns:a="http://schemas.openxmlformats.org/drawingml/2006/main">
               <a:ext uri="{FF2B5EF4-FFF2-40B4-BE49-F238E27FC236}">
-                <a16:creationId xmlns:a16="http://schemas.microsoft.com/office/drawing/2014/main" id="{0A204674-EAF1-4618-994F-049AA46EA2AA}"/>
+                <a16:creationId xmlns:a16="http://schemas.microsoft.com/office/drawing/2014/main" id="{488D31E2-BE61-4149-BD49-1497D69474BA}"/>
               </a:ext>
             </a:extLst>
           </p:cNvPr>
@@ -17071,7 +16957,7 @@
           <p:cNvPr id="13" name="p02-right-1">
             <a:extLst xmlns:a="http://schemas.openxmlformats.org/drawingml/2006/main">
               <a:ext uri="{FF2B5EF4-FFF2-40B4-BE49-F238E27FC236}">
-                <a16:creationId xmlns:a16="http://schemas.microsoft.com/office/drawing/2014/main" id="{55CA79FE-6611-4EE5-997D-7DDF8268D928}"/>
+                <a16:creationId xmlns:a16="http://schemas.microsoft.com/office/drawing/2014/main" id="{B9B47F78-D310-4373-95DF-B2F7DE80C03C}"/>
               </a:ext>
             </a:extLst>
           </p:cNvPr>
@@ -17130,7 +17016,7 @@
           <p:cNvPr id="14" name="p02-right-2">
             <a:extLst xmlns:a="http://schemas.openxmlformats.org/drawingml/2006/main">
               <a:ext uri="{FF2B5EF4-FFF2-40B4-BE49-F238E27FC236}">
-                <a16:creationId xmlns:a16="http://schemas.microsoft.com/office/drawing/2014/main" id="{DB64104D-1515-477D-A303-C10CA9A3A57F}"/>
+                <a16:creationId xmlns:a16="http://schemas.microsoft.com/office/drawing/2014/main" id="{88B4B9C5-066C-4085-A58A-6F000EA8EA63}"/>
               </a:ext>
             </a:extLst>
           </p:cNvPr>
@@ -17189,7 +17075,7 @@
           <p:cNvPr id="15" name="p02-bottom">
             <a:extLst xmlns:a="http://schemas.openxmlformats.org/drawingml/2006/main">
               <a:ext uri="{FF2B5EF4-FFF2-40B4-BE49-F238E27FC236}">
-                <a16:creationId xmlns:a16="http://schemas.microsoft.com/office/drawing/2014/main" id="{DC33BA81-2E6B-4C4C-A299-4C133899B5AD}"/>
+                <a16:creationId xmlns:a16="http://schemas.microsoft.com/office/drawing/2014/main" id="{2BF59140-DF93-4FCE-A2E0-FFB8A14DAF99}"/>
               </a:ext>
             </a:extLst>
           </p:cNvPr>
@@ -17334,7 +17220,7 @@
           <p:cNvPr id="6" name="p03-thesis">
             <a:extLst xmlns:a="http://schemas.openxmlformats.org/drawingml/2006/main">
               <a:ext uri="{FF2B5EF4-FFF2-40B4-BE49-F238E27FC236}">
-                <a16:creationId xmlns:a16="http://schemas.microsoft.com/office/drawing/2014/main" id="{757E5EC6-E390-495A-A0EB-90AA44931507}"/>
+                <a16:creationId xmlns:a16="http://schemas.microsoft.com/office/drawing/2014/main" id="{2F36DD86-56DD-4047-81AA-9710306D189C}"/>
               </a:ext>
             </a:extLst>
           </p:cNvPr>
@@ -17389,7 +17275,7 @@
           <p:cNvPr id="7" name="p03-n0">
             <a:extLst xmlns:a="http://schemas.openxmlformats.org/drawingml/2006/main">
               <a:ext uri="{FF2B5EF4-FFF2-40B4-BE49-F238E27FC236}">
-                <a16:creationId xmlns:a16="http://schemas.microsoft.com/office/drawing/2014/main" id="{4BE50487-32B8-4488-A25B-754AD17DE701}"/>
+                <a16:creationId xmlns:a16="http://schemas.microsoft.com/office/drawing/2014/main" id="{5B1A8D85-EA94-4111-828F-04A1FD8227B5}"/>
               </a:ext>
             </a:extLst>
           </p:cNvPr>
@@ -17446,7 +17332,7 @@
           <p:cNvPr id="8" name="p03-h0">
             <a:extLst xmlns:a="http://schemas.openxmlformats.org/drawingml/2006/main">
               <a:ext uri="{FF2B5EF4-FFF2-40B4-BE49-F238E27FC236}">
-                <a16:creationId xmlns:a16="http://schemas.microsoft.com/office/drawing/2014/main" id="{DDE5A112-6BC8-438F-90DE-AADD800E0B0C}"/>
+                <a16:creationId xmlns:a16="http://schemas.microsoft.com/office/drawing/2014/main" id="{B599746D-C2E5-4B7C-A4DA-DC0F5BCB1428}"/>
               </a:ext>
             </a:extLst>
           </p:cNvPr>
@@ -17499,7 +17385,7 @@
           <p:cNvPr id="9" name="p03-d0">
             <a:extLst xmlns:a="http://schemas.openxmlformats.org/drawingml/2006/main">
               <a:ext uri="{FF2B5EF4-FFF2-40B4-BE49-F238E27FC236}">
-                <a16:creationId xmlns:a16="http://schemas.microsoft.com/office/drawing/2014/main" id="{B35BBF9B-2E2C-47C7-82F5-77935B6F7D6C}"/>
+                <a16:creationId xmlns:a16="http://schemas.microsoft.com/office/drawing/2014/main" id="{18C55410-6AE8-40F4-A4E2-DEC2F46851E9}"/>
               </a:ext>
             </a:extLst>
           </p:cNvPr>
@@ -17556,7 +17442,7 @@
           <p:cNvPr id="10" name="p03-n1">
             <a:extLst xmlns:a="http://schemas.openxmlformats.org/drawingml/2006/main">
               <a:ext uri="{FF2B5EF4-FFF2-40B4-BE49-F238E27FC236}">
-                <a16:creationId xmlns:a16="http://schemas.microsoft.com/office/drawing/2014/main" id="{27E4BF38-D614-4DC1-868F-7F25774C85E6}"/>
+                <a16:creationId xmlns:a16="http://schemas.microsoft.com/office/drawing/2014/main" id="{7159B5C5-28A7-4A64-9969-EC543F396A2B}"/>
               </a:ext>
             </a:extLst>
           </p:cNvPr>
@@ -17613,7 +17499,7 @@
           <p:cNvPr id="11" name="p03-h1">
             <a:extLst xmlns:a="http://schemas.openxmlformats.org/drawingml/2006/main">
               <a:ext uri="{FF2B5EF4-FFF2-40B4-BE49-F238E27FC236}">
-                <a16:creationId xmlns:a16="http://schemas.microsoft.com/office/drawing/2014/main" id="{E904E882-3589-49B2-9F3F-58B66731B42F}"/>
+                <a16:creationId xmlns:a16="http://schemas.microsoft.com/office/drawing/2014/main" id="{FD933C0F-DBD6-4F60-9657-B8A988BC3FD0}"/>
               </a:ext>
             </a:extLst>
           </p:cNvPr>
@@ -17666,7 +17552,7 @@
           <p:cNvPr id="12" name="p03-d1">
             <a:extLst xmlns:a="http://schemas.openxmlformats.org/drawingml/2006/main">
               <a:ext uri="{FF2B5EF4-FFF2-40B4-BE49-F238E27FC236}">
-                <a16:creationId xmlns:a16="http://schemas.microsoft.com/office/drawing/2014/main" id="{A2D36720-3447-46BD-A140-9E7B9FCF4F25}"/>
+                <a16:creationId xmlns:a16="http://schemas.microsoft.com/office/drawing/2014/main" id="{3874C6B8-24BE-423E-BC88-8C1213502B0B}"/>
               </a:ext>
             </a:extLst>
           </p:cNvPr>
@@ -17723,7 +17609,7 @@
           <p:cNvPr id="13" name="p03-n2">
             <a:extLst xmlns:a="http://schemas.openxmlformats.org/drawingml/2006/main">
               <a:ext uri="{FF2B5EF4-FFF2-40B4-BE49-F238E27FC236}">
-                <a16:creationId xmlns:a16="http://schemas.microsoft.com/office/drawing/2014/main" id="{B1D76D08-7828-469B-B3B8-6F3B4CA31182}"/>
+                <a16:creationId xmlns:a16="http://schemas.microsoft.com/office/drawing/2014/main" id="{A77C418C-4F9F-410C-B904-9A7DC9D2138E}"/>
               </a:ext>
             </a:extLst>
           </p:cNvPr>
@@ -17780,7 +17666,7 @@
           <p:cNvPr id="14" name="p03-h2">
             <a:extLst xmlns:a="http://schemas.openxmlformats.org/drawingml/2006/main">
               <a:ext uri="{FF2B5EF4-FFF2-40B4-BE49-F238E27FC236}">
-                <a16:creationId xmlns:a16="http://schemas.microsoft.com/office/drawing/2014/main" id="{170D2F31-5F8A-41CA-990F-26EC359FF6BE}"/>
+                <a16:creationId xmlns:a16="http://schemas.microsoft.com/office/drawing/2014/main" id="{8907073F-81B1-43E7-B8AD-E760E7FF7093}"/>
               </a:ext>
             </a:extLst>
           </p:cNvPr>
@@ -17833,7 +17719,7 @@
           <p:cNvPr id="15" name="p03-d2">
             <a:extLst xmlns:a="http://schemas.openxmlformats.org/drawingml/2006/main">
               <a:ext uri="{FF2B5EF4-FFF2-40B4-BE49-F238E27FC236}">
-                <a16:creationId xmlns:a16="http://schemas.microsoft.com/office/drawing/2014/main" id="{E0298357-0D32-4B85-B0BD-101C56B94BB4}"/>
+                <a16:creationId xmlns:a16="http://schemas.microsoft.com/office/drawing/2014/main" id="{ECF7582C-B2A4-49AA-A6CB-C35315B154B6}"/>
               </a:ext>
             </a:extLst>
           </p:cNvPr>
@@ -17890,7 +17776,7 @@
           <p:cNvPr id="16" name="p03-n3">
             <a:extLst xmlns:a="http://schemas.openxmlformats.org/drawingml/2006/main">
               <a:ext uri="{FF2B5EF4-FFF2-40B4-BE49-F238E27FC236}">
-                <a16:creationId xmlns:a16="http://schemas.microsoft.com/office/drawing/2014/main" id="{275BCDD9-33CF-4D0C-AB11-D6AA737B229F}"/>
+                <a16:creationId xmlns:a16="http://schemas.microsoft.com/office/drawing/2014/main" id="{01EDCCA3-8DD3-4000-B3B9-D164E84A8F03}"/>
               </a:ext>
             </a:extLst>
           </p:cNvPr>
@@ -17947,7 +17833,7 @@
           <p:cNvPr id="17" name="p03-h3">
             <a:extLst xmlns:a="http://schemas.openxmlformats.org/drawingml/2006/main">
               <a:ext uri="{FF2B5EF4-FFF2-40B4-BE49-F238E27FC236}">
-                <a16:creationId xmlns:a16="http://schemas.microsoft.com/office/drawing/2014/main" id="{5FC2331C-0ED5-4566-89D6-DEFF8B00CE8E}"/>
+                <a16:creationId xmlns:a16="http://schemas.microsoft.com/office/drawing/2014/main" id="{CB6E584B-0E13-418C-8AFF-6395EF6922E6}"/>
               </a:ext>
             </a:extLst>
           </p:cNvPr>
@@ -18000,7 +17886,7 @@
           <p:cNvPr id="18" name="p03-d3">
             <a:extLst xmlns:a="http://schemas.openxmlformats.org/drawingml/2006/main">
               <a:ext uri="{FF2B5EF4-FFF2-40B4-BE49-F238E27FC236}">
-                <a16:creationId xmlns:a16="http://schemas.microsoft.com/office/drawing/2014/main" id="{E1876A87-3F94-419C-860B-98DD0A84CFB0}"/>
+                <a16:creationId xmlns:a16="http://schemas.microsoft.com/office/drawing/2014/main" id="{898ADEB4-BFE9-4302-97F4-17D3EE48CFAD}"/>
               </a:ext>
             </a:extLst>
           </p:cNvPr>
@@ -18057,7 +17943,7 @@
           <p:cNvPr id="19" name="p03-n4">
             <a:extLst xmlns:a="http://schemas.openxmlformats.org/drawingml/2006/main">
               <a:ext uri="{FF2B5EF4-FFF2-40B4-BE49-F238E27FC236}">
-                <a16:creationId xmlns:a16="http://schemas.microsoft.com/office/drawing/2014/main" id="{459B3B8C-266A-4757-BCF9-595700CED724}"/>
+                <a16:creationId xmlns:a16="http://schemas.microsoft.com/office/drawing/2014/main" id="{7BB4778F-DA72-4F6E-A958-D06267CF666F}"/>
               </a:ext>
             </a:extLst>
           </p:cNvPr>
@@ -18114,7 +18000,7 @@
           <p:cNvPr id="20" name="p03-h4">
             <a:extLst xmlns:a="http://schemas.openxmlformats.org/drawingml/2006/main">
               <a:ext uri="{FF2B5EF4-FFF2-40B4-BE49-F238E27FC236}">
-                <a16:creationId xmlns:a16="http://schemas.microsoft.com/office/drawing/2014/main" id="{98F68B04-B760-4BE3-B63E-D9DDE6CB4357}"/>
+                <a16:creationId xmlns:a16="http://schemas.microsoft.com/office/drawing/2014/main" id="{5366081F-DE44-4480-A8E3-3C4C7E63179A}"/>
               </a:ext>
             </a:extLst>
           </p:cNvPr>
@@ -18167,7 +18053,7 @@
           <p:cNvPr id="21" name="p03-d4">
             <a:extLst xmlns:a="http://schemas.openxmlformats.org/drawingml/2006/main">
               <a:ext uri="{FF2B5EF4-FFF2-40B4-BE49-F238E27FC236}">
-                <a16:creationId xmlns:a16="http://schemas.microsoft.com/office/drawing/2014/main" id="{41379276-6B51-4499-8DEF-4982C50DC6DC}"/>
+                <a16:creationId xmlns:a16="http://schemas.microsoft.com/office/drawing/2014/main" id="{C83DEF1A-9E59-46C5-A94B-237C7328CEA1}"/>
               </a:ext>
             </a:extLst>
           </p:cNvPr>
@@ -18224,7 +18110,7 @@
           <p:cNvPr id="22" name="p03-boundary">
             <a:extLst xmlns:a="http://schemas.openxmlformats.org/drawingml/2006/main">
               <a:ext uri="{FF2B5EF4-FFF2-40B4-BE49-F238E27FC236}">
-                <a16:creationId xmlns:a16="http://schemas.microsoft.com/office/drawing/2014/main" id="{25B4F7F1-3DC3-4395-BCD0-307D503738CF}"/>
+                <a16:creationId xmlns:a16="http://schemas.microsoft.com/office/drawing/2014/main" id="{58A64E55-8B48-4F75-A6D2-46650554415E}"/>
               </a:ext>
             </a:extLst>
           </p:cNvPr>
@@ -18371,7 +18257,7 @@
           <p:cNvPr id="6" name="p04-left-h">
             <a:extLst xmlns:a="http://schemas.openxmlformats.org/drawingml/2006/main">
               <a:ext uri="{FF2B5EF4-FFF2-40B4-BE49-F238E27FC236}">
-                <a16:creationId xmlns:a16="http://schemas.microsoft.com/office/drawing/2014/main" id="{A467C46B-1D9C-478A-BB72-250C79F665BA}"/>
+                <a16:creationId xmlns:a16="http://schemas.microsoft.com/office/drawing/2014/main" id="{F8395AEE-88A8-4149-8CFA-778EE6FF2759}"/>
               </a:ext>
             </a:extLst>
           </p:cNvPr>
@@ -18426,7 +18312,7 @@
           <p:cNvPr id="7" name="p04-a0">
             <a:extLst xmlns:a="http://schemas.openxmlformats.org/drawingml/2006/main">
               <a:ext uri="{FF2B5EF4-FFF2-40B4-BE49-F238E27FC236}">
-                <a16:creationId xmlns:a16="http://schemas.microsoft.com/office/drawing/2014/main" id="{1C742231-F88A-4041-8F69-BDCB577CA667}"/>
+                <a16:creationId xmlns:a16="http://schemas.microsoft.com/office/drawing/2014/main" id="{2C866765-2194-474B-8602-3551BF646AB2}"/>
               </a:ext>
             </a:extLst>
           </p:cNvPr>
@@ -18485,7 +18371,7 @@
           <p:cNvPr id="8" name="p04-a1">
             <a:extLst xmlns:a="http://schemas.openxmlformats.org/drawingml/2006/main">
               <a:ext uri="{FF2B5EF4-FFF2-40B4-BE49-F238E27FC236}">
-                <a16:creationId xmlns:a16="http://schemas.microsoft.com/office/drawing/2014/main" id="{19456B5A-C8A1-4CFF-9028-7F3FD92115F0}"/>
+                <a16:creationId xmlns:a16="http://schemas.microsoft.com/office/drawing/2014/main" id="{3DC2FE3A-CF0F-43BD-8C7D-9310D2BDBA69}"/>
               </a:ext>
             </a:extLst>
           </p:cNvPr>
@@ -18544,7 +18430,7 @@
           <p:cNvPr id="9" name="p04-a2">
             <a:extLst xmlns:a="http://schemas.openxmlformats.org/drawingml/2006/main">
               <a:ext uri="{FF2B5EF4-FFF2-40B4-BE49-F238E27FC236}">
-                <a16:creationId xmlns:a16="http://schemas.microsoft.com/office/drawing/2014/main" id="{5F5F9B37-850F-4603-AB15-B091A75ADEDE}"/>
+                <a16:creationId xmlns:a16="http://schemas.microsoft.com/office/drawing/2014/main" id="{9CCF1535-043C-4823-AF82-DDCE815C5A6F}"/>
               </a:ext>
             </a:extLst>
           </p:cNvPr>
@@ -18603,7 +18489,7 @@
           <p:cNvPr id="10" name="p04-neq">
             <a:extLst xmlns:a="http://schemas.openxmlformats.org/drawingml/2006/main">
               <a:ext uri="{FF2B5EF4-FFF2-40B4-BE49-F238E27FC236}">
-                <a16:creationId xmlns:a16="http://schemas.microsoft.com/office/drawing/2014/main" id="{995C7029-C005-494C-BF5D-FF29076964E3}"/>
+                <a16:creationId xmlns:a16="http://schemas.microsoft.com/office/drawing/2014/main" id="{B40FAED9-4239-484D-8A21-120F82AB93E1}"/>
               </a:ext>
             </a:extLst>
           </p:cNvPr>
@@ -18656,7 +18542,7 @@
           <p:cNvPr id="11" name="p04-right-h">
             <a:extLst xmlns:a="http://schemas.openxmlformats.org/drawingml/2006/main">
               <a:ext uri="{FF2B5EF4-FFF2-40B4-BE49-F238E27FC236}">
-                <a16:creationId xmlns:a16="http://schemas.microsoft.com/office/drawing/2014/main" id="{2824F6FF-B3CB-4AD7-BA0C-488BC014D875}"/>
+                <a16:creationId xmlns:a16="http://schemas.microsoft.com/office/drawing/2014/main" id="{B7C358C9-1999-488B-9829-F1F2174ED1BC}"/>
               </a:ext>
             </a:extLst>
           </p:cNvPr>
@@ -18711,7 +18597,7 @@
           <p:cNvPr id="12" name="p04-q0">
             <a:extLst xmlns:a="http://schemas.openxmlformats.org/drawingml/2006/main">
               <a:ext uri="{FF2B5EF4-FFF2-40B4-BE49-F238E27FC236}">
-                <a16:creationId xmlns:a16="http://schemas.microsoft.com/office/drawing/2014/main" id="{1015AA08-EF4D-4CEB-B2D3-56EBCA3F0AEA}"/>
+                <a16:creationId xmlns:a16="http://schemas.microsoft.com/office/drawing/2014/main" id="{DF0A6D63-111B-40AD-AB05-8AF3A1FFF86E}"/>
               </a:ext>
             </a:extLst>
           </p:cNvPr>
@@ -18770,7 +18656,7 @@
           <p:cNvPr id="13" name="p04-q1">
             <a:extLst xmlns:a="http://schemas.openxmlformats.org/drawingml/2006/main">
               <a:ext uri="{FF2B5EF4-FFF2-40B4-BE49-F238E27FC236}">
-                <a16:creationId xmlns:a16="http://schemas.microsoft.com/office/drawing/2014/main" id="{C1E25B76-263A-4456-AAED-3EA035303D9C}"/>
+                <a16:creationId xmlns:a16="http://schemas.microsoft.com/office/drawing/2014/main" id="{41449ED1-1F79-4494-9A15-602D7CD621D9}"/>
               </a:ext>
             </a:extLst>
           </p:cNvPr>
@@ -18829,7 +18715,7 @@
           <p:cNvPr id="14" name="p04-q2">
             <a:extLst xmlns:a="http://schemas.openxmlformats.org/drawingml/2006/main">
               <a:ext uri="{FF2B5EF4-FFF2-40B4-BE49-F238E27FC236}">
-                <a16:creationId xmlns:a16="http://schemas.microsoft.com/office/drawing/2014/main" id="{0F3D1D52-0A84-4B72-B9A7-FF3C1566E62D}"/>
+                <a16:creationId xmlns:a16="http://schemas.microsoft.com/office/drawing/2014/main" id="{BB36785E-51C7-419D-B59A-0F5C17F69DE5}"/>
               </a:ext>
             </a:extLst>
           </p:cNvPr>
@@ -18888,7 +18774,7 @@
           <p:cNvPr id="15" name="p04-bottom">
             <a:extLst xmlns:a="http://schemas.openxmlformats.org/drawingml/2006/main">
               <a:ext uri="{FF2B5EF4-FFF2-40B4-BE49-F238E27FC236}">
-                <a16:creationId xmlns:a16="http://schemas.microsoft.com/office/drawing/2014/main" id="{9CF76586-0D48-4454-A052-35AB29D6551B}"/>
+                <a16:creationId xmlns:a16="http://schemas.microsoft.com/office/drawing/2014/main" id="{7378EF33-3FD4-4EA6-9943-B98477521172}"/>
               </a:ext>
             </a:extLst>
           </p:cNvPr>
@@ -19033,7 +18919,7 @@
           <p:cNvPr id="6" name="p05-h-0">
             <a:extLst xmlns:a="http://schemas.openxmlformats.org/drawingml/2006/main">
               <a:ext uri="{FF2B5EF4-FFF2-40B4-BE49-F238E27FC236}">
-                <a16:creationId xmlns:a16="http://schemas.microsoft.com/office/drawing/2014/main" id="{3D90A0BE-7D48-48DE-B1E8-1314B0A6E533}"/>
+                <a16:creationId xmlns:a16="http://schemas.microsoft.com/office/drawing/2014/main" id="{C0CEAD2F-493B-4AE9-BA4D-A6B9178A7671}"/>
               </a:ext>
             </a:extLst>
           </p:cNvPr>
@@ -19088,7 +18974,7 @@
           <p:cNvPr id="7" name="p05-h-1">
             <a:extLst xmlns:a="http://schemas.openxmlformats.org/drawingml/2006/main">
               <a:ext uri="{FF2B5EF4-FFF2-40B4-BE49-F238E27FC236}">
-                <a16:creationId xmlns:a16="http://schemas.microsoft.com/office/drawing/2014/main" id="{451C6E1A-9A69-4076-A105-E92FF52832BE}"/>
+                <a16:creationId xmlns:a16="http://schemas.microsoft.com/office/drawing/2014/main" id="{BA593F7D-78FE-43C3-A77A-847D47B8941B}"/>
               </a:ext>
             </a:extLst>
           </p:cNvPr>
@@ -19143,7 +19029,7 @@
           <p:cNvPr id="8" name="p05-h-2">
             <a:extLst xmlns:a="http://schemas.openxmlformats.org/drawingml/2006/main">
               <a:ext uri="{FF2B5EF4-FFF2-40B4-BE49-F238E27FC236}">
-                <a16:creationId xmlns:a16="http://schemas.microsoft.com/office/drawing/2014/main" id="{AE29862B-3C62-4446-9D5F-7EEE77D71D14}"/>
+                <a16:creationId xmlns:a16="http://schemas.microsoft.com/office/drawing/2014/main" id="{86D9E5C6-A069-406E-A564-159A34E974EF}"/>
               </a:ext>
             </a:extLst>
           </p:cNvPr>
@@ -19198,7 +19084,7 @@
           <p:cNvPr id="9" name="p05-r0-0">
             <a:extLst xmlns:a="http://schemas.openxmlformats.org/drawingml/2006/main">
               <a:ext uri="{FF2B5EF4-FFF2-40B4-BE49-F238E27FC236}">
-                <a16:creationId xmlns:a16="http://schemas.microsoft.com/office/drawing/2014/main" id="{7DC3984F-B910-4AFF-BDEE-3F64817EF4A9}"/>
+                <a16:creationId xmlns:a16="http://schemas.microsoft.com/office/drawing/2014/main" id="{0CB5C68B-4916-4689-B12C-4E214966E686}"/>
               </a:ext>
             </a:extLst>
           </p:cNvPr>
@@ -19259,7 +19145,7 @@
           <p:cNvPr id="10" name="p05-r0-1">
             <a:extLst xmlns:a="http://schemas.openxmlformats.org/drawingml/2006/main">
               <a:ext uri="{FF2B5EF4-FFF2-40B4-BE49-F238E27FC236}">
-                <a16:creationId xmlns:a16="http://schemas.microsoft.com/office/drawing/2014/main" id="{1FA763E4-F879-4172-8B35-E87CCBDDB1BE}"/>
+                <a16:creationId xmlns:a16="http://schemas.microsoft.com/office/drawing/2014/main" id="{726DEA08-6334-4EAF-9736-07D5E700DB62}"/>
               </a:ext>
             </a:extLst>
           </p:cNvPr>
@@ -19320,7 +19206,7 @@
           <p:cNvPr id="11" name="p05-r0-2">
             <a:extLst xmlns:a="http://schemas.openxmlformats.org/drawingml/2006/main">
               <a:ext uri="{FF2B5EF4-FFF2-40B4-BE49-F238E27FC236}">
-                <a16:creationId xmlns:a16="http://schemas.microsoft.com/office/drawing/2014/main" id="{5A48939D-A3BD-41D2-9DE2-CBCD9009A9D3}"/>
+                <a16:creationId xmlns:a16="http://schemas.microsoft.com/office/drawing/2014/main" id="{C6DFCAEC-ACD8-4F7B-AC1A-0FE0A3E82BB6}"/>
               </a:ext>
             </a:extLst>
           </p:cNvPr>
@@ -19381,7 +19267,7 @@
           <p:cNvPr id="12" name="p05-r1-0">
             <a:extLst xmlns:a="http://schemas.openxmlformats.org/drawingml/2006/main">
               <a:ext uri="{FF2B5EF4-FFF2-40B4-BE49-F238E27FC236}">
-                <a16:creationId xmlns:a16="http://schemas.microsoft.com/office/drawing/2014/main" id="{9042AD9F-3B66-435D-8661-DC998B4AFDA4}"/>
+                <a16:creationId xmlns:a16="http://schemas.microsoft.com/office/drawing/2014/main" id="{CBBCB29C-323C-4E26-883A-1D37930C717A}"/>
               </a:ext>
             </a:extLst>
           </p:cNvPr>
@@ -19442,7 +19328,7 @@
           <p:cNvPr id="13" name="p05-r1-1">
             <a:extLst xmlns:a="http://schemas.openxmlformats.org/drawingml/2006/main">
               <a:ext uri="{FF2B5EF4-FFF2-40B4-BE49-F238E27FC236}">
-                <a16:creationId xmlns:a16="http://schemas.microsoft.com/office/drawing/2014/main" id="{105019B4-6EE3-484B-A546-21F2F8E6C907}"/>
+                <a16:creationId xmlns:a16="http://schemas.microsoft.com/office/drawing/2014/main" id="{BF9F3166-38ED-475E-81F5-3B6779830DAC}"/>
               </a:ext>
             </a:extLst>
           </p:cNvPr>
@@ -19503,7 +19389,7 @@
           <p:cNvPr id="14" name="p05-r1-2">
             <a:extLst xmlns:a="http://schemas.openxmlformats.org/drawingml/2006/main">
               <a:ext uri="{FF2B5EF4-FFF2-40B4-BE49-F238E27FC236}">
-                <a16:creationId xmlns:a16="http://schemas.microsoft.com/office/drawing/2014/main" id="{D195A543-C1F3-4B74-B27F-7178A16405B6}"/>
+                <a16:creationId xmlns:a16="http://schemas.microsoft.com/office/drawing/2014/main" id="{70234BB4-60DF-4E0E-B824-B8F0B7142626}"/>
               </a:ext>
             </a:extLst>
           </p:cNvPr>
@@ -19564,7 +19450,7 @@
           <p:cNvPr id="15" name="p05-r2-0">
             <a:extLst xmlns:a="http://schemas.openxmlformats.org/drawingml/2006/main">
               <a:ext uri="{FF2B5EF4-FFF2-40B4-BE49-F238E27FC236}">
-                <a16:creationId xmlns:a16="http://schemas.microsoft.com/office/drawing/2014/main" id="{A11D7265-01BE-4315-8CD0-11A01A27F5AE}"/>
+                <a16:creationId xmlns:a16="http://schemas.microsoft.com/office/drawing/2014/main" id="{3D83805A-44E0-4C6D-9AEC-7A973A41824B}"/>
               </a:ext>
             </a:extLst>
           </p:cNvPr>
@@ -19625,7 +19511,7 @@
           <p:cNvPr id="16" name="p05-r2-1">
             <a:extLst xmlns:a="http://schemas.openxmlformats.org/drawingml/2006/main">
               <a:ext uri="{FF2B5EF4-FFF2-40B4-BE49-F238E27FC236}">
-                <a16:creationId xmlns:a16="http://schemas.microsoft.com/office/drawing/2014/main" id="{B3B644BF-F96B-4F84-829B-18A7DDCCB277}"/>
+                <a16:creationId xmlns:a16="http://schemas.microsoft.com/office/drawing/2014/main" id="{47B2911E-DD55-40F7-8880-1FDA20B2BF53}"/>
               </a:ext>
             </a:extLst>
           </p:cNvPr>
@@ -19686,7 +19572,7 @@
           <p:cNvPr id="17" name="p05-r2-2">
             <a:extLst xmlns:a="http://schemas.openxmlformats.org/drawingml/2006/main">
               <a:ext uri="{FF2B5EF4-FFF2-40B4-BE49-F238E27FC236}">
-                <a16:creationId xmlns:a16="http://schemas.microsoft.com/office/drawing/2014/main" id="{BA1218DD-E31A-49CF-B29F-0297FC18151A}"/>
+                <a16:creationId xmlns:a16="http://schemas.microsoft.com/office/drawing/2014/main" id="{1349FCA4-01E1-4875-85C7-E581F349B54B}"/>
               </a:ext>
             </a:extLst>
           </p:cNvPr>
@@ -19747,7 +19633,7 @@
           <p:cNvPr id="18" name="p05-r3-0">
             <a:extLst xmlns:a="http://schemas.openxmlformats.org/drawingml/2006/main">
               <a:ext uri="{FF2B5EF4-FFF2-40B4-BE49-F238E27FC236}">
-                <a16:creationId xmlns:a16="http://schemas.microsoft.com/office/drawing/2014/main" id="{BBB25AA4-3278-4A45-803C-47F6EFA7AC4D}"/>
+                <a16:creationId xmlns:a16="http://schemas.microsoft.com/office/drawing/2014/main" id="{791A0EE3-192E-4CD9-9027-5BAFB0FE2ECC}"/>
               </a:ext>
             </a:extLst>
           </p:cNvPr>
@@ -19808,7 +19694,7 @@
           <p:cNvPr id="19" name="p05-r3-1">
             <a:extLst xmlns:a="http://schemas.openxmlformats.org/drawingml/2006/main">
               <a:ext uri="{FF2B5EF4-FFF2-40B4-BE49-F238E27FC236}">
-                <a16:creationId xmlns:a16="http://schemas.microsoft.com/office/drawing/2014/main" id="{A2B1DD37-172A-4C2E-AF66-1679DCC935EB}"/>
+                <a16:creationId xmlns:a16="http://schemas.microsoft.com/office/drawing/2014/main" id="{DE1FBF14-ADB4-4AE7-9B60-D1B0DC10D2A1}"/>
               </a:ext>
             </a:extLst>
           </p:cNvPr>
@@ -19869,7 +19755,7 @@
           <p:cNvPr id="20" name="p05-r3-2">
             <a:extLst xmlns:a="http://schemas.openxmlformats.org/drawingml/2006/main">
               <a:ext uri="{FF2B5EF4-FFF2-40B4-BE49-F238E27FC236}">
-                <a16:creationId xmlns:a16="http://schemas.microsoft.com/office/drawing/2014/main" id="{6D43361A-A537-426D-817E-8D7F555D24B0}"/>
+                <a16:creationId xmlns:a16="http://schemas.microsoft.com/office/drawing/2014/main" id="{DA4A5497-AA55-4EB1-B0AB-69D6C1787F23}"/>
               </a:ext>
             </a:extLst>
           </p:cNvPr>
@@ -19930,7 +19816,7 @@
           <p:cNvPr id="21" name="p05-bottom">
             <a:extLst xmlns:a="http://schemas.openxmlformats.org/drawingml/2006/main">
               <a:ext uri="{FF2B5EF4-FFF2-40B4-BE49-F238E27FC236}">
-                <a16:creationId xmlns:a16="http://schemas.microsoft.com/office/drawing/2014/main" id="{683DA581-DC93-4959-AE3A-3818D8EEA8AA}"/>
+                <a16:creationId xmlns:a16="http://schemas.microsoft.com/office/drawing/2014/main" id="{94A462C5-92DD-4B95-9F11-59D811D91C76}"/>
               </a:ext>
             </a:extLst>
           </p:cNvPr>
@@ -20077,7 +19963,7 @@
           <p:cNvPr id="6" name="p06-rule">
             <a:extLst xmlns:a="http://schemas.openxmlformats.org/drawingml/2006/main">
               <a:ext uri="{FF2B5EF4-FFF2-40B4-BE49-F238E27FC236}">
-                <a16:creationId xmlns:a16="http://schemas.microsoft.com/office/drawing/2014/main" id="{31D27BC7-AB12-4483-A657-3AF8394A102C}"/>
+                <a16:creationId xmlns:a16="http://schemas.microsoft.com/office/drawing/2014/main" id="{E86CC03C-A3D4-4984-9027-4DD71590CAB2}"/>
               </a:ext>
             </a:extLst>
           </p:cNvPr>
@@ -20132,7 +20018,7 @@
           <p:cNvPr id="7" name="p06-h-0">
             <a:extLst xmlns:a="http://schemas.openxmlformats.org/drawingml/2006/main">
               <a:ext uri="{FF2B5EF4-FFF2-40B4-BE49-F238E27FC236}">
-                <a16:creationId xmlns:a16="http://schemas.microsoft.com/office/drawing/2014/main" id="{FE6370B2-F5DA-41D2-A6DC-FE5580CC90BC}"/>
+                <a16:creationId xmlns:a16="http://schemas.microsoft.com/office/drawing/2014/main" id="{0E452575-6F56-4953-B3EE-3A9DA2B74055}"/>
               </a:ext>
             </a:extLst>
           </p:cNvPr>
@@ -20187,7 +20073,7 @@
           <p:cNvPr id="8" name="p06-h-1">
             <a:extLst xmlns:a="http://schemas.openxmlformats.org/drawingml/2006/main">
               <a:ext uri="{FF2B5EF4-FFF2-40B4-BE49-F238E27FC236}">
-                <a16:creationId xmlns:a16="http://schemas.microsoft.com/office/drawing/2014/main" id="{F785263A-FBD2-41A4-9D12-7C02F8782510}"/>
+                <a16:creationId xmlns:a16="http://schemas.microsoft.com/office/drawing/2014/main" id="{2C6301B4-B763-4F32-9105-14B8D81ED848}"/>
               </a:ext>
             </a:extLst>
           </p:cNvPr>
@@ -20242,7 +20128,7 @@
           <p:cNvPr id="9" name="p06-h-2">
             <a:extLst xmlns:a="http://schemas.openxmlformats.org/drawingml/2006/main">
               <a:ext uri="{FF2B5EF4-FFF2-40B4-BE49-F238E27FC236}">
-                <a16:creationId xmlns:a16="http://schemas.microsoft.com/office/drawing/2014/main" id="{2B0E5185-8EAF-4502-86AA-E82A1976CE25}"/>
+                <a16:creationId xmlns:a16="http://schemas.microsoft.com/office/drawing/2014/main" id="{9D0A0DFF-DDB2-4A43-8E74-D885FCA48DF0}"/>
               </a:ext>
             </a:extLst>
           </p:cNvPr>
@@ -20297,7 +20183,7 @@
           <p:cNvPr id="10" name="p06-h-3">
             <a:extLst xmlns:a="http://schemas.openxmlformats.org/drawingml/2006/main">
               <a:ext uri="{FF2B5EF4-FFF2-40B4-BE49-F238E27FC236}">
-                <a16:creationId xmlns:a16="http://schemas.microsoft.com/office/drawing/2014/main" id="{42E874E3-7C44-4C5F-846A-431233DFB221}"/>
+                <a16:creationId xmlns:a16="http://schemas.microsoft.com/office/drawing/2014/main" id="{68D13D8F-8A59-4A13-B1D9-0FD47E6B49C0}"/>
               </a:ext>
             </a:extLst>
           </p:cNvPr>
@@ -20352,7 +20238,7 @@
           <p:cNvPr id="11" name="p06-h-4">
             <a:extLst xmlns:a="http://schemas.openxmlformats.org/drawingml/2006/main">
               <a:ext uri="{FF2B5EF4-FFF2-40B4-BE49-F238E27FC236}">
-                <a16:creationId xmlns:a16="http://schemas.microsoft.com/office/drawing/2014/main" id="{E20CCFBB-6979-4299-A1CF-CD2954B0D5CC}"/>
+                <a16:creationId xmlns:a16="http://schemas.microsoft.com/office/drawing/2014/main" id="{467751C0-B404-4BA1-84A9-791DDF0AA70D}"/>
               </a:ext>
             </a:extLst>
           </p:cNvPr>
@@ -20407,7 +20293,7 @@
           <p:cNvPr id="12" name="p06-r0-0">
             <a:extLst xmlns:a="http://schemas.openxmlformats.org/drawingml/2006/main">
               <a:ext uri="{FF2B5EF4-FFF2-40B4-BE49-F238E27FC236}">
-                <a16:creationId xmlns:a16="http://schemas.microsoft.com/office/drawing/2014/main" id="{C64708C5-1C93-43E8-85EA-6648A7AB4A9A}"/>
+                <a16:creationId xmlns:a16="http://schemas.microsoft.com/office/drawing/2014/main" id="{1E3BA73A-744B-4CC3-A9DA-219965428A15}"/>
               </a:ext>
             </a:extLst>
           </p:cNvPr>
@@ -20468,7 +20354,7 @@
           <p:cNvPr id="13" name="p06-r0-1">
             <a:extLst xmlns:a="http://schemas.openxmlformats.org/drawingml/2006/main">
               <a:ext uri="{FF2B5EF4-FFF2-40B4-BE49-F238E27FC236}">
-                <a16:creationId xmlns:a16="http://schemas.microsoft.com/office/drawing/2014/main" id="{114DCE75-5A3E-4195-912B-24400F6586D7}"/>
+                <a16:creationId xmlns:a16="http://schemas.microsoft.com/office/drawing/2014/main" id="{B830044A-6932-4325-B607-072624CEC00F}"/>
               </a:ext>
             </a:extLst>
           </p:cNvPr>
@@ -20529,7 +20415,7 @@
           <p:cNvPr id="14" name="p06-r0-2">
             <a:extLst xmlns:a="http://schemas.openxmlformats.org/drawingml/2006/main">
               <a:ext uri="{FF2B5EF4-FFF2-40B4-BE49-F238E27FC236}">
-                <a16:creationId xmlns:a16="http://schemas.microsoft.com/office/drawing/2014/main" id="{BA4526C2-CEA9-45ED-B292-DA111CA35F76}"/>
+                <a16:creationId xmlns:a16="http://schemas.microsoft.com/office/drawing/2014/main" id="{54AE5100-5337-4A05-A233-CF15BFF97E31}"/>
               </a:ext>
             </a:extLst>
           </p:cNvPr>
@@ -20590,7 +20476,7 @@
           <p:cNvPr id="15" name="p06-r0-3">
             <a:extLst xmlns:a="http://schemas.openxmlformats.org/drawingml/2006/main">
               <a:ext uri="{FF2B5EF4-FFF2-40B4-BE49-F238E27FC236}">
-                <a16:creationId xmlns:a16="http://schemas.microsoft.com/office/drawing/2014/main" id="{95D9BDA7-005A-4850-BB89-706F3EBC49C5}"/>
+                <a16:creationId xmlns:a16="http://schemas.microsoft.com/office/drawing/2014/main" id="{28166C7E-56F3-4198-BDBD-1D2140AA6C47}"/>
               </a:ext>
             </a:extLst>
           </p:cNvPr>
@@ -20651,7 +20537,7 @@
           <p:cNvPr id="16" name="p06-r0-4">
             <a:extLst xmlns:a="http://schemas.openxmlformats.org/drawingml/2006/main">
               <a:ext uri="{FF2B5EF4-FFF2-40B4-BE49-F238E27FC236}">
-                <a16:creationId xmlns:a16="http://schemas.microsoft.com/office/drawing/2014/main" id="{C47A54A2-F595-4CB1-A320-BD876C5E7834}"/>
+                <a16:creationId xmlns:a16="http://schemas.microsoft.com/office/drawing/2014/main" id="{0B2B5B3C-23EB-44C6-84DD-B3DE5E0E7116}"/>
               </a:ext>
             </a:extLst>
           </p:cNvPr>
@@ -20712,7 +20598,7 @@
           <p:cNvPr id="17" name="p06-r1-0">
             <a:extLst xmlns:a="http://schemas.openxmlformats.org/drawingml/2006/main">
               <a:ext uri="{FF2B5EF4-FFF2-40B4-BE49-F238E27FC236}">
-                <a16:creationId xmlns:a16="http://schemas.microsoft.com/office/drawing/2014/main" id="{303521AB-A175-4481-B77B-9DD55FD10614}"/>
+                <a16:creationId xmlns:a16="http://schemas.microsoft.com/office/drawing/2014/main" id="{61E9EB25-4FCA-4B9D-8ABC-87546DD119FD}"/>
               </a:ext>
             </a:extLst>
           </p:cNvPr>
@@ -20773,7 +20659,7 @@
           <p:cNvPr id="18" name="p06-r1-1">
             <a:extLst xmlns:a="http://schemas.openxmlformats.org/drawingml/2006/main">
               <a:ext uri="{FF2B5EF4-FFF2-40B4-BE49-F238E27FC236}">
-                <a16:creationId xmlns:a16="http://schemas.microsoft.com/office/drawing/2014/main" id="{853F2246-4669-4902-BFEC-4C183D1BC388}"/>
+                <a16:creationId xmlns:a16="http://schemas.microsoft.com/office/drawing/2014/main" id="{2E29E307-0A94-4EC8-BD30-C664B1BD2AEB}"/>
               </a:ext>
             </a:extLst>
           </p:cNvPr>
@@ -20834,7 +20720,7 @@
           <p:cNvPr id="19" name="p06-r1-2">
             <a:extLst xmlns:a="http://schemas.openxmlformats.org/drawingml/2006/main">
               <a:ext uri="{FF2B5EF4-FFF2-40B4-BE49-F238E27FC236}">
-                <a16:creationId xmlns:a16="http://schemas.microsoft.com/office/drawing/2014/main" id="{2DF04FB2-F6DF-4342-8C29-6D6394A0284A}"/>
+                <a16:creationId xmlns:a16="http://schemas.microsoft.com/office/drawing/2014/main" id="{B5B62457-34FC-4BAE-B932-6F5FCED71D21}"/>
               </a:ext>
             </a:extLst>
           </p:cNvPr>
@@ -20895,7 +20781,7 @@
           <p:cNvPr id="20" name="p06-r1-3">
             <a:extLst xmlns:a="http://schemas.openxmlformats.org/drawingml/2006/main">
               <a:ext uri="{FF2B5EF4-FFF2-40B4-BE49-F238E27FC236}">
-                <a16:creationId xmlns:a16="http://schemas.microsoft.com/office/drawing/2014/main" id="{6E10139D-1A4A-4075-ACB1-C019AD52A563}"/>
+                <a16:creationId xmlns:a16="http://schemas.microsoft.com/office/drawing/2014/main" id="{671C2976-97BA-4026-8D4B-D3796CACA79A}"/>
               </a:ext>
             </a:extLst>
           </p:cNvPr>
@@ -20956,7 +20842,7 @@
           <p:cNvPr id="21" name="p06-r1-4">
             <a:extLst xmlns:a="http://schemas.openxmlformats.org/drawingml/2006/main">
               <a:ext uri="{FF2B5EF4-FFF2-40B4-BE49-F238E27FC236}">
-                <a16:creationId xmlns:a16="http://schemas.microsoft.com/office/drawing/2014/main" id="{A1BAE21C-A906-4583-9B6C-8694F35D6498}"/>
+                <a16:creationId xmlns:a16="http://schemas.microsoft.com/office/drawing/2014/main" id="{A88489C1-7A36-47CF-8062-7C5FC8948650}"/>
               </a:ext>
             </a:extLst>
           </p:cNvPr>
@@ -21017,7 +20903,7 @@
           <p:cNvPr id="22" name="p06-r2-0">
             <a:extLst xmlns:a="http://schemas.openxmlformats.org/drawingml/2006/main">
               <a:ext uri="{FF2B5EF4-FFF2-40B4-BE49-F238E27FC236}">
-                <a16:creationId xmlns:a16="http://schemas.microsoft.com/office/drawing/2014/main" id="{37600EA3-05F7-459B-989D-78B21C999734}"/>
+                <a16:creationId xmlns:a16="http://schemas.microsoft.com/office/drawing/2014/main" id="{8F13FCCA-75BE-466F-9AF7-E171698FE380}"/>
               </a:ext>
             </a:extLst>
           </p:cNvPr>
@@ -21078,7 +20964,7 @@
           <p:cNvPr id="23" name="p06-r2-1">
             <a:extLst xmlns:a="http://schemas.openxmlformats.org/drawingml/2006/main">
               <a:ext uri="{FF2B5EF4-FFF2-40B4-BE49-F238E27FC236}">
-                <a16:creationId xmlns:a16="http://schemas.microsoft.com/office/drawing/2014/main" id="{08ED9679-A244-4489-8926-CB16BA1FFB51}"/>
+                <a16:creationId xmlns:a16="http://schemas.microsoft.com/office/drawing/2014/main" id="{E5C834D4-9833-4AA2-83DC-19F174E71C59}"/>
               </a:ext>
             </a:extLst>
           </p:cNvPr>
@@ -21139,7 +21025,7 @@
           <p:cNvPr id="24" name="p06-r2-2">
             <a:extLst xmlns:a="http://schemas.openxmlformats.org/drawingml/2006/main">
               <a:ext uri="{FF2B5EF4-FFF2-40B4-BE49-F238E27FC236}">
-                <a16:creationId xmlns:a16="http://schemas.microsoft.com/office/drawing/2014/main" id="{794CE330-2172-4186-8285-460414D39691}"/>
+                <a16:creationId xmlns:a16="http://schemas.microsoft.com/office/drawing/2014/main" id="{EE5A92D8-8558-4820-9914-CD6F4543D7FA}"/>
               </a:ext>
             </a:extLst>
           </p:cNvPr>
@@ -21200,7 +21086,7 @@
           <p:cNvPr id="25" name="p06-r2-3">
             <a:extLst xmlns:a="http://schemas.openxmlformats.org/drawingml/2006/main">
               <a:ext uri="{FF2B5EF4-FFF2-40B4-BE49-F238E27FC236}">
-                <a16:creationId xmlns:a16="http://schemas.microsoft.com/office/drawing/2014/main" id="{687A365C-2645-4232-B564-0D66AD89E729}"/>
+                <a16:creationId xmlns:a16="http://schemas.microsoft.com/office/drawing/2014/main" id="{4A19DEB6-D68A-4813-8A24-E9F9F25317AA}"/>
               </a:ext>
             </a:extLst>
           </p:cNvPr>
@@ -21261,7 +21147,7 @@
           <p:cNvPr id="26" name="p06-r2-4">
             <a:extLst xmlns:a="http://schemas.openxmlformats.org/drawingml/2006/main">
               <a:ext uri="{FF2B5EF4-FFF2-40B4-BE49-F238E27FC236}">
-                <a16:creationId xmlns:a16="http://schemas.microsoft.com/office/drawing/2014/main" id="{6729C97D-2AD8-4D09-98E8-70B28A784440}"/>
+                <a16:creationId xmlns:a16="http://schemas.microsoft.com/office/drawing/2014/main" id="{9D7D2AE3-0B8F-4D29-AD17-EA2D32D73F90}"/>
               </a:ext>
             </a:extLst>
           </p:cNvPr>
@@ -21322,7 +21208,7 @@
           <p:cNvPr id="27" name="p06-r3-0">
             <a:extLst xmlns:a="http://schemas.openxmlformats.org/drawingml/2006/main">
               <a:ext uri="{FF2B5EF4-FFF2-40B4-BE49-F238E27FC236}">
-                <a16:creationId xmlns:a16="http://schemas.microsoft.com/office/drawing/2014/main" id="{051D81B8-AC09-4937-A42C-7434047CC46E}"/>
+                <a16:creationId xmlns:a16="http://schemas.microsoft.com/office/drawing/2014/main" id="{4A4C70B4-2589-453C-83E5-8A5F6FDC8050}"/>
               </a:ext>
             </a:extLst>
           </p:cNvPr>
@@ -21383,7 +21269,7 @@
           <p:cNvPr id="28" name="p06-r3-1">
             <a:extLst xmlns:a="http://schemas.openxmlformats.org/drawingml/2006/main">
               <a:ext uri="{FF2B5EF4-FFF2-40B4-BE49-F238E27FC236}">
-                <a16:creationId xmlns:a16="http://schemas.microsoft.com/office/drawing/2014/main" id="{B43D4435-21C1-4468-BE33-C91072F368AB}"/>
+                <a16:creationId xmlns:a16="http://schemas.microsoft.com/office/drawing/2014/main" id="{ED2760CC-245F-42C6-B0F8-5068D5C62C30}"/>
               </a:ext>
             </a:extLst>
           </p:cNvPr>
@@ -21444,7 +21330,7 @@
           <p:cNvPr id="29" name="p06-r3-2">
             <a:extLst xmlns:a="http://schemas.openxmlformats.org/drawingml/2006/main">
               <a:ext uri="{FF2B5EF4-FFF2-40B4-BE49-F238E27FC236}">
-                <a16:creationId xmlns:a16="http://schemas.microsoft.com/office/drawing/2014/main" id="{E0A50D70-FA5C-4C3E-A948-51E782904BD1}"/>
+                <a16:creationId xmlns:a16="http://schemas.microsoft.com/office/drawing/2014/main" id="{8014AF48-7647-4991-A80B-B7BE5A72BCEF}"/>
               </a:ext>
             </a:extLst>
           </p:cNvPr>
@@ -21505,7 +21391,7 @@
           <p:cNvPr id="30" name="p06-r3-3">
             <a:extLst xmlns:a="http://schemas.openxmlformats.org/drawingml/2006/main">
               <a:ext uri="{FF2B5EF4-FFF2-40B4-BE49-F238E27FC236}">
-                <a16:creationId xmlns:a16="http://schemas.microsoft.com/office/drawing/2014/main" id="{603B0B35-CE50-4490-BF88-37F1BC5DF8B7}"/>
+                <a16:creationId xmlns:a16="http://schemas.microsoft.com/office/drawing/2014/main" id="{307265FA-70A3-424B-93A7-A509F9FCEDEC}"/>
               </a:ext>
             </a:extLst>
           </p:cNvPr>
@@ -21566,7 +21452,7 @@
           <p:cNvPr id="31" name="p06-r3-4">
             <a:extLst xmlns:a="http://schemas.openxmlformats.org/drawingml/2006/main">
               <a:ext uri="{FF2B5EF4-FFF2-40B4-BE49-F238E27FC236}">
-                <a16:creationId xmlns:a16="http://schemas.microsoft.com/office/drawing/2014/main" id="{026C96CD-CE2D-4A66-975D-040B16BD0A95}"/>
+                <a16:creationId xmlns:a16="http://schemas.microsoft.com/office/drawing/2014/main" id="{9B6AE304-FCB2-4A73-9A9D-345C7C0F2FE1}"/>
               </a:ext>
             </a:extLst>
           </p:cNvPr>
@@ -21627,7 +21513,7 @@
           <p:cNvPr id="32" name="p06-r4-0">
             <a:extLst xmlns:a="http://schemas.openxmlformats.org/drawingml/2006/main">
               <a:ext uri="{FF2B5EF4-FFF2-40B4-BE49-F238E27FC236}">
-                <a16:creationId xmlns:a16="http://schemas.microsoft.com/office/drawing/2014/main" id="{A9E03FB4-877A-497D-A772-1FC9ED4962FB}"/>
+                <a16:creationId xmlns:a16="http://schemas.microsoft.com/office/drawing/2014/main" id="{4614E4FE-11D8-4086-988D-52454CAEBB2C}"/>
               </a:ext>
             </a:extLst>
           </p:cNvPr>
@@ -21688,7 +21574,7 @@
           <p:cNvPr id="33" name="p06-r4-1">
             <a:extLst xmlns:a="http://schemas.openxmlformats.org/drawingml/2006/main">
               <a:ext uri="{FF2B5EF4-FFF2-40B4-BE49-F238E27FC236}">
-                <a16:creationId xmlns:a16="http://schemas.microsoft.com/office/drawing/2014/main" id="{86437534-BDE3-46E3-9E06-A72B6C6C1812}"/>
+                <a16:creationId xmlns:a16="http://schemas.microsoft.com/office/drawing/2014/main" id="{2C86C0B4-0061-45EE-ADCD-9C20DEC5A07A}"/>
               </a:ext>
             </a:extLst>
           </p:cNvPr>
@@ -21749,7 +21635,7 @@
           <p:cNvPr id="34" name="p06-r4-2">
             <a:extLst xmlns:a="http://schemas.openxmlformats.org/drawingml/2006/main">
               <a:ext uri="{FF2B5EF4-FFF2-40B4-BE49-F238E27FC236}">
-                <a16:creationId xmlns:a16="http://schemas.microsoft.com/office/drawing/2014/main" id="{A3B2F400-EBDF-482A-981E-C270C2FF5043}"/>
+                <a16:creationId xmlns:a16="http://schemas.microsoft.com/office/drawing/2014/main" id="{73F9E344-7877-4D0A-9166-505FB93B2887}"/>
               </a:ext>
             </a:extLst>
           </p:cNvPr>
@@ -21810,7 +21696,7 @@
           <p:cNvPr id="35" name="p06-r4-3">
             <a:extLst xmlns:a="http://schemas.openxmlformats.org/drawingml/2006/main">
               <a:ext uri="{FF2B5EF4-FFF2-40B4-BE49-F238E27FC236}">
-                <a16:creationId xmlns:a16="http://schemas.microsoft.com/office/drawing/2014/main" id="{B25B1B77-70E9-4447-A425-8BC69BF28967}"/>
+                <a16:creationId xmlns:a16="http://schemas.microsoft.com/office/drawing/2014/main" id="{2B039E96-15E2-4EA1-AA29-6CD7BCBBC704}"/>
               </a:ext>
             </a:extLst>
           </p:cNvPr>
@@ -21871,7 +21757,7 @@
           <p:cNvPr id="36" name="p06-r4-4">
             <a:extLst xmlns:a="http://schemas.openxmlformats.org/drawingml/2006/main">
               <a:ext uri="{FF2B5EF4-FFF2-40B4-BE49-F238E27FC236}">
-                <a16:creationId xmlns:a16="http://schemas.microsoft.com/office/drawing/2014/main" id="{1769A04F-C37A-461E-98AB-D6AB358FC62A}"/>
+                <a16:creationId xmlns:a16="http://schemas.microsoft.com/office/drawing/2014/main" id="{D4CD2B49-DCAF-4CCA-B7D4-C9D2FF98CECD}"/>
               </a:ext>
             </a:extLst>
           </p:cNvPr>
@@ -21932,7 +21818,7 @@
           <p:cNvPr id="37" name="p06-bottom">
             <a:extLst xmlns:a="http://schemas.openxmlformats.org/drawingml/2006/main">
               <a:ext uri="{FF2B5EF4-FFF2-40B4-BE49-F238E27FC236}">
-                <a16:creationId xmlns:a16="http://schemas.microsoft.com/office/drawing/2014/main" id="{2A62E388-C610-440A-BA9E-856E242B6EBE}"/>
+                <a16:creationId xmlns:a16="http://schemas.microsoft.com/office/drawing/2014/main" id="{6F1F18CA-9D12-43B7-8CDD-BDB994070CE5}"/>
               </a:ext>
             </a:extLst>
           </p:cNvPr>
@@ -22077,7 +21963,7 @@
           <p:cNvPr id="6" name="p07-left-h">
             <a:extLst xmlns:a="http://schemas.openxmlformats.org/drawingml/2006/main">
               <a:ext uri="{FF2B5EF4-FFF2-40B4-BE49-F238E27FC236}">
-                <a16:creationId xmlns:a16="http://schemas.microsoft.com/office/drawing/2014/main" id="{EC7C9392-1A83-49E7-994E-E1FF07F59B76}"/>
+                <a16:creationId xmlns:a16="http://schemas.microsoft.com/office/drawing/2014/main" id="{147EA3AA-EC55-4636-84C6-A6E80DC819EF}"/>
               </a:ext>
             </a:extLst>
           </p:cNvPr>
@@ -22132,7 +22018,7 @@
           <p:cNvPr id="7" name="p07-l0">
             <a:extLst xmlns:a="http://schemas.openxmlformats.org/drawingml/2006/main">
               <a:ext uri="{FF2B5EF4-FFF2-40B4-BE49-F238E27FC236}">
-                <a16:creationId xmlns:a16="http://schemas.microsoft.com/office/drawing/2014/main" id="{292FB0CC-80FF-4EDD-B633-C35F1B1353A5}"/>
+                <a16:creationId xmlns:a16="http://schemas.microsoft.com/office/drawing/2014/main" id="{6BDDCFD9-8470-4E75-9767-04F11DCD56A4}"/>
               </a:ext>
             </a:extLst>
           </p:cNvPr>
@@ -22191,7 +22077,7 @@
           <p:cNvPr id="8" name="p07-l1">
             <a:extLst xmlns:a="http://schemas.openxmlformats.org/drawingml/2006/main">
               <a:ext uri="{FF2B5EF4-FFF2-40B4-BE49-F238E27FC236}">
-                <a16:creationId xmlns:a16="http://schemas.microsoft.com/office/drawing/2014/main" id="{9231F9A7-20FD-448D-A395-B57B4FC6399B}"/>
+                <a16:creationId xmlns:a16="http://schemas.microsoft.com/office/drawing/2014/main" id="{875B89E5-ADE2-4A40-9EE0-10BD9C42C72B}"/>
               </a:ext>
             </a:extLst>
           </p:cNvPr>
@@ -22250,7 +22136,7 @@
           <p:cNvPr id="9" name="p07-l2">
             <a:extLst xmlns:a="http://schemas.openxmlformats.org/drawingml/2006/main">
               <a:ext uri="{FF2B5EF4-FFF2-40B4-BE49-F238E27FC236}">
-                <a16:creationId xmlns:a16="http://schemas.microsoft.com/office/drawing/2014/main" id="{6F5AB3B8-29F2-48EF-81AB-2918D339ABD5}"/>
+                <a16:creationId xmlns:a16="http://schemas.microsoft.com/office/drawing/2014/main" id="{4B1C8FAC-0BFF-4CEB-8D51-F4F0130263F0}"/>
               </a:ext>
             </a:extLst>
           </p:cNvPr>
@@ -22309,7 +22195,7 @@
           <p:cNvPr id="10" name="p07-l3">
             <a:extLst xmlns:a="http://schemas.openxmlformats.org/drawingml/2006/main">
               <a:ext uri="{FF2B5EF4-FFF2-40B4-BE49-F238E27FC236}">
-                <a16:creationId xmlns:a16="http://schemas.microsoft.com/office/drawing/2014/main" id="{C9FAC209-9FB2-411B-81E5-E6298F2CAFF3}"/>
+                <a16:creationId xmlns:a16="http://schemas.microsoft.com/office/drawing/2014/main" id="{ACAF2317-EEBB-4BB6-8986-A4B9BA3AD230}"/>
               </a:ext>
             </a:extLst>
           </p:cNvPr>
@@ -22368,7 +22254,7 @@
           <p:cNvPr id="11" name="p07-a1">
             <a:extLst xmlns:a="http://schemas.openxmlformats.org/drawingml/2006/main">
               <a:ext uri="{FF2B5EF4-FFF2-40B4-BE49-F238E27FC236}">
-                <a16:creationId xmlns:a16="http://schemas.microsoft.com/office/drawing/2014/main" id="{A028CDE1-4B6E-40D8-9831-65FE81903ECD}"/>
+                <a16:creationId xmlns:a16="http://schemas.microsoft.com/office/drawing/2014/main" id="{0E848CC3-7F33-4B87-AEF9-CF1A66A940BF}"/>
               </a:ext>
             </a:extLst>
           </p:cNvPr>
@@ -22421,7 +22307,7 @@
           <p:cNvPr id="12" name="p07-a2">
             <a:extLst xmlns:a="http://schemas.openxmlformats.org/drawingml/2006/main">
               <a:ext uri="{FF2B5EF4-FFF2-40B4-BE49-F238E27FC236}">
-                <a16:creationId xmlns:a16="http://schemas.microsoft.com/office/drawing/2014/main" id="{BF3F8D7A-0AC8-43DA-86E3-E45AA9AE697F}"/>
+                <a16:creationId xmlns:a16="http://schemas.microsoft.com/office/drawing/2014/main" id="{0DE3CE96-7D25-4162-BCD2-78528A2113E7}"/>
               </a:ext>
             </a:extLst>
           </p:cNvPr>
@@ -22474,7 +22360,7 @@
           <p:cNvPr id="13" name="p07-a3">
             <a:extLst xmlns:a="http://schemas.openxmlformats.org/drawingml/2006/main">
               <a:ext uri="{FF2B5EF4-FFF2-40B4-BE49-F238E27FC236}">
-                <a16:creationId xmlns:a16="http://schemas.microsoft.com/office/drawing/2014/main" id="{0CEFBF88-9730-4F26-870D-A29576CCFD0E}"/>
+                <a16:creationId xmlns:a16="http://schemas.microsoft.com/office/drawing/2014/main" id="{E0355538-4B5A-40D8-8C25-7242B3455D23}"/>
               </a:ext>
             </a:extLst>
           </p:cNvPr>
@@ -22527,7 +22413,7 @@
           <p:cNvPr id="14" name="p07-a4">
             <a:extLst xmlns:a="http://schemas.openxmlformats.org/drawingml/2006/main">
               <a:ext uri="{FF2B5EF4-FFF2-40B4-BE49-F238E27FC236}">
-                <a16:creationId xmlns:a16="http://schemas.microsoft.com/office/drawing/2014/main" id="{7B77A291-D2D1-461E-AE87-DA889982983B}"/>
+                <a16:creationId xmlns:a16="http://schemas.microsoft.com/office/drawing/2014/main" id="{FFF8C5FE-4B8D-482E-A177-2A51194DC342}"/>
               </a:ext>
             </a:extLst>
           </p:cNvPr>
@@ -22584,7 +22470,7 @@
           <p:cNvPr id="15" name="p07-right-h">
             <a:extLst xmlns:a="http://schemas.openxmlformats.org/drawingml/2006/main">
               <a:ext uri="{FF2B5EF4-FFF2-40B4-BE49-F238E27FC236}">
-                <a16:creationId xmlns:a16="http://schemas.microsoft.com/office/drawing/2014/main" id="{A6FE6DE5-3EAB-4A55-803F-5156958D5A57}"/>
+                <a16:creationId xmlns:a16="http://schemas.microsoft.com/office/drawing/2014/main" id="{1C34D828-BA6C-455D-8CBC-E54B3D67CD71}"/>
               </a:ext>
             </a:extLst>
           </p:cNvPr>
@@ -22639,7 +22525,7 @@
           <p:cNvPr id="16" name="p07-rh0">
             <a:extLst xmlns:a="http://schemas.openxmlformats.org/drawingml/2006/main">
               <a:ext uri="{FF2B5EF4-FFF2-40B4-BE49-F238E27FC236}">
-                <a16:creationId xmlns:a16="http://schemas.microsoft.com/office/drawing/2014/main" id="{1CE7F02A-3DF6-40F8-9B68-A521F909F5CC}"/>
+                <a16:creationId xmlns:a16="http://schemas.microsoft.com/office/drawing/2014/main" id="{A6FABADA-CE72-4F45-8ADF-F89E69DD04B9}"/>
               </a:ext>
             </a:extLst>
           </p:cNvPr>
@@ -22698,7 +22584,7 @@
           <p:cNvPr id="17" name="p07-rd0">
             <a:extLst xmlns:a="http://schemas.openxmlformats.org/drawingml/2006/main">
               <a:ext uri="{FF2B5EF4-FFF2-40B4-BE49-F238E27FC236}">
-                <a16:creationId xmlns:a16="http://schemas.microsoft.com/office/drawing/2014/main" id="{02333FD6-A5BB-4FA6-834A-2AF1ACF2E3DA}"/>
+                <a16:creationId xmlns:a16="http://schemas.microsoft.com/office/drawing/2014/main" id="{51FA94F0-2892-4C6E-A437-2C865CD4C16E}"/>
               </a:ext>
             </a:extLst>
           </p:cNvPr>
@@ -22761,7 +22647,7 @@
           <p:cNvPr id="18" name="p07-rh1">
             <a:extLst xmlns:a="http://schemas.openxmlformats.org/drawingml/2006/main">
               <a:ext uri="{FF2B5EF4-FFF2-40B4-BE49-F238E27FC236}">
-                <a16:creationId xmlns:a16="http://schemas.microsoft.com/office/drawing/2014/main" id="{DF839AFE-E48F-49C6-818C-99B3A529CB66}"/>
+                <a16:creationId xmlns:a16="http://schemas.microsoft.com/office/drawing/2014/main" id="{20E3D79F-5EBE-457F-B52F-A1F9020EEFA8}"/>
               </a:ext>
             </a:extLst>
           </p:cNvPr>
@@ -22820,7 +22706,7 @@
           <p:cNvPr id="19" name="p07-rd1">
             <a:extLst xmlns:a="http://schemas.openxmlformats.org/drawingml/2006/main">
               <a:ext uri="{FF2B5EF4-FFF2-40B4-BE49-F238E27FC236}">
-                <a16:creationId xmlns:a16="http://schemas.microsoft.com/office/drawing/2014/main" id="{502C7F87-92CB-4B18-A1CD-0EC4810CC655}"/>
+                <a16:creationId xmlns:a16="http://schemas.microsoft.com/office/drawing/2014/main" id="{BC49C6EF-9185-4269-9DC0-31DE6FCE59F7}"/>
               </a:ext>
             </a:extLst>
           </p:cNvPr>
@@ -22883,7 +22769,7 @@
           <p:cNvPr id="20" name="p07-rh2">
             <a:extLst xmlns:a="http://schemas.openxmlformats.org/drawingml/2006/main">
               <a:ext uri="{FF2B5EF4-FFF2-40B4-BE49-F238E27FC236}">
-                <a16:creationId xmlns:a16="http://schemas.microsoft.com/office/drawing/2014/main" id="{122FAA7C-4B1A-4303-B07C-54C783450860}"/>
+                <a16:creationId xmlns:a16="http://schemas.microsoft.com/office/drawing/2014/main" id="{DDA7ED8A-F603-4518-B5D1-9D60132C5B44}"/>
               </a:ext>
             </a:extLst>
           </p:cNvPr>
@@ -22942,7 +22828,7 @@
           <p:cNvPr id="21" name="p07-rd2">
             <a:extLst xmlns:a="http://schemas.openxmlformats.org/drawingml/2006/main">
               <a:ext uri="{FF2B5EF4-FFF2-40B4-BE49-F238E27FC236}">
-                <a16:creationId xmlns:a16="http://schemas.microsoft.com/office/drawing/2014/main" id="{72D82FEF-3FB2-4DFC-91E0-5F871F929A22}"/>
+                <a16:creationId xmlns:a16="http://schemas.microsoft.com/office/drawing/2014/main" id="{01EAECAB-1E02-4DA4-BAC3-362E7B10923E}"/>
               </a:ext>
             </a:extLst>
           </p:cNvPr>
@@ -23005,7 +22891,7 @@
           <p:cNvPr id="22" name="p07-rh3">
             <a:extLst xmlns:a="http://schemas.openxmlformats.org/drawingml/2006/main">
               <a:ext uri="{FF2B5EF4-FFF2-40B4-BE49-F238E27FC236}">
-                <a16:creationId xmlns:a16="http://schemas.microsoft.com/office/drawing/2014/main" id="{FCB8EF7A-96DA-408F-8878-1EDAC9252C35}"/>
+                <a16:creationId xmlns:a16="http://schemas.microsoft.com/office/drawing/2014/main" id="{9A46654C-6731-45EF-BEB4-8ABB029F3F24}"/>
               </a:ext>
             </a:extLst>
           </p:cNvPr>
@@ -23064,7 +22950,7 @@
           <p:cNvPr id="23" name="p07-rd3">
             <a:extLst xmlns:a="http://schemas.openxmlformats.org/drawingml/2006/main">
               <a:ext uri="{FF2B5EF4-FFF2-40B4-BE49-F238E27FC236}">
-                <a16:creationId xmlns:a16="http://schemas.microsoft.com/office/drawing/2014/main" id="{0DBDE300-2FF2-4D95-BF7A-D686F93AEAF0}"/>
+                <a16:creationId xmlns:a16="http://schemas.microsoft.com/office/drawing/2014/main" id="{33C53ED8-874D-44C3-ACAF-024DA86F8439}"/>
               </a:ext>
             </a:extLst>
           </p:cNvPr>
@@ -23127,7 +23013,7 @@
           <p:cNvPr id="24" name="p07-bottom">
             <a:extLst xmlns:a="http://schemas.openxmlformats.org/drawingml/2006/main">
               <a:ext uri="{FF2B5EF4-FFF2-40B4-BE49-F238E27FC236}">
-                <a16:creationId xmlns:a16="http://schemas.microsoft.com/office/drawing/2014/main" id="{1DF157B1-FDE2-4046-A648-98808CBEB381}"/>
+                <a16:creationId xmlns:a16="http://schemas.microsoft.com/office/drawing/2014/main" id="{5D7602D7-1CE3-481E-A27A-BDC4301A38DB}"/>
               </a:ext>
             </a:extLst>
           </p:cNvPr>
@@ -23272,7 +23158,7 @@
           <p:cNvPr id="6" name="p08-n0">
             <a:extLst xmlns:a="http://schemas.openxmlformats.org/drawingml/2006/main">
               <a:ext uri="{FF2B5EF4-FFF2-40B4-BE49-F238E27FC236}">
-                <a16:creationId xmlns:a16="http://schemas.microsoft.com/office/drawing/2014/main" id="{A0AE979C-643F-4698-886A-F83B2550EACD}"/>
+                <a16:creationId xmlns:a16="http://schemas.microsoft.com/office/drawing/2014/main" id="{677D563A-B25C-47CE-A12A-A869DD7A5D6D}"/>
               </a:ext>
             </a:extLst>
           </p:cNvPr>
@@ -23329,7 +23215,7 @@
           <p:cNvPr id="7" name="p08-h0">
             <a:extLst xmlns:a="http://schemas.openxmlformats.org/drawingml/2006/main">
               <a:ext uri="{FF2B5EF4-FFF2-40B4-BE49-F238E27FC236}">
-                <a16:creationId xmlns:a16="http://schemas.microsoft.com/office/drawing/2014/main" id="{ECDA0E33-CC4A-4A92-8BBE-84EF2E554318}"/>
+                <a16:creationId xmlns:a16="http://schemas.microsoft.com/office/drawing/2014/main" id="{B3BA1C5C-909A-4187-9EDD-BD92AE27A3F9}"/>
               </a:ext>
             </a:extLst>
           </p:cNvPr>
@@ -23386,7 +23272,7 @@
           <p:cNvPr id="8" name="p08-d0">
             <a:extLst xmlns:a="http://schemas.openxmlformats.org/drawingml/2006/main">
               <a:ext uri="{FF2B5EF4-FFF2-40B4-BE49-F238E27FC236}">
-                <a16:creationId xmlns:a16="http://schemas.microsoft.com/office/drawing/2014/main" id="{CE9C545F-30A6-4E40-90EA-81B28F8817C9}"/>
+                <a16:creationId xmlns:a16="http://schemas.microsoft.com/office/drawing/2014/main" id="{6D92B9BE-F258-41B5-B9BE-84108F1057DC}"/>
               </a:ext>
             </a:extLst>
           </p:cNvPr>
@@ -23445,7 +23331,7 @@
           <p:cNvPr id="9" name="p08-c0">
             <a:extLst xmlns:a="http://schemas.openxmlformats.org/drawingml/2006/main">
               <a:ext uri="{FF2B5EF4-FFF2-40B4-BE49-F238E27FC236}">
-                <a16:creationId xmlns:a16="http://schemas.microsoft.com/office/drawing/2014/main" id="{EA2ABB7F-33C1-4FEC-B47A-1C54222330F1}"/>
+                <a16:creationId xmlns:a16="http://schemas.microsoft.com/office/drawing/2014/main" id="{8BB3BE68-1CAF-4D3F-BE14-0279E8005FB7}"/>
               </a:ext>
             </a:extLst>
           </p:cNvPr>
@@ -23504,7 +23390,7 @@
           <p:cNvPr id="10" name="p08-n1">
             <a:extLst xmlns:a="http://schemas.openxmlformats.org/drawingml/2006/main">
               <a:ext uri="{FF2B5EF4-FFF2-40B4-BE49-F238E27FC236}">
-                <a16:creationId xmlns:a16="http://schemas.microsoft.com/office/drawing/2014/main" id="{02A4BDA7-FE1D-499A-9C79-E69A1D646614}"/>
+                <a16:creationId xmlns:a16="http://schemas.microsoft.com/office/drawing/2014/main" id="{CE55917F-0AC5-459D-A2C1-17E9F75946B7}"/>
               </a:ext>
             </a:extLst>
           </p:cNvPr>
@@ -23561,7 +23447,7 @@
           <p:cNvPr id="11" name="p08-h1">
             <a:extLst xmlns:a="http://schemas.openxmlformats.org/drawingml/2006/main">
               <a:ext uri="{FF2B5EF4-FFF2-40B4-BE49-F238E27FC236}">
-                <a16:creationId xmlns:a16="http://schemas.microsoft.com/office/drawing/2014/main" id="{25BD41E6-942B-4032-9AD5-1A3DE8F47EE9}"/>
+                <a16:creationId xmlns:a16="http://schemas.microsoft.com/office/drawing/2014/main" id="{60F241FF-8152-4DC7-9C20-8672E0EF0DBD}"/>
               </a:ext>
             </a:extLst>
           </p:cNvPr>
@@ -23618,7 +23504,7 @@
           <p:cNvPr id="12" name="p08-d1">
             <a:extLst xmlns:a="http://schemas.openxmlformats.org/drawingml/2006/main">
               <a:ext uri="{FF2B5EF4-FFF2-40B4-BE49-F238E27FC236}">
-                <a16:creationId xmlns:a16="http://schemas.microsoft.com/office/drawing/2014/main" id="{3F81BB08-55D2-40D2-B6E7-ECFF305583C4}"/>
+                <a16:creationId xmlns:a16="http://schemas.microsoft.com/office/drawing/2014/main" id="{D1066D62-D94F-43E1-8579-4014C75617DC}"/>
               </a:ext>
             </a:extLst>
           </p:cNvPr>
@@ -23677,7 +23563,7 @@
           <p:cNvPr id="13" name="p08-c1">
             <a:extLst xmlns:a="http://schemas.openxmlformats.org/drawingml/2006/main">
               <a:ext uri="{FF2B5EF4-FFF2-40B4-BE49-F238E27FC236}">
-                <a16:creationId xmlns:a16="http://schemas.microsoft.com/office/drawing/2014/main" id="{1F1C4309-4B0C-4678-9099-9AB1CBDA2723}"/>
+                <a16:creationId xmlns:a16="http://schemas.microsoft.com/office/drawing/2014/main" id="{CAC34771-2F9A-404E-80B5-9F9C62301B46}"/>
               </a:ext>
             </a:extLst>
           </p:cNvPr>
@@ -23736,7 +23622,7 @@
           <p:cNvPr id="14" name="p08-n2">
             <a:extLst xmlns:a="http://schemas.openxmlformats.org/drawingml/2006/main">
               <a:ext uri="{FF2B5EF4-FFF2-40B4-BE49-F238E27FC236}">
-                <a16:creationId xmlns:a16="http://schemas.microsoft.com/office/drawing/2014/main" id="{A8E52D07-E9BE-4F7C-8510-1D6286200253}"/>
+                <a16:creationId xmlns:a16="http://schemas.microsoft.com/office/drawing/2014/main" id="{A5F95C70-3B59-4D5C-A006-992C1392A34E}"/>
               </a:ext>
             </a:extLst>
           </p:cNvPr>
@@ -23793,7 +23679,7 @@
           <p:cNvPr id="15" name="p08-h2">
             <a:extLst xmlns:a="http://schemas.openxmlformats.org/drawingml/2006/main">
               <a:ext uri="{FF2B5EF4-FFF2-40B4-BE49-F238E27FC236}">
-                <a16:creationId xmlns:a16="http://schemas.microsoft.com/office/drawing/2014/main" id="{F696580C-1B01-488C-9689-E4DED1650AA2}"/>
+                <a16:creationId xmlns:a16="http://schemas.microsoft.com/office/drawing/2014/main" id="{E7E440FD-F2A7-4044-BB1C-979E430CB91B}"/>
               </a:ext>
             </a:extLst>
           </p:cNvPr>
@@ -23850,7 +23736,7 @@
           <p:cNvPr id="16" name="p08-d2">
             <a:extLst xmlns:a="http://schemas.openxmlformats.org/drawingml/2006/main">
               <a:ext uri="{FF2B5EF4-FFF2-40B4-BE49-F238E27FC236}">
-                <a16:creationId xmlns:a16="http://schemas.microsoft.com/office/drawing/2014/main" id="{41D97A0E-F412-4505-8431-4AD8DB0E7D19}"/>
+                <a16:creationId xmlns:a16="http://schemas.microsoft.com/office/drawing/2014/main" id="{7245439B-9ACE-4B50-9A9A-B665A26F5091}"/>
               </a:ext>
             </a:extLst>
           </p:cNvPr>
@@ -23909,7 +23795,7 @@
           <p:cNvPr id="17" name="p08-c2">
             <a:extLst xmlns:a="http://schemas.openxmlformats.org/drawingml/2006/main">
               <a:ext uri="{FF2B5EF4-FFF2-40B4-BE49-F238E27FC236}">
-                <a16:creationId xmlns:a16="http://schemas.microsoft.com/office/drawing/2014/main" id="{34064687-4369-44D1-BF0F-E9B444E1D5FD}"/>
+                <a16:creationId xmlns:a16="http://schemas.microsoft.com/office/drawing/2014/main" id="{93061DB8-F711-4D66-8D83-E4B2C3ECFC2F}"/>
               </a:ext>
             </a:extLst>
           </p:cNvPr>
@@ -23968,7 +23854,7 @@
           <p:cNvPr id="18" name="p08-bottom">
             <a:extLst xmlns:a="http://schemas.openxmlformats.org/drawingml/2006/main">
               <a:ext uri="{FF2B5EF4-FFF2-40B4-BE49-F238E27FC236}">
-                <a16:creationId xmlns:a16="http://schemas.microsoft.com/office/drawing/2014/main" id="{8DE65586-97EA-4C62-BB3C-03BA90EEAA8F}"/>
+                <a16:creationId xmlns:a16="http://schemas.microsoft.com/office/drawing/2014/main" id="{4DCC7FC3-37CD-49D9-9379-9C111D839157}"/>
               </a:ext>
             </a:extLst>
           </p:cNvPr>
@@ -24115,7 +24001,7 @@
           <p:cNvPr id="6" name="p09-n0">
             <a:extLst xmlns:a="http://schemas.openxmlformats.org/drawingml/2006/main">
               <a:ext uri="{FF2B5EF4-FFF2-40B4-BE49-F238E27FC236}">
-                <a16:creationId xmlns:a16="http://schemas.microsoft.com/office/drawing/2014/main" id="{FA3B5558-25EA-452F-9E27-50FEE1C9B9FF}"/>
+                <a16:creationId xmlns:a16="http://schemas.microsoft.com/office/drawing/2014/main" id="{A3D534BA-AB1D-4128-9D6B-8E1F4EFEC7ED}"/>
               </a:ext>
             </a:extLst>
           </p:cNvPr>
@@ -24172,7 +24058,7 @@
           <p:cNvPr id="7" name="p09-h0">
             <a:extLst xmlns:a="http://schemas.openxmlformats.org/drawingml/2006/main">
               <a:ext uri="{FF2B5EF4-FFF2-40B4-BE49-F238E27FC236}">
-                <a16:creationId xmlns:a16="http://schemas.microsoft.com/office/drawing/2014/main" id="{296D5522-420C-4AFC-B175-6A6B6268A63D}"/>
+                <a16:creationId xmlns:a16="http://schemas.microsoft.com/office/drawing/2014/main" id="{B299A5A4-1AD3-43D9-928B-26DBCE6DDFF0}"/>
               </a:ext>
             </a:extLst>
           </p:cNvPr>
@@ -24229,7 +24115,7 @@
           <p:cNvPr id="8" name="p09-d0">
             <a:extLst xmlns:a="http://schemas.openxmlformats.org/drawingml/2006/main">
               <a:ext uri="{FF2B5EF4-FFF2-40B4-BE49-F238E27FC236}">
-                <a16:creationId xmlns:a16="http://schemas.microsoft.com/office/drawing/2014/main" id="{E91FA4CC-BECC-4037-86A7-5194F93B310F}"/>
+                <a16:creationId xmlns:a16="http://schemas.microsoft.com/office/drawing/2014/main" id="{9AA4E957-441E-40B2-A56A-0F2B3335B885}"/>
               </a:ext>
             </a:extLst>
           </p:cNvPr>
@@ -24292,7 +24178,7 @@
           <p:cNvPr id="9" name="p09-a0">
             <a:extLst xmlns:a="http://schemas.openxmlformats.org/drawingml/2006/main">
               <a:ext uri="{FF2B5EF4-FFF2-40B4-BE49-F238E27FC236}">
-                <a16:creationId xmlns:a16="http://schemas.microsoft.com/office/drawing/2014/main" id="{A23905ED-DD3C-4010-AE67-34A89CEC69D2}"/>
+                <a16:creationId xmlns:a16="http://schemas.microsoft.com/office/drawing/2014/main" id="{3A00A264-9AFC-4337-8455-298D2879475E}"/>
               </a:ext>
             </a:extLst>
           </p:cNvPr>
@@ -24345,7 +24231,7 @@
           <p:cNvPr id="10" name="p09-n1">
             <a:extLst xmlns:a="http://schemas.openxmlformats.org/drawingml/2006/main">
               <a:ext uri="{FF2B5EF4-FFF2-40B4-BE49-F238E27FC236}">
-                <a16:creationId xmlns:a16="http://schemas.microsoft.com/office/drawing/2014/main" id="{962C97FC-F5CF-48DC-B385-A15A7F34F553}"/>
+                <a16:creationId xmlns:a16="http://schemas.microsoft.com/office/drawing/2014/main" id="{0E761202-55E6-483D-9C28-DFA9EC824E51}"/>
               </a:ext>
             </a:extLst>
           </p:cNvPr>
@@ -24402,7 +24288,7 @@
           <p:cNvPr id="11" name="p09-h1">
             <a:extLst xmlns:a="http://schemas.openxmlformats.org/drawingml/2006/main">
               <a:ext uri="{FF2B5EF4-FFF2-40B4-BE49-F238E27FC236}">
-                <a16:creationId xmlns:a16="http://schemas.microsoft.com/office/drawing/2014/main" id="{FFD5A8E6-1B3E-4761-BDB2-2573D246A849}"/>
+                <a16:creationId xmlns:a16="http://schemas.microsoft.com/office/drawing/2014/main" id="{778DE76E-A5C2-49DA-8FCC-566B6B713931}"/>
               </a:ext>
             </a:extLst>
           </p:cNvPr>
@@ -24459,7 +24345,7 @@
           <p:cNvPr id="12" name="p09-d1">
             <a:extLst xmlns:a="http://schemas.openxmlformats.org/drawingml/2006/main">
               <a:ext uri="{FF2B5EF4-FFF2-40B4-BE49-F238E27FC236}">
-                <a16:creationId xmlns:a16="http://schemas.microsoft.com/office/drawing/2014/main" id="{CA83D086-0227-420F-9210-269251512CC8}"/>
+                <a16:creationId xmlns:a16="http://schemas.microsoft.com/office/drawing/2014/main" id="{CCD8694D-EF58-4AF2-BC91-657F86EEA5F3}"/>
               </a:ext>
             </a:extLst>
           </p:cNvPr>
@@ -24522,7 +24408,7 @@
           <p:cNvPr id="13" name="p09-a1">
             <a:extLst xmlns:a="http://schemas.openxmlformats.org/drawingml/2006/main">
               <a:ext uri="{FF2B5EF4-FFF2-40B4-BE49-F238E27FC236}">
-                <a16:creationId xmlns:a16="http://schemas.microsoft.com/office/drawing/2014/main" id="{701B0C5B-DD53-4298-9EC9-2789D4DA9633}"/>
+                <a16:creationId xmlns:a16="http://schemas.microsoft.com/office/drawing/2014/main" id="{4E6B414A-1748-4457-ADCF-4AE46A266686}"/>
               </a:ext>
             </a:extLst>
           </p:cNvPr>
@@ -24575,7 +24461,7 @@
           <p:cNvPr id="14" name="p09-n2">
             <a:extLst xmlns:a="http://schemas.openxmlformats.org/drawingml/2006/main">
               <a:ext uri="{FF2B5EF4-FFF2-40B4-BE49-F238E27FC236}">
-                <a16:creationId xmlns:a16="http://schemas.microsoft.com/office/drawing/2014/main" id="{C5DF82C1-5383-456E-8C9E-BB1C900D9661}"/>
+                <a16:creationId xmlns:a16="http://schemas.microsoft.com/office/drawing/2014/main" id="{F5AA9F99-DEDD-4D7D-BE58-CC8D9E18A001}"/>
               </a:ext>
             </a:extLst>
           </p:cNvPr>
@@ -24632,7 +24518,7 @@
           <p:cNvPr id="15" name="p09-h2">
             <a:extLst xmlns:a="http://schemas.openxmlformats.org/drawingml/2006/main">
               <a:ext uri="{FF2B5EF4-FFF2-40B4-BE49-F238E27FC236}">
-                <a16:creationId xmlns:a16="http://schemas.microsoft.com/office/drawing/2014/main" id="{D5D140DC-FAE2-4F97-9BDF-7E98248FBFCE}"/>
+                <a16:creationId xmlns:a16="http://schemas.microsoft.com/office/drawing/2014/main" id="{2D588B32-FAC8-4416-9E30-C90023EDF9AE}"/>
               </a:ext>
             </a:extLst>
           </p:cNvPr>
@@ -24689,7 +24575,7 @@
           <p:cNvPr id="16" name="p09-d2">
             <a:extLst xmlns:a="http://schemas.openxmlformats.org/drawingml/2006/main">
               <a:ext uri="{FF2B5EF4-FFF2-40B4-BE49-F238E27FC236}">
-                <a16:creationId xmlns:a16="http://schemas.microsoft.com/office/drawing/2014/main" id="{38DC5654-5BA6-460A-B5BC-4A5C67F8877C}"/>
+                <a16:creationId xmlns:a16="http://schemas.microsoft.com/office/drawing/2014/main" id="{4254A99E-9F3C-420B-BB85-133C43A5D20E}"/>
               </a:ext>
             </a:extLst>
           </p:cNvPr>
@@ -24752,7 +24638,7 @@
           <p:cNvPr id="17" name="p09-pass">
             <a:extLst xmlns:a="http://schemas.openxmlformats.org/drawingml/2006/main">
               <a:ext uri="{FF2B5EF4-FFF2-40B4-BE49-F238E27FC236}">
-                <a16:creationId xmlns:a16="http://schemas.microsoft.com/office/drawing/2014/main" id="{58051F33-6256-4DD0-8CD1-37BEA5EC93D1}"/>
+                <a16:creationId xmlns:a16="http://schemas.microsoft.com/office/drawing/2014/main" id="{4C2E2103-433B-4A14-B572-ACA2AE308700}"/>
               </a:ext>
             </a:extLst>
           </p:cNvPr>
@@ -24811,7 +24697,7 @@
           <p:cNvPr id="18" name="p09-back">
             <a:extLst xmlns:a="http://schemas.openxmlformats.org/drawingml/2006/main">
               <a:ext uri="{FF2B5EF4-FFF2-40B4-BE49-F238E27FC236}">
-                <a16:creationId xmlns:a16="http://schemas.microsoft.com/office/drawing/2014/main" id="{4B6AFBEF-CC9F-4B85-8883-06E9F1F2902E}"/>
+                <a16:creationId xmlns:a16="http://schemas.microsoft.com/office/drawing/2014/main" id="{81546501-9EEC-47C3-A896-5E003ECFE469}"/>
               </a:ext>
             </a:extLst>
           </p:cNvPr>
@@ -24870,7 +24756,7 @@
           <p:cNvPr id="19" name="p09-bottom">
             <a:extLst xmlns:a="http://schemas.openxmlformats.org/drawingml/2006/main">
               <a:ext uri="{FF2B5EF4-FFF2-40B4-BE49-F238E27FC236}">
-                <a16:creationId xmlns:a16="http://schemas.microsoft.com/office/drawing/2014/main" id="{1EC34C26-9CBE-4C8C-809F-5B3DEC7A1684}"/>
+                <a16:creationId xmlns:a16="http://schemas.microsoft.com/office/drawing/2014/main" id="{2D1AAAEF-2275-4AC6-B851-7797091AB276}"/>
               </a:ext>
             </a:extLst>
           </p:cNvPr>

</xml_diff>